<commit_message>
docs: add final delivery checklist and guardrail demo
</commit_message>
<xml_diff>
--- a/docs/ppt/E3-VDT-OOC-答辩PPT初稿.pptx
+++ b/docs/ppt/E3-VDT-OOC-答辩PPT初稿.pptx
@@ -2,27 +2,27 @@
 <file path=ppt/presentation.xml><?xml version="1.0" encoding="utf-8"?>
 <p:presentation xmlns:p="http://schemas.openxmlformats.org/presentationml/2006/main">
   <p:sldMasterIdLst>
-    <p:sldMasterId xmlns:r="http://schemas.openxmlformats.org/officeDocument/2006/relationships" id="2147483648" r:id="Rcba47b63dbc349de"/>
+    <p:sldMasterId xmlns:r="http://schemas.openxmlformats.org/officeDocument/2006/relationships" id="2147483648" r:id="Rb9b36cdc477341b2"/>
   </p:sldMasterIdLst>
   <p:notesMasterIdLst>
-    <p:notesMasterId xmlns:r="http://schemas.openxmlformats.org/officeDocument/2006/relationships" r:id="R8a3f172f64aa4bd2"/>
+    <p:notesMasterId xmlns:r="http://schemas.openxmlformats.org/officeDocument/2006/relationships" r:id="Rc833cd9d121246e4"/>
   </p:notesMasterIdLst>
   <p:sldIdLst>
-    <p:sldId xmlns:r="http://schemas.openxmlformats.org/officeDocument/2006/relationships" id="256" r:id="R17227b7d7c2b4087"/>
-    <p:sldId xmlns:r="http://schemas.openxmlformats.org/officeDocument/2006/relationships" id="257" r:id="R006837836a6e4c86"/>
-    <p:sldId xmlns:r="http://schemas.openxmlformats.org/officeDocument/2006/relationships" id="258" r:id="R8c7a3dd142a94d45"/>
-    <p:sldId xmlns:r="http://schemas.openxmlformats.org/officeDocument/2006/relationships" id="259" r:id="R2b5c25c0624641ff"/>
-    <p:sldId xmlns:r="http://schemas.openxmlformats.org/officeDocument/2006/relationships" id="260" r:id="R9a7662f115934656"/>
-    <p:sldId xmlns:r="http://schemas.openxmlformats.org/officeDocument/2006/relationships" id="261" r:id="Ree35661c94924021"/>
-    <p:sldId xmlns:r="http://schemas.openxmlformats.org/officeDocument/2006/relationships" id="262" r:id="Rab8604db1ecb4ea3"/>
-    <p:sldId xmlns:r="http://schemas.openxmlformats.org/officeDocument/2006/relationships" id="263" r:id="R276f4f2ef6ea44fe"/>
-    <p:sldId xmlns:r="http://schemas.openxmlformats.org/officeDocument/2006/relationships" id="264" r:id="Rcfa77b6d21204449"/>
-    <p:sldId xmlns:r="http://schemas.openxmlformats.org/officeDocument/2006/relationships" id="265" r:id="R7745ac9dc0684840"/>
-    <p:sldId xmlns:r="http://schemas.openxmlformats.org/officeDocument/2006/relationships" id="266" r:id="Rad2a0e64bf6548c7"/>
-    <p:sldId xmlns:r="http://schemas.openxmlformats.org/officeDocument/2006/relationships" id="267" r:id="R622d22e3b3ab4812"/>
-    <p:sldId xmlns:r="http://schemas.openxmlformats.org/officeDocument/2006/relationships" id="268" r:id="Ree7d6db04f91497e"/>
-    <p:sldId xmlns:r="http://schemas.openxmlformats.org/officeDocument/2006/relationships" id="269" r:id="Rf7700629e4c94c89"/>
-    <p:sldId xmlns:r="http://schemas.openxmlformats.org/officeDocument/2006/relationships" id="270" r:id="R5491abb6436b4937"/>
+    <p:sldId xmlns:r="http://schemas.openxmlformats.org/officeDocument/2006/relationships" id="256" r:id="Rdeb1b712ab6246a0"/>
+    <p:sldId xmlns:r="http://schemas.openxmlformats.org/officeDocument/2006/relationships" id="257" r:id="R54dd219a177e4e7e"/>
+    <p:sldId xmlns:r="http://schemas.openxmlformats.org/officeDocument/2006/relationships" id="258" r:id="R71fb8a83a5134b8c"/>
+    <p:sldId xmlns:r="http://schemas.openxmlformats.org/officeDocument/2006/relationships" id="259" r:id="R32fda03676cb4686"/>
+    <p:sldId xmlns:r="http://schemas.openxmlformats.org/officeDocument/2006/relationships" id="260" r:id="R46430f30b9a9498f"/>
+    <p:sldId xmlns:r="http://schemas.openxmlformats.org/officeDocument/2006/relationships" id="261" r:id="R0490810819e448f0"/>
+    <p:sldId xmlns:r="http://schemas.openxmlformats.org/officeDocument/2006/relationships" id="262" r:id="Rd927c2d466c64f78"/>
+    <p:sldId xmlns:r="http://schemas.openxmlformats.org/officeDocument/2006/relationships" id="263" r:id="Ra423ca1af409402a"/>
+    <p:sldId xmlns:r="http://schemas.openxmlformats.org/officeDocument/2006/relationships" id="264" r:id="R3dea78a104394e3b"/>
+    <p:sldId xmlns:r="http://schemas.openxmlformats.org/officeDocument/2006/relationships" id="265" r:id="R847796703bbe4bc4"/>
+    <p:sldId xmlns:r="http://schemas.openxmlformats.org/officeDocument/2006/relationships" id="266" r:id="Rf5f480a075084a8c"/>
+    <p:sldId xmlns:r="http://schemas.openxmlformats.org/officeDocument/2006/relationships" id="267" r:id="Ra645df97645749d2"/>
+    <p:sldId xmlns:r="http://schemas.openxmlformats.org/officeDocument/2006/relationships" id="268" r:id="R35f0897c0c38496f"/>
+    <p:sldId xmlns:r="http://schemas.openxmlformats.org/officeDocument/2006/relationships" id="269" r:id="R224b8d8694c54e2c"/>
+    <p:sldId xmlns:r="http://schemas.openxmlformats.org/officeDocument/2006/relationships" id="270" r:id="R717880b4ac274f51"/>
   </p:sldIdLst>
   <p:sldSz cx="12192000" cy="6858000"/>
   <p:notesSz cx="6858000" cy="9144000"/>
@@ -1539,7 +1539,7 @@
   </p:cSld>
   <p:clrMap bg1="lt1" tx1="dk1" bg2="lt2" tx2="dk2" accent1="accent1" accent2="accent2" accent3="accent3" accent4="accent4" accent5="accent5" accent6="accent6" hlink="hlink" folHlink="folHlink"/>
   <p:sldLayoutIdLst>
-    <p:sldLayoutId xmlns:r="http://schemas.openxmlformats.org/officeDocument/2006/relationships" id="2147483649" r:id="R99a86f77bec84f64"/>
+    <p:sldLayoutId xmlns:r="http://schemas.openxmlformats.org/officeDocument/2006/relationships" id="2147483649" r:id="Rc3c0c9f0e627420c"/>
   </p:sldLayoutIdLst>
   <p:txStyles>
     <p:titleStyle>
@@ -2090,7 +2090,7 @@
           <p:cNvPr id="1" name="">
             <a:extLst xmlns:a="http://schemas.openxmlformats.org/drawingml/2006/main">
               <a:ext uri="{FF2B5EF4-FFF2-40B4-BE49-F238E27FC236}">
-                <a16:creationId xmlns:a16="http://schemas.microsoft.com/office/drawing/2014/main" id="{3E920D6F-0C3A-4224-8591-CC949B67C4D1}"/>
+                <a16:creationId xmlns:a16="http://schemas.microsoft.com/office/drawing/2014/main" id="{5B894035-1652-4184-B80C-F8DC673478D4}"/>
               </a:ext>
             </a:extLst>
           </p:cNvPr>
@@ -2121,7 +2121,7 @@
           <p:cNvPr id="2" name="">
             <a:extLst xmlns:a="http://schemas.openxmlformats.org/drawingml/2006/main">
               <a:ext uri="{FF2B5EF4-FFF2-40B4-BE49-F238E27FC236}">
-                <a16:creationId xmlns:a16="http://schemas.microsoft.com/office/drawing/2014/main" id="{207A80B3-3CE9-4BF7-9B98-15E5B6E53A36}"/>
+                <a16:creationId xmlns:a16="http://schemas.microsoft.com/office/drawing/2014/main" id="{9155F9FC-6A6C-4C1B-85EA-AC5A04072E86}"/>
               </a:ext>
             </a:extLst>
           </p:cNvPr>
@@ -2152,7 +2152,7 @@
           <p:cNvPr id="3" name="">
             <a:extLst xmlns:a="http://schemas.openxmlformats.org/drawingml/2006/main">
               <a:ext uri="{FF2B5EF4-FFF2-40B4-BE49-F238E27FC236}">
-                <a16:creationId xmlns:a16="http://schemas.microsoft.com/office/drawing/2014/main" id="{28A9E9F4-F538-4C3F-BCD1-A8BCF72A0A52}"/>
+                <a16:creationId xmlns:a16="http://schemas.microsoft.com/office/drawing/2014/main" id="{CBE38574-8D2F-4918-B5D7-28FCA4E7E4C4}"/>
               </a:ext>
             </a:extLst>
           </p:cNvPr>
@@ -2202,7 +2202,7 @@
           <p:cNvPr id="4" name="">
             <a:extLst xmlns:a="http://schemas.openxmlformats.org/drawingml/2006/main">
               <a:ext uri="{FF2B5EF4-FFF2-40B4-BE49-F238E27FC236}">
-                <a16:creationId xmlns:a16="http://schemas.microsoft.com/office/drawing/2014/main" id="{FFD084A8-F10E-434A-AD93-97D6BB97C5CF}"/>
+                <a16:creationId xmlns:a16="http://schemas.microsoft.com/office/drawing/2014/main" id="{EBF42A7D-7FD0-4A7D-81C4-2727AFF01B6F}"/>
               </a:ext>
             </a:extLst>
           </p:cNvPr>
@@ -2269,7 +2269,7 @@
           <p:cNvPr id="5" name="">
             <a:extLst xmlns:a="http://schemas.openxmlformats.org/drawingml/2006/main">
               <a:ext uri="{FF2B5EF4-FFF2-40B4-BE49-F238E27FC236}">
-                <a16:creationId xmlns:a16="http://schemas.microsoft.com/office/drawing/2014/main" id="{CF9DC9F9-D52B-4DAD-A223-FB46856F021B}"/>
+                <a16:creationId xmlns:a16="http://schemas.microsoft.com/office/drawing/2014/main" id="{D276A461-8C40-4BE2-88F7-7CE87F253D1F}"/>
               </a:ext>
             </a:extLst>
           </p:cNvPr>
@@ -2319,7 +2319,7 @@
           <p:cNvPr id="6" name="">
             <a:extLst xmlns:a="http://schemas.openxmlformats.org/drawingml/2006/main">
               <a:ext uri="{FF2B5EF4-FFF2-40B4-BE49-F238E27FC236}">
-                <a16:creationId xmlns:a16="http://schemas.microsoft.com/office/drawing/2014/main" id="{EC37FA16-436E-48BF-840C-763A077D87D0}"/>
+                <a16:creationId xmlns:a16="http://schemas.microsoft.com/office/drawing/2014/main" id="{4D8AC592-A444-4F01-B2CE-477101EA1BBC}"/>
               </a:ext>
             </a:extLst>
           </p:cNvPr>
@@ -2369,7 +2369,7 @@
           <p:cNvPr id="7" name="">
             <a:extLst xmlns:a="http://schemas.openxmlformats.org/drawingml/2006/main">
               <a:ext uri="{FF2B5EF4-FFF2-40B4-BE49-F238E27FC236}">
-                <a16:creationId xmlns:a16="http://schemas.microsoft.com/office/drawing/2014/main" id="{07ABE3FE-AE99-417E-A22F-B161F524B3BE}"/>
+                <a16:creationId xmlns:a16="http://schemas.microsoft.com/office/drawing/2014/main" id="{08C613DA-0096-4AD0-B925-30BC534D6195}"/>
               </a:ext>
             </a:extLst>
           </p:cNvPr>
@@ -2404,7 +2404,7 @@
           <p:cNvPr id="8" name="">
             <a:extLst xmlns:a="http://schemas.openxmlformats.org/drawingml/2006/main">
               <a:ext uri="{FF2B5EF4-FFF2-40B4-BE49-F238E27FC236}">
-                <a16:creationId xmlns:a16="http://schemas.microsoft.com/office/drawing/2014/main" id="{0B940238-D422-47EE-9C7D-850F4A5DBE29}"/>
+                <a16:creationId xmlns:a16="http://schemas.microsoft.com/office/drawing/2014/main" id="{13B4EEB9-AC1C-46AA-B0C6-5B899D092685}"/>
               </a:ext>
             </a:extLst>
           </p:cNvPr>
@@ -2522,7 +2522,7 @@
           <p:cNvPr id="9" name="">
             <a:extLst xmlns:a="http://schemas.openxmlformats.org/drawingml/2006/main">
               <a:ext uri="{FF2B5EF4-FFF2-40B4-BE49-F238E27FC236}">
-                <a16:creationId xmlns:a16="http://schemas.microsoft.com/office/drawing/2014/main" id="{5BEEBD4D-EE56-42FD-B58D-BF17839D4B5D}"/>
+                <a16:creationId xmlns:a16="http://schemas.microsoft.com/office/drawing/2014/main" id="{BD6EB965-F9F5-4E89-AD51-B1C39F95F839}"/>
               </a:ext>
             </a:extLst>
           </p:cNvPr>
@@ -2570,7 +2570,7 @@
     </p:spTree>
     <p:extLst>
       <p:ext uri="{BB962C8B-B14F-4D97-AF65-F5344CB8AC3E}">
-        <p14:creationId xmlns:p14="http://schemas.microsoft.com/office/powerpoint/2010/main" val="1058543261"/>
+        <p14:creationId xmlns:p14="http://schemas.microsoft.com/office/powerpoint/2010/main" val="874911019"/>
       </p:ext>
     </p:extLst>
   </p:cSld>
@@ -2601,7 +2601,7 @@
           <p:cNvPr id="1" name="">
             <a:extLst xmlns:a="http://schemas.openxmlformats.org/drawingml/2006/main">
               <a:ext uri="{FF2B5EF4-FFF2-40B4-BE49-F238E27FC236}">
-                <a16:creationId xmlns:a16="http://schemas.microsoft.com/office/drawing/2014/main" id="{E4628F2D-2E89-48D5-809A-415CCD7F72DB}"/>
+                <a16:creationId xmlns:a16="http://schemas.microsoft.com/office/drawing/2014/main" id="{07524FF5-F7AA-4AA8-8BB0-F77C03A60920}"/>
               </a:ext>
             </a:extLst>
           </p:cNvPr>
@@ -2632,7 +2632,7 @@
           <p:cNvPr id="2" name="">
             <a:extLst xmlns:a="http://schemas.openxmlformats.org/drawingml/2006/main">
               <a:ext uri="{FF2B5EF4-FFF2-40B4-BE49-F238E27FC236}">
-                <a16:creationId xmlns:a16="http://schemas.microsoft.com/office/drawing/2014/main" id="{8D08CBAA-4052-4F75-86E9-662D03347643}"/>
+                <a16:creationId xmlns:a16="http://schemas.microsoft.com/office/drawing/2014/main" id="{517B6BBB-7895-4EED-9439-282694DA2009}"/>
               </a:ext>
             </a:extLst>
           </p:cNvPr>
@@ -2682,7 +2682,7 @@
           <p:cNvPr id="3" name="">
             <a:extLst xmlns:a="http://schemas.openxmlformats.org/drawingml/2006/main">
               <a:ext uri="{FF2B5EF4-FFF2-40B4-BE49-F238E27FC236}">
-                <a16:creationId xmlns:a16="http://schemas.microsoft.com/office/drawing/2014/main" id="{14C01EC5-543A-463F-913D-ECCC27EB58C5}"/>
+                <a16:creationId xmlns:a16="http://schemas.microsoft.com/office/drawing/2014/main" id="{E438042D-7AB0-4258-9909-BCBB196BAD63}"/>
               </a:ext>
             </a:extLst>
           </p:cNvPr>
@@ -2732,7 +2732,7 @@
           <p:cNvPr id="4" name="">
             <a:extLst xmlns:a="http://schemas.openxmlformats.org/drawingml/2006/main">
               <a:ext uri="{FF2B5EF4-FFF2-40B4-BE49-F238E27FC236}">
-                <a16:creationId xmlns:a16="http://schemas.microsoft.com/office/drawing/2014/main" id="{A47E5718-A9AD-48A8-BEBF-715BC94F7B03}"/>
+                <a16:creationId xmlns:a16="http://schemas.microsoft.com/office/drawing/2014/main" id="{336ECF69-53B5-4A10-89E2-DC7AD2441EB6}"/>
               </a:ext>
             </a:extLst>
           </p:cNvPr>
@@ -2763,7 +2763,7 @@
           <p:cNvPr id="5" name="footer-10">
             <a:extLst xmlns:a="http://schemas.openxmlformats.org/drawingml/2006/main">
               <a:ext uri="{FF2B5EF4-FFF2-40B4-BE49-F238E27FC236}">
-                <a16:creationId xmlns:a16="http://schemas.microsoft.com/office/drawing/2014/main" id="{8E7652D7-B40B-4DCC-9C20-87ABF98FEE63}"/>
+                <a16:creationId xmlns:a16="http://schemas.microsoft.com/office/drawing/2014/main" id="{8509376E-B4E1-410B-BC25-792826436AAB}"/>
               </a:ext>
             </a:extLst>
           </p:cNvPr>
@@ -2813,7 +2813,7 @@
           <p:cNvPr id="6" name="">
             <a:extLst xmlns:a="http://schemas.openxmlformats.org/drawingml/2006/main">
               <a:ext uri="{FF2B5EF4-FFF2-40B4-BE49-F238E27FC236}">
-                <a16:creationId xmlns:a16="http://schemas.microsoft.com/office/drawing/2014/main" id="{D07E2410-5E98-442F-8181-657E950EB811}"/>
+                <a16:creationId xmlns:a16="http://schemas.microsoft.com/office/drawing/2014/main" id="{84F52515-0439-4F99-88B8-1CD6A44F5B35}"/>
               </a:ext>
             </a:extLst>
           </p:cNvPr>
@@ -2846,7 +2846,7 @@
           <p:cNvPr id="7" name="">
             <a:extLst xmlns:a="http://schemas.openxmlformats.org/drawingml/2006/main">
               <a:ext uri="{FF2B5EF4-FFF2-40B4-BE49-F238E27FC236}">
-                <a16:creationId xmlns:a16="http://schemas.microsoft.com/office/drawing/2014/main" id="{268ACB3C-8388-4C70-B5BD-D3341A78C941}"/>
+                <a16:creationId xmlns:a16="http://schemas.microsoft.com/office/drawing/2014/main" id="{5B075ABE-691B-4D17-9F5D-ECA8D252151E}"/>
               </a:ext>
             </a:extLst>
           </p:cNvPr>
@@ -3015,7 +3015,7 @@
           <p:cNvPr id="8" name="">
             <a:extLst xmlns:a="http://schemas.openxmlformats.org/drawingml/2006/main">
               <a:ext uri="{FF2B5EF4-FFF2-40B4-BE49-F238E27FC236}">
-                <a16:creationId xmlns:a16="http://schemas.microsoft.com/office/drawing/2014/main" id="{1DC79795-FDB4-40DC-923F-6DDC86E5DF79}"/>
+                <a16:creationId xmlns:a16="http://schemas.microsoft.com/office/drawing/2014/main" id="{45090909-1A07-4F86-8B4B-37874D680B22}"/>
               </a:ext>
             </a:extLst>
           </p:cNvPr>
@@ -3065,7 +3065,7 @@
           <p:cNvPr id="9" name="">
             <a:extLst xmlns:a="http://schemas.openxmlformats.org/drawingml/2006/main">
               <a:ext uri="{FF2B5EF4-FFF2-40B4-BE49-F238E27FC236}">
-                <a16:creationId xmlns:a16="http://schemas.microsoft.com/office/drawing/2014/main" id="{543C459D-8689-46F0-9037-0282528646CB}"/>
+                <a16:creationId xmlns:a16="http://schemas.microsoft.com/office/drawing/2014/main" id="{157E8FAF-7991-41D9-95E5-6BCBF3CC5210}"/>
               </a:ext>
             </a:extLst>
           </p:cNvPr>
@@ -3164,7 +3164,7 @@
     </p:spTree>
     <p:extLst>
       <p:ext uri="{BB962C8B-B14F-4D97-AF65-F5344CB8AC3E}">
-        <p14:creationId xmlns:p14="http://schemas.microsoft.com/office/powerpoint/2010/main" val="590287798"/>
+        <p14:creationId xmlns:p14="http://schemas.microsoft.com/office/powerpoint/2010/main" val="320608163"/>
       </p:ext>
     </p:extLst>
   </p:cSld>
@@ -3195,7 +3195,7 @@
           <p:cNvPr id="1" name="">
             <a:extLst xmlns:a="http://schemas.openxmlformats.org/drawingml/2006/main">
               <a:ext uri="{FF2B5EF4-FFF2-40B4-BE49-F238E27FC236}">
-                <a16:creationId xmlns:a16="http://schemas.microsoft.com/office/drawing/2014/main" id="{94CE7A82-EA7D-4688-A1E5-F6C204E8D2B8}"/>
+                <a16:creationId xmlns:a16="http://schemas.microsoft.com/office/drawing/2014/main" id="{837572EC-FB98-49E6-A6E6-5968E82A53C2}"/>
               </a:ext>
             </a:extLst>
           </p:cNvPr>
@@ -3226,7 +3226,7 @@
           <p:cNvPr id="2" name="">
             <a:extLst xmlns:a="http://schemas.openxmlformats.org/drawingml/2006/main">
               <a:ext uri="{FF2B5EF4-FFF2-40B4-BE49-F238E27FC236}">
-                <a16:creationId xmlns:a16="http://schemas.microsoft.com/office/drawing/2014/main" id="{2EA0E8FC-AE48-461D-B59E-DD8CFBC8CA16}"/>
+                <a16:creationId xmlns:a16="http://schemas.microsoft.com/office/drawing/2014/main" id="{A526FC30-76D2-4305-ACBA-FAD4AD5ECC5B}"/>
               </a:ext>
             </a:extLst>
           </p:cNvPr>
@@ -3276,7 +3276,7 @@
           <p:cNvPr id="3" name="">
             <a:extLst xmlns:a="http://schemas.openxmlformats.org/drawingml/2006/main">
               <a:ext uri="{FF2B5EF4-FFF2-40B4-BE49-F238E27FC236}">
-                <a16:creationId xmlns:a16="http://schemas.microsoft.com/office/drawing/2014/main" id="{D1EEB4B2-E4D4-4DA3-8E1B-9C94AA81EC71}"/>
+                <a16:creationId xmlns:a16="http://schemas.microsoft.com/office/drawing/2014/main" id="{9C5BBB83-6511-4735-900F-E36AD2E65318}"/>
               </a:ext>
             </a:extLst>
           </p:cNvPr>
@@ -3326,7 +3326,7 @@
           <p:cNvPr id="4" name="">
             <a:extLst xmlns:a="http://schemas.openxmlformats.org/drawingml/2006/main">
               <a:ext uri="{FF2B5EF4-FFF2-40B4-BE49-F238E27FC236}">
-                <a16:creationId xmlns:a16="http://schemas.microsoft.com/office/drawing/2014/main" id="{E0011853-65F8-4123-B180-CA74DA6135A3}"/>
+                <a16:creationId xmlns:a16="http://schemas.microsoft.com/office/drawing/2014/main" id="{68C691C4-48D9-4370-8511-5115F8038332}"/>
               </a:ext>
             </a:extLst>
           </p:cNvPr>
@@ -3357,7 +3357,7 @@
           <p:cNvPr id="5" name="footer-11">
             <a:extLst xmlns:a="http://schemas.openxmlformats.org/drawingml/2006/main">
               <a:ext uri="{FF2B5EF4-FFF2-40B4-BE49-F238E27FC236}">
-                <a16:creationId xmlns:a16="http://schemas.microsoft.com/office/drawing/2014/main" id="{9CEFE535-E1DF-4971-B973-6F1254DCC2D3}"/>
+                <a16:creationId xmlns:a16="http://schemas.microsoft.com/office/drawing/2014/main" id="{BFE01FF8-3A23-40D3-AB48-10BA1994DC88}"/>
               </a:ext>
             </a:extLst>
           </p:cNvPr>
@@ -3407,7 +3407,7 @@
           <p:cNvPr id="6" name="">
             <a:extLst xmlns:a="http://schemas.openxmlformats.org/drawingml/2006/main">
               <a:ext uri="{FF2B5EF4-FFF2-40B4-BE49-F238E27FC236}">
-                <a16:creationId xmlns:a16="http://schemas.microsoft.com/office/drawing/2014/main" id="{65ADDF08-DD3C-4277-AB5D-ADD3E59C3BF1}"/>
+                <a16:creationId xmlns:a16="http://schemas.microsoft.com/office/drawing/2014/main" id="{A4696E9F-494C-40CE-A72C-6C1157795E4C}"/>
               </a:ext>
             </a:extLst>
           </p:cNvPr>
@@ -3442,7 +3442,7 @@
           <p:cNvPr id="7" name="">
             <a:extLst xmlns:a="http://schemas.openxmlformats.org/drawingml/2006/main">
               <a:ext uri="{FF2B5EF4-FFF2-40B4-BE49-F238E27FC236}">
-                <a16:creationId xmlns:a16="http://schemas.microsoft.com/office/drawing/2014/main" id="{369D6347-529D-4D7D-80CB-8FD342A55C7D}"/>
+                <a16:creationId xmlns:a16="http://schemas.microsoft.com/office/drawing/2014/main" id="{5AA61BFF-1473-4E1A-87F7-C3FC419E7C83}"/>
               </a:ext>
             </a:extLst>
           </p:cNvPr>
@@ -3492,7 +3492,7 @@
           <p:cNvPr id="8" name="">
             <a:extLst xmlns:a="http://schemas.openxmlformats.org/drawingml/2006/main">
               <a:ext uri="{FF2B5EF4-FFF2-40B4-BE49-F238E27FC236}">
-                <a16:creationId xmlns:a16="http://schemas.microsoft.com/office/drawing/2014/main" id="{1BF46313-FAD3-491D-B1CC-4169A89392B4}"/>
+                <a16:creationId xmlns:a16="http://schemas.microsoft.com/office/drawing/2014/main" id="{3011DE5E-1162-4FE6-A401-F578F1AF1E09}"/>
               </a:ext>
             </a:extLst>
           </p:cNvPr>
@@ -3593,7 +3593,7 @@
           <p:cNvPr id="9" name="">
             <a:extLst xmlns:a="http://schemas.openxmlformats.org/drawingml/2006/main">
               <a:ext uri="{FF2B5EF4-FFF2-40B4-BE49-F238E27FC236}">
-                <a16:creationId xmlns:a16="http://schemas.microsoft.com/office/drawing/2014/main" id="{CFC52C6B-7B60-46B4-BC1B-986E934B24E1}"/>
+                <a16:creationId xmlns:a16="http://schemas.microsoft.com/office/drawing/2014/main" id="{AA59BE28-1030-42C1-B80D-F5F873FB9CCD}"/>
               </a:ext>
             </a:extLst>
           </p:cNvPr>
@@ -3628,7 +3628,7 @@
           <p:cNvPr id="10" name="">
             <a:extLst xmlns:a="http://schemas.openxmlformats.org/drawingml/2006/main">
               <a:ext uri="{FF2B5EF4-FFF2-40B4-BE49-F238E27FC236}">
-                <a16:creationId xmlns:a16="http://schemas.microsoft.com/office/drawing/2014/main" id="{5D5863F8-B10F-441B-BEC0-1D900C91AA88}"/>
+                <a16:creationId xmlns:a16="http://schemas.microsoft.com/office/drawing/2014/main" id="{88ABA95B-B538-45C6-BF68-3CE00099F1B2}"/>
               </a:ext>
             </a:extLst>
           </p:cNvPr>
@@ -3678,7 +3678,7 @@
           <p:cNvPr id="11" name="">
             <a:extLst xmlns:a="http://schemas.openxmlformats.org/drawingml/2006/main">
               <a:ext uri="{FF2B5EF4-FFF2-40B4-BE49-F238E27FC236}">
-                <a16:creationId xmlns:a16="http://schemas.microsoft.com/office/drawing/2014/main" id="{53F0183B-B840-414F-9FCD-AA6EECA8220D}"/>
+                <a16:creationId xmlns:a16="http://schemas.microsoft.com/office/drawing/2014/main" id="{FD31B269-6746-48D4-9FBA-E65844B78829}"/>
               </a:ext>
             </a:extLst>
           </p:cNvPr>
@@ -3777,7 +3777,7 @@
     </p:spTree>
     <p:extLst>
       <p:ext uri="{BB962C8B-B14F-4D97-AF65-F5344CB8AC3E}">
-        <p14:creationId xmlns:p14="http://schemas.microsoft.com/office/powerpoint/2010/main" val="1701743758"/>
+        <p14:creationId xmlns:p14="http://schemas.microsoft.com/office/powerpoint/2010/main" val="138378098"/>
       </p:ext>
     </p:extLst>
   </p:cSld>
@@ -3808,7 +3808,7 @@
           <p:cNvPr id="1" name="">
             <a:extLst xmlns:a="http://schemas.openxmlformats.org/drawingml/2006/main">
               <a:ext uri="{FF2B5EF4-FFF2-40B4-BE49-F238E27FC236}">
-                <a16:creationId xmlns:a16="http://schemas.microsoft.com/office/drawing/2014/main" id="{A72AC7D4-791D-48DA-946C-1156F78B2FB4}"/>
+                <a16:creationId xmlns:a16="http://schemas.microsoft.com/office/drawing/2014/main" id="{6DE786F9-C2B1-45B7-A90B-0722A1D9672C}"/>
               </a:ext>
             </a:extLst>
           </p:cNvPr>
@@ -3839,7 +3839,7 @@
           <p:cNvPr id="2" name="">
             <a:extLst xmlns:a="http://schemas.openxmlformats.org/drawingml/2006/main">
               <a:ext uri="{FF2B5EF4-FFF2-40B4-BE49-F238E27FC236}">
-                <a16:creationId xmlns:a16="http://schemas.microsoft.com/office/drawing/2014/main" id="{6D68A7B1-DFA7-49B9-B942-788721948EBA}"/>
+                <a16:creationId xmlns:a16="http://schemas.microsoft.com/office/drawing/2014/main" id="{BC8F0C3D-CCC4-4CCB-9C1A-BC0ED4ED13F4}"/>
               </a:ext>
             </a:extLst>
           </p:cNvPr>
@@ -3889,7 +3889,7 @@
           <p:cNvPr id="3" name="">
             <a:extLst xmlns:a="http://schemas.openxmlformats.org/drawingml/2006/main">
               <a:ext uri="{FF2B5EF4-FFF2-40B4-BE49-F238E27FC236}">
-                <a16:creationId xmlns:a16="http://schemas.microsoft.com/office/drawing/2014/main" id="{541EF971-CAE2-4892-BC08-2B9B3FD08561}"/>
+                <a16:creationId xmlns:a16="http://schemas.microsoft.com/office/drawing/2014/main" id="{71533D07-1431-4436-B704-AF14476A37EB}"/>
               </a:ext>
             </a:extLst>
           </p:cNvPr>
@@ -3939,7 +3939,7 @@
           <p:cNvPr id="4" name="">
             <a:extLst xmlns:a="http://schemas.openxmlformats.org/drawingml/2006/main">
               <a:ext uri="{FF2B5EF4-FFF2-40B4-BE49-F238E27FC236}">
-                <a16:creationId xmlns:a16="http://schemas.microsoft.com/office/drawing/2014/main" id="{C20F7449-B911-47CA-9424-B563AA6CDD48}"/>
+                <a16:creationId xmlns:a16="http://schemas.microsoft.com/office/drawing/2014/main" id="{D97A6DF2-3F1B-408C-AFFF-BB8B27212D58}"/>
               </a:ext>
             </a:extLst>
           </p:cNvPr>
@@ -3970,7 +3970,7 @@
           <p:cNvPr id="5" name="footer-12">
             <a:extLst xmlns:a="http://schemas.openxmlformats.org/drawingml/2006/main">
               <a:ext uri="{FF2B5EF4-FFF2-40B4-BE49-F238E27FC236}">
-                <a16:creationId xmlns:a16="http://schemas.microsoft.com/office/drawing/2014/main" id="{2C679BEC-2294-4E24-B4B5-CF7A7A2E99F4}"/>
+                <a16:creationId xmlns:a16="http://schemas.microsoft.com/office/drawing/2014/main" id="{9402E720-7F35-462C-8DA7-34D26BE92D4B}"/>
               </a:ext>
             </a:extLst>
           </p:cNvPr>
@@ -4020,7 +4020,7 @@
           <p:cNvPr id="6" name="">
             <a:extLst xmlns:a="http://schemas.openxmlformats.org/drawingml/2006/main">
               <a:ext uri="{FF2B5EF4-FFF2-40B4-BE49-F238E27FC236}">
-                <a16:creationId xmlns:a16="http://schemas.microsoft.com/office/drawing/2014/main" id="{A05F1968-697A-4805-9495-60AB94250781}"/>
+                <a16:creationId xmlns:a16="http://schemas.microsoft.com/office/drawing/2014/main" id="{F995FF62-7FFD-4D39-B14F-128DDBE8535E}"/>
               </a:ext>
             </a:extLst>
           </p:cNvPr>
@@ -4055,7 +4055,7 @@
           <p:cNvPr id="7" name="">
             <a:extLst xmlns:a="http://schemas.openxmlformats.org/drawingml/2006/main">
               <a:ext uri="{FF2B5EF4-FFF2-40B4-BE49-F238E27FC236}">
-                <a16:creationId xmlns:a16="http://schemas.microsoft.com/office/drawing/2014/main" id="{C7A16C6D-EC73-416C-B139-CC0C1F35B5F8}"/>
+                <a16:creationId xmlns:a16="http://schemas.microsoft.com/office/drawing/2014/main" id="{98CA05D8-8930-4A3D-B6E8-352CE5EC1F3C}"/>
               </a:ext>
             </a:extLst>
           </p:cNvPr>
@@ -4105,7 +4105,7 @@
           <p:cNvPr id="8" name="">
             <a:extLst xmlns:a="http://schemas.openxmlformats.org/drawingml/2006/main">
               <a:ext uri="{FF2B5EF4-FFF2-40B4-BE49-F238E27FC236}">
-                <a16:creationId xmlns:a16="http://schemas.microsoft.com/office/drawing/2014/main" id="{C91B5E97-FCBB-4675-9ACB-1B2E5D50B374}"/>
+                <a16:creationId xmlns:a16="http://schemas.microsoft.com/office/drawing/2014/main" id="{43EE3D3F-5AF4-4540-9908-19468FDD49E1}"/>
               </a:ext>
             </a:extLst>
           </p:cNvPr>
@@ -4155,7 +4155,7 @@
           <p:cNvPr id="9" name="">
             <a:extLst xmlns:a="http://schemas.openxmlformats.org/drawingml/2006/main">
               <a:ext uri="{FF2B5EF4-FFF2-40B4-BE49-F238E27FC236}">
-                <a16:creationId xmlns:a16="http://schemas.microsoft.com/office/drawing/2014/main" id="{FC4F8DE1-06F0-4E88-BBEC-9DAB65A9963F}"/>
+                <a16:creationId xmlns:a16="http://schemas.microsoft.com/office/drawing/2014/main" id="{BF64E8EF-63A5-4FA9-98BA-71B4A7E090BC}"/>
               </a:ext>
             </a:extLst>
           </p:cNvPr>
@@ -4205,7 +4205,7 @@
           <p:cNvPr id="10" name="">
             <a:extLst xmlns:a="http://schemas.openxmlformats.org/drawingml/2006/main">
               <a:ext uri="{FF2B5EF4-FFF2-40B4-BE49-F238E27FC236}">
-                <a16:creationId xmlns:a16="http://schemas.microsoft.com/office/drawing/2014/main" id="{045DD2B8-52EC-4100-A553-DD24482AD0E2}"/>
+                <a16:creationId xmlns:a16="http://schemas.microsoft.com/office/drawing/2014/main" id="{03052495-7299-4598-A408-4B691FE270E9}"/>
               </a:ext>
             </a:extLst>
           </p:cNvPr>
@@ -4255,7 +4255,7 @@
           <p:cNvPr id="11" name="">
             <a:extLst xmlns:a="http://schemas.openxmlformats.org/drawingml/2006/main">
               <a:ext uri="{FF2B5EF4-FFF2-40B4-BE49-F238E27FC236}">
-                <a16:creationId xmlns:a16="http://schemas.microsoft.com/office/drawing/2014/main" id="{A656E405-15FE-453C-9C1F-1B1C25486786}"/>
+                <a16:creationId xmlns:a16="http://schemas.microsoft.com/office/drawing/2014/main" id="{5E91800B-D647-4B4A-9495-222B6174C2C8}"/>
               </a:ext>
             </a:extLst>
           </p:cNvPr>
@@ -4305,7 +4305,7 @@
           <p:cNvPr id="12" name="">
             <a:extLst xmlns:a="http://schemas.openxmlformats.org/drawingml/2006/main">
               <a:ext uri="{FF2B5EF4-FFF2-40B4-BE49-F238E27FC236}">
-                <a16:creationId xmlns:a16="http://schemas.microsoft.com/office/drawing/2014/main" id="{F27F2C63-139C-44E5-A8F9-9531849F1004}"/>
+                <a16:creationId xmlns:a16="http://schemas.microsoft.com/office/drawing/2014/main" id="{CDCB5C80-A6DC-46DD-9C03-A3A518590BAA}"/>
               </a:ext>
             </a:extLst>
           </p:cNvPr>
@@ -4355,7 +4355,7 @@
           <p:cNvPr id="13" name="">
             <a:extLst xmlns:a="http://schemas.openxmlformats.org/drawingml/2006/main">
               <a:ext uri="{FF2B5EF4-FFF2-40B4-BE49-F238E27FC236}">
-                <a16:creationId xmlns:a16="http://schemas.microsoft.com/office/drawing/2014/main" id="{79D3FD96-AF19-40B8-B318-885B9C72EE8C}"/>
+                <a16:creationId xmlns:a16="http://schemas.microsoft.com/office/drawing/2014/main" id="{C2F62D7F-A280-4A72-BA5F-57E285C1A9D4}"/>
               </a:ext>
             </a:extLst>
           </p:cNvPr>
@@ -4405,7 +4405,7 @@
           <p:cNvPr id="14" name="">
             <a:extLst xmlns:a="http://schemas.openxmlformats.org/drawingml/2006/main">
               <a:ext uri="{FF2B5EF4-FFF2-40B4-BE49-F238E27FC236}">
-                <a16:creationId xmlns:a16="http://schemas.microsoft.com/office/drawing/2014/main" id="{86DEEED1-D7C9-4E4F-8A36-4EFBCE2282EC}"/>
+                <a16:creationId xmlns:a16="http://schemas.microsoft.com/office/drawing/2014/main" id="{5AF89871-6A48-430D-AC81-3AAFFF3CDDE5}"/>
               </a:ext>
             </a:extLst>
           </p:cNvPr>
@@ -4455,7 +4455,7 @@
           <p:cNvPr id="15" name="">
             <a:extLst xmlns:a="http://schemas.openxmlformats.org/drawingml/2006/main">
               <a:ext uri="{FF2B5EF4-FFF2-40B4-BE49-F238E27FC236}">
-                <a16:creationId xmlns:a16="http://schemas.microsoft.com/office/drawing/2014/main" id="{8C357FC7-9C79-45DC-BC66-E82BDF39EBD9}"/>
+                <a16:creationId xmlns:a16="http://schemas.microsoft.com/office/drawing/2014/main" id="{112B560F-9748-4A94-B112-C596DDF36188}"/>
               </a:ext>
             </a:extLst>
           </p:cNvPr>
@@ -4505,7 +4505,7 @@
           <p:cNvPr id="16" name="">
             <a:extLst xmlns:a="http://schemas.openxmlformats.org/drawingml/2006/main">
               <a:ext uri="{FF2B5EF4-FFF2-40B4-BE49-F238E27FC236}">
-                <a16:creationId xmlns:a16="http://schemas.microsoft.com/office/drawing/2014/main" id="{CBA257B0-7A52-4219-90B6-1D60EC474D4E}"/>
+                <a16:creationId xmlns:a16="http://schemas.microsoft.com/office/drawing/2014/main" id="{ED93DDFF-9257-42C7-9D4D-1DFA13301841}"/>
               </a:ext>
             </a:extLst>
           </p:cNvPr>
@@ -4553,7 +4553,7 @@
     </p:spTree>
     <p:extLst>
       <p:ext uri="{BB962C8B-B14F-4D97-AF65-F5344CB8AC3E}">
-        <p14:creationId xmlns:p14="http://schemas.microsoft.com/office/powerpoint/2010/main" val="1303088151"/>
+        <p14:creationId xmlns:p14="http://schemas.microsoft.com/office/powerpoint/2010/main" val="184946464"/>
       </p:ext>
     </p:extLst>
   </p:cSld>
@@ -4584,7 +4584,7 @@
           <p:cNvPr id="1" name="">
             <a:extLst xmlns:a="http://schemas.openxmlformats.org/drawingml/2006/main">
               <a:ext uri="{FF2B5EF4-FFF2-40B4-BE49-F238E27FC236}">
-                <a16:creationId xmlns:a16="http://schemas.microsoft.com/office/drawing/2014/main" id="{5CF68B3F-CF6B-4F11-A281-5E55AF5D144C}"/>
+                <a16:creationId xmlns:a16="http://schemas.microsoft.com/office/drawing/2014/main" id="{D4589B04-5A83-4D01-AC4C-C82C783662DE}"/>
               </a:ext>
             </a:extLst>
           </p:cNvPr>
@@ -4615,7 +4615,7 @@
           <p:cNvPr id="2" name="">
             <a:extLst xmlns:a="http://schemas.openxmlformats.org/drawingml/2006/main">
               <a:ext uri="{FF2B5EF4-FFF2-40B4-BE49-F238E27FC236}">
-                <a16:creationId xmlns:a16="http://schemas.microsoft.com/office/drawing/2014/main" id="{2E0091AC-AC47-4E4D-8A7F-C583F90CA9F9}"/>
+                <a16:creationId xmlns:a16="http://schemas.microsoft.com/office/drawing/2014/main" id="{324BA72D-5D83-4C19-8EC9-4794A0086A34}"/>
               </a:ext>
             </a:extLst>
           </p:cNvPr>
@@ -4665,7 +4665,7 @@
           <p:cNvPr id="3" name="">
             <a:extLst xmlns:a="http://schemas.openxmlformats.org/drawingml/2006/main">
               <a:ext uri="{FF2B5EF4-FFF2-40B4-BE49-F238E27FC236}">
-                <a16:creationId xmlns:a16="http://schemas.microsoft.com/office/drawing/2014/main" id="{57F94ADE-2DCE-4A7A-9E55-82BB51C97564}"/>
+                <a16:creationId xmlns:a16="http://schemas.microsoft.com/office/drawing/2014/main" id="{F817B52A-E52A-4909-B178-5C0644D63D02}"/>
               </a:ext>
             </a:extLst>
           </p:cNvPr>
@@ -4715,7 +4715,7 @@
           <p:cNvPr id="4" name="">
             <a:extLst xmlns:a="http://schemas.openxmlformats.org/drawingml/2006/main">
               <a:ext uri="{FF2B5EF4-FFF2-40B4-BE49-F238E27FC236}">
-                <a16:creationId xmlns:a16="http://schemas.microsoft.com/office/drawing/2014/main" id="{44E12E77-D280-4377-AF64-F275C38FFB8A}"/>
+                <a16:creationId xmlns:a16="http://schemas.microsoft.com/office/drawing/2014/main" id="{F3C9D148-193B-4A7E-AECF-EF88B7D28802}"/>
               </a:ext>
             </a:extLst>
           </p:cNvPr>
@@ -4746,7 +4746,7 @@
           <p:cNvPr id="5" name="footer-13">
             <a:extLst xmlns:a="http://schemas.openxmlformats.org/drawingml/2006/main">
               <a:ext uri="{FF2B5EF4-FFF2-40B4-BE49-F238E27FC236}">
-                <a16:creationId xmlns:a16="http://schemas.microsoft.com/office/drawing/2014/main" id="{74BDE110-7541-4D3D-B8A0-FF1F5F6DBABE}"/>
+                <a16:creationId xmlns:a16="http://schemas.microsoft.com/office/drawing/2014/main" id="{13E951DF-8ABA-4AA8-95E1-FA0DC4B06C6E}"/>
               </a:ext>
             </a:extLst>
           </p:cNvPr>
@@ -4796,7 +4796,7 @@
           <p:cNvPr id="6" name="">
             <a:extLst xmlns:a="http://schemas.openxmlformats.org/drawingml/2006/main">
               <a:ext uri="{FF2B5EF4-FFF2-40B4-BE49-F238E27FC236}">
-                <a16:creationId xmlns:a16="http://schemas.microsoft.com/office/drawing/2014/main" id="{4468B3FA-C1E7-466D-B0D6-DA0499C730F5}"/>
+                <a16:creationId xmlns:a16="http://schemas.microsoft.com/office/drawing/2014/main" id="{FDF41ABA-840D-4BC2-A49D-27024AC06132}"/>
               </a:ext>
             </a:extLst>
           </p:cNvPr>
@@ -4846,7 +4846,7 @@
           <p:cNvPr id="7" name="">
             <a:extLst xmlns:a="http://schemas.openxmlformats.org/drawingml/2006/main">
               <a:ext uri="{FF2B5EF4-FFF2-40B4-BE49-F238E27FC236}">
-                <a16:creationId xmlns:a16="http://schemas.microsoft.com/office/drawing/2014/main" id="{D9448933-FC0C-4586-A49A-3CC754FA23D7}"/>
+                <a16:creationId xmlns:a16="http://schemas.microsoft.com/office/drawing/2014/main" id="{0DFF0E3C-A1A4-48DA-9BCA-65AFB8DCEBB7}"/>
               </a:ext>
             </a:extLst>
           </p:cNvPr>
@@ -4896,7 +4896,7 @@
           <p:cNvPr id="8" name="">
             <a:extLst xmlns:a="http://schemas.openxmlformats.org/drawingml/2006/main">
               <a:ext uri="{FF2B5EF4-FFF2-40B4-BE49-F238E27FC236}">
-                <a16:creationId xmlns:a16="http://schemas.microsoft.com/office/drawing/2014/main" id="{A6AF2A44-80E9-4D83-BD63-46CF88233A53}"/>
+                <a16:creationId xmlns:a16="http://schemas.microsoft.com/office/drawing/2014/main" id="{E8D86486-5694-4665-8B31-0BE9E9AA6349}"/>
               </a:ext>
             </a:extLst>
           </p:cNvPr>
@@ -4946,7 +4946,7 @@
           <p:cNvPr id="9" name="">
             <a:extLst xmlns:a="http://schemas.openxmlformats.org/drawingml/2006/main">
               <a:ext uri="{FF2B5EF4-FFF2-40B4-BE49-F238E27FC236}">
-                <a16:creationId xmlns:a16="http://schemas.microsoft.com/office/drawing/2014/main" id="{5CEE358E-ED13-4A14-948F-32B3D55C7D00}"/>
+                <a16:creationId xmlns:a16="http://schemas.microsoft.com/office/drawing/2014/main" id="{4B1850F2-E00A-47A6-B967-28977510BAB3}"/>
               </a:ext>
             </a:extLst>
           </p:cNvPr>
@@ -4977,7 +4977,7 @@
           <p:cNvPr id="10" name="">
             <a:extLst xmlns:a="http://schemas.openxmlformats.org/drawingml/2006/main">
               <a:ext uri="{FF2B5EF4-FFF2-40B4-BE49-F238E27FC236}">
-                <a16:creationId xmlns:a16="http://schemas.microsoft.com/office/drawing/2014/main" id="{A849F895-F14E-4558-A4B5-D1BC7273C688}"/>
+                <a16:creationId xmlns:a16="http://schemas.microsoft.com/office/drawing/2014/main" id="{A4ED954E-C48E-46FF-9B13-6C2E0E982038}"/>
               </a:ext>
             </a:extLst>
           </p:cNvPr>
@@ -5027,7 +5027,7 @@
           <p:cNvPr id="11" name="">
             <a:extLst xmlns:a="http://schemas.openxmlformats.org/drawingml/2006/main">
               <a:ext uri="{FF2B5EF4-FFF2-40B4-BE49-F238E27FC236}">
-                <a16:creationId xmlns:a16="http://schemas.microsoft.com/office/drawing/2014/main" id="{AF80E030-B922-40A4-B48D-EE397AD2048D}"/>
+                <a16:creationId xmlns:a16="http://schemas.microsoft.com/office/drawing/2014/main" id="{BFE00847-6380-436E-9537-6024ED1586E9}"/>
               </a:ext>
             </a:extLst>
           </p:cNvPr>
@@ -5077,7 +5077,7 @@
           <p:cNvPr id="12" name="">
             <a:extLst xmlns:a="http://schemas.openxmlformats.org/drawingml/2006/main">
               <a:ext uri="{FF2B5EF4-FFF2-40B4-BE49-F238E27FC236}">
-                <a16:creationId xmlns:a16="http://schemas.microsoft.com/office/drawing/2014/main" id="{42B90B4B-55FD-4E1F-A947-6F56B1D7F02E}"/>
+                <a16:creationId xmlns:a16="http://schemas.microsoft.com/office/drawing/2014/main" id="{422D8C21-0027-4E2F-BE35-2D5CFE600984}"/>
               </a:ext>
             </a:extLst>
           </p:cNvPr>
@@ -5127,7 +5127,7 @@
           <p:cNvPr id="13" name="">
             <a:extLst xmlns:a="http://schemas.openxmlformats.org/drawingml/2006/main">
               <a:ext uri="{FF2B5EF4-FFF2-40B4-BE49-F238E27FC236}">
-                <a16:creationId xmlns:a16="http://schemas.microsoft.com/office/drawing/2014/main" id="{4EAE6B3B-D22D-4C03-86A2-DF2A3D7C6CF0}"/>
+                <a16:creationId xmlns:a16="http://schemas.microsoft.com/office/drawing/2014/main" id="{9F7606ED-1171-4D31-925C-C503F407F758}"/>
               </a:ext>
             </a:extLst>
           </p:cNvPr>
@@ -5158,7 +5158,7 @@
           <p:cNvPr id="14" name="">
             <a:extLst xmlns:a="http://schemas.openxmlformats.org/drawingml/2006/main">
               <a:ext uri="{FF2B5EF4-FFF2-40B4-BE49-F238E27FC236}">
-                <a16:creationId xmlns:a16="http://schemas.microsoft.com/office/drawing/2014/main" id="{EEBCD19D-9800-4F39-88D2-9F5499FD33E6}"/>
+                <a16:creationId xmlns:a16="http://schemas.microsoft.com/office/drawing/2014/main" id="{C1E25F24-FCFA-4DC7-9514-F4DA0FCD2E0B}"/>
               </a:ext>
             </a:extLst>
           </p:cNvPr>
@@ -5208,7 +5208,7 @@
           <p:cNvPr id="15" name="">
             <a:extLst xmlns:a="http://schemas.openxmlformats.org/drawingml/2006/main">
               <a:ext uri="{FF2B5EF4-FFF2-40B4-BE49-F238E27FC236}">
-                <a16:creationId xmlns:a16="http://schemas.microsoft.com/office/drawing/2014/main" id="{12F7E254-852B-455D-B12D-E513C4DC522E}"/>
+                <a16:creationId xmlns:a16="http://schemas.microsoft.com/office/drawing/2014/main" id="{B379410D-02A9-4707-A897-031FD7A89ED4}"/>
               </a:ext>
             </a:extLst>
           </p:cNvPr>
@@ -5258,7 +5258,7 @@
           <p:cNvPr id="16" name="">
             <a:extLst xmlns:a="http://schemas.openxmlformats.org/drawingml/2006/main">
               <a:ext uri="{FF2B5EF4-FFF2-40B4-BE49-F238E27FC236}">
-                <a16:creationId xmlns:a16="http://schemas.microsoft.com/office/drawing/2014/main" id="{8C40FA96-1DEF-40C2-AC9C-5949DF15E043}"/>
+                <a16:creationId xmlns:a16="http://schemas.microsoft.com/office/drawing/2014/main" id="{D6E942B0-7777-453B-A4E9-C0F86363F8E8}"/>
               </a:ext>
             </a:extLst>
           </p:cNvPr>
@@ -5308,7 +5308,7 @@
           <p:cNvPr id="17" name="">
             <a:extLst xmlns:a="http://schemas.openxmlformats.org/drawingml/2006/main">
               <a:ext uri="{FF2B5EF4-FFF2-40B4-BE49-F238E27FC236}">
-                <a16:creationId xmlns:a16="http://schemas.microsoft.com/office/drawing/2014/main" id="{9C6F9EE6-5A48-4FEB-A4BC-97C37ED9D049}"/>
+                <a16:creationId xmlns:a16="http://schemas.microsoft.com/office/drawing/2014/main" id="{0D6B69F5-24F6-4164-9721-9B75A59CD77A}"/>
               </a:ext>
             </a:extLst>
           </p:cNvPr>
@@ -5339,7 +5339,7 @@
           <p:cNvPr id="18" name="">
             <a:extLst xmlns:a="http://schemas.openxmlformats.org/drawingml/2006/main">
               <a:ext uri="{FF2B5EF4-FFF2-40B4-BE49-F238E27FC236}">
-                <a16:creationId xmlns:a16="http://schemas.microsoft.com/office/drawing/2014/main" id="{066C394A-0525-442E-9E8F-F7A32DC1C1B9}"/>
+                <a16:creationId xmlns:a16="http://schemas.microsoft.com/office/drawing/2014/main" id="{B3D2E46E-7B00-4FA9-ABDC-1B21BE900553}"/>
               </a:ext>
             </a:extLst>
           </p:cNvPr>
@@ -5389,7 +5389,7 @@
           <p:cNvPr id="19" name="">
             <a:extLst xmlns:a="http://schemas.openxmlformats.org/drawingml/2006/main">
               <a:ext uri="{FF2B5EF4-FFF2-40B4-BE49-F238E27FC236}">
-                <a16:creationId xmlns:a16="http://schemas.microsoft.com/office/drawing/2014/main" id="{7913A1A7-485B-44DE-8893-72010589EC8B}"/>
+                <a16:creationId xmlns:a16="http://schemas.microsoft.com/office/drawing/2014/main" id="{5EEF110A-00D2-4ED0-8FAA-B0D3445861F0}"/>
               </a:ext>
             </a:extLst>
           </p:cNvPr>
@@ -5439,7 +5439,7 @@
           <p:cNvPr id="20" name="">
             <a:extLst xmlns:a="http://schemas.openxmlformats.org/drawingml/2006/main">
               <a:ext uri="{FF2B5EF4-FFF2-40B4-BE49-F238E27FC236}">
-                <a16:creationId xmlns:a16="http://schemas.microsoft.com/office/drawing/2014/main" id="{2108B499-BE2D-4B5F-A8F4-02CFFD68E5A1}"/>
+                <a16:creationId xmlns:a16="http://schemas.microsoft.com/office/drawing/2014/main" id="{43AAE7F7-9A48-466B-B0C2-A3A495FEC200}"/>
               </a:ext>
             </a:extLst>
           </p:cNvPr>
@@ -5489,7 +5489,7 @@
           <p:cNvPr id="21" name="">
             <a:extLst xmlns:a="http://schemas.openxmlformats.org/drawingml/2006/main">
               <a:ext uri="{FF2B5EF4-FFF2-40B4-BE49-F238E27FC236}">
-                <a16:creationId xmlns:a16="http://schemas.microsoft.com/office/drawing/2014/main" id="{758C11C7-4C75-440E-B735-A4CC86D25272}"/>
+                <a16:creationId xmlns:a16="http://schemas.microsoft.com/office/drawing/2014/main" id="{A67B98F3-9E7B-48F4-95D1-F77115F708D6}"/>
               </a:ext>
             </a:extLst>
           </p:cNvPr>
@@ -5520,7 +5520,7 @@
           <p:cNvPr id="22" name="">
             <a:extLst xmlns:a="http://schemas.openxmlformats.org/drawingml/2006/main">
               <a:ext uri="{FF2B5EF4-FFF2-40B4-BE49-F238E27FC236}">
-                <a16:creationId xmlns:a16="http://schemas.microsoft.com/office/drawing/2014/main" id="{7ED0081C-5357-4923-A3D0-1AF22CFC2856}"/>
+                <a16:creationId xmlns:a16="http://schemas.microsoft.com/office/drawing/2014/main" id="{F07449EB-2358-4EC1-9183-8DE808D9399A}"/>
               </a:ext>
             </a:extLst>
           </p:cNvPr>
@@ -5570,7 +5570,7 @@
           <p:cNvPr id="23" name="">
             <a:extLst xmlns:a="http://schemas.openxmlformats.org/drawingml/2006/main">
               <a:ext uri="{FF2B5EF4-FFF2-40B4-BE49-F238E27FC236}">
-                <a16:creationId xmlns:a16="http://schemas.microsoft.com/office/drawing/2014/main" id="{CC623017-53E5-4A5D-BE7D-237697609096}"/>
+                <a16:creationId xmlns:a16="http://schemas.microsoft.com/office/drawing/2014/main" id="{9262DDEA-5AE0-417F-8EB5-CB1EA1D22770}"/>
               </a:ext>
             </a:extLst>
           </p:cNvPr>
@@ -5620,7 +5620,7 @@
           <p:cNvPr id="24" name="">
             <a:extLst xmlns:a="http://schemas.openxmlformats.org/drawingml/2006/main">
               <a:ext uri="{FF2B5EF4-FFF2-40B4-BE49-F238E27FC236}">
-                <a16:creationId xmlns:a16="http://schemas.microsoft.com/office/drawing/2014/main" id="{898D90D6-E15C-48CF-BE4A-B40184A3B542}"/>
+                <a16:creationId xmlns:a16="http://schemas.microsoft.com/office/drawing/2014/main" id="{D2AABC25-C2F6-443F-9082-57ECFC8C3498}"/>
               </a:ext>
             </a:extLst>
           </p:cNvPr>
@@ -5670,7 +5670,7 @@
           <p:cNvPr id="25" name="">
             <a:extLst xmlns:a="http://schemas.openxmlformats.org/drawingml/2006/main">
               <a:ext uri="{FF2B5EF4-FFF2-40B4-BE49-F238E27FC236}">
-                <a16:creationId xmlns:a16="http://schemas.microsoft.com/office/drawing/2014/main" id="{CE3A8823-B10B-498B-B9E1-03EC679D0A90}"/>
+                <a16:creationId xmlns:a16="http://schemas.microsoft.com/office/drawing/2014/main" id="{3C3E18D2-2728-42B1-A4AA-C06774597CC9}"/>
               </a:ext>
             </a:extLst>
           </p:cNvPr>
@@ -5701,7 +5701,7 @@
           <p:cNvPr id="26" name="">
             <a:extLst xmlns:a="http://schemas.openxmlformats.org/drawingml/2006/main">
               <a:ext uri="{FF2B5EF4-FFF2-40B4-BE49-F238E27FC236}">
-                <a16:creationId xmlns:a16="http://schemas.microsoft.com/office/drawing/2014/main" id="{0492BA52-110C-4C64-AB16-908EC5724D98}"/>
+                <a16:creationId xmlns:a16="http://schemas.microsoft.com/office/drawing/2014/main" id="{8941505A-B5C0-4C72-82DC-F47C1481A3B7}"/>
               </a:ext>
             </a:extLst>
           </p:cNvPr>
@@ -5751,7 +5751,7 @@
           <p:cNvPr id="27" name="">
             <a:extLst xmlns:a="http://schemas.openxmlformats.org/drawingml/2006/main">
               <a:ext uri="{FF2B5EF4-FFF2-40B4-BE49-F238E27FC236}">
-                <a16:creationId xmlns:a16="http://schemas.microsoft.com/office/drawing/2014/main" id="{1A291D40-EDB9-4ACC-A6FC-621F7E6A4748}"/>
+                <a16:creationId xmlns:a16="http://schemas.microsoft.com/office/drawing/2014/main" id="{FC1DBE03-50AA-414E-A765-4EDA3BD8D831}"/>
               </a:ext>
             </a:extLst>
           </p:cNvPr>
@@ -5801,7 +5801,7 @@
           <p:cNvPr id="28" name="">
             <a:extLst xmlns:a="http://schemas.openxmlformats.org/drawingml/2006/main">
               <a:ext uri="{FF2B5EF4-FFF2-40B4-BE49-F238E27FC236}">
-                <a16:creationId xmlns:a16="http://schemas.microsoft.com/office/drawing/2014/main" id="{71532E76-14FB-4903-A9C0-CC231323CA13}"/>
+                <a16:creationId xmlns:a16="http://schemas.microsoft.com/office/drawing/2014/main" id="{92B5338D-4870-4CDE-A5BB-5D9BDB944DA3}"/>
               </a:ext>
             </a:extLst>
           </p:cNvPr>
@@ -5851,7 +5851,7 @@
           <p:cNvPr id="29" name="">
             <a:extLst xmlns:a="http://schemas.openxmlformats.org/drawingml/2006/main">
               <a:ext uri="{FF2B5EF4-FFF2-40B4-BE49-F238E27FC236}">
-                <a16:creationId xmlns:a16="http://schemas.microsoft.com/office/drawing/2014/main" id="{27657B00-E24F-43B5-9E61-799715A1438C}"/>
+                <a16:creationId xmlns:a16="http://schemas.microsoft.com/office/drawing/2014/main" id="{6EBC3631-310F-4518-9493-505BC782AD02}"/>
               </a:ext>
             </a:extLst>
           </p:cNvPr>
@@ -5880,7 +5880,7 @@
     </p:spTree>
     <p:extLst>
       <p:ext uri="{BB962C8B-B14F-4D97-AF65-F5344CB8AC3E}">
-        <p14:creationId xmlns:p14="http://schemas.microsoft.com/office/powerpoint/2010/main" val="90070107"/>
+        <p14:creationId xmlns:p14="http://schemas.microsoft.com/office/powerpoint/2010/main" val="986092403"/>
       </p:ext>
     </p:extLst>
   </p:cSld>
@@ -5911,7 +5911,7 @@
           <p:cNvPr id="1" name="">
             <a:extLst xmlns:a="http://schemas.openxmlformats.org/drawingml/2006/main">
               <a:ext uri="{FF2B5EF4-FFF2-40B4-BE49-F238E27FC236}">
-                <a16:creationId xmlns:a16="http://schemas.microsoft.com/office/drawing/2014/main" id="{9DCC354C-D92A-4878-A57A-2E5CEBF1B8B9}"/>
+                <a16:creationId xmlns:a16="http://schemas.microsoft.com/office/drawing/2014/main" id="{E07E6B1C-0EF5-47D9-B37F-9192D3E6D917}"/>
               </a:ext>
             </a:extLst>
           </p:cNvPr>
@@ -5942,7 +5942,7 @@
           <p:cNvPr id="2" name="">
             <a:extLst xmlns:a="http://schemas.openxmlformats.org/drawingml/2006/main">
               <a:ext uri="{FF2B5EF4-FFF2-40B4-BE49-F238E27FC236}">
-                <a16:creationId xmlns:a16="http://schemas.microsoft.com/office/drawing/2014/main" id="{671BC227-D5D1-48F4-9DD5-1DBD2EA8C217}"/>
+                <a16:creationId xmlns:a16="http://schemas.microsoft.com/office/drawing/2014/main" id="{80C9C4E2-68D4-4638-B655-949C799A341D}"/>
               </a:ext>
             </a:extLst>
           </p:cNvPr>
@@ -5992,7 +5992,7 @@
           <p:cNvPr id="3" name="">
             <a:extLst xmlns:a="http://schemas.openxmlformats.org/drawingml/2006/main">
               <a:ext uri="{FF2B5EF4-FFF2-40B4-BE49-F238E27FC236}">
-                <a16:creationId xmlns:a16="http://schemas.microsoft.com/office/drawing/2014/main" id="{7A148D6B-D0E6-4A78-BF45-3A9CF31CB34F}"/>
+                <a16:creationId xmlns:a16="http://schemas.microsoft.com/office/drawing/2014/main" id="{AA398FEB-B03B-48AA-A0DA-B9834BD496D0}"/>
               </a:ext>
             </a:extLst>
           </p:cNvPr>
@@ -6042,7 +6042,7 @@
           <p:cNvPr id="4" name="">
             <a:extLst xmlns:a="http://schemas.openxmlformats.org/drawingml/2006/main">
               <a:ext uri="{FF2B5EF4-FFF2-40B4-BE49-F238E27FC236}">
-                <a16:creationId xmlns:a16="http://schemas.microsoft.com/office/drawing/2014/main" id="{6B881651-152C-46E2-868B-BF198A01E801}"/>
+                <a16:creationId xmlns:a16="http://schemas.microsoft.com/office/drawing/2014/main" id="{E0D9BCEF-032D-47EC-A5B8-D6381C8C1B45}"/>
               </a:ext>
             </a:extLst>
           </p:cNvPr>
@@ -6073,7 +6073,7 @@
           <p:cNvPr id="5" name="footer-14">
             <a:extLst xmlns:a="http://schemas.openxmlformats.org/drawingml/2006/main">
               <a:ext uri="{FF2B5EF4-FFF2-40B4-BE49-F238E27FC236}">
-                <a16:creationId xmlns:a16="http://schemas.microsoft.com/office/drawing/2014/main" id="{0A483674-40AA-40F1-A2B5-5222322823FC}"/>
+                <a16:creationId xmlns:a16="http://schemas.microsoft.com/office/drawing/2014/main" id="{B7E45824-C61A-42B0-A142-48856077B27A}"/>
               </a:ext>
             </a:extLst>
           </p:cNvPr>
@@ -6123,7 +6123,7 @@
           <p:cNvPr id="6" name="">
             <a:extLst xmlns:a="http://schemas.openxmlformats.org/drawingml/2006/main">
               <a:ext uri="{FF2B5EF4-FFF2-40B4-BE49-F238E27FC236}">
-                <a16:creationId xmlns:a16="http://schemas.microsoft.com/office/drawing/2014/main" id="{76559A75-879D-4294-9271-4AA7C64279B0}"/>
+                <a16:creationId xmlns:a16="http://schemas.microsoft.com/office/drawing/2014/main" id="{94C261A1-6190-41FD-B798-25C15558A2C6}"/>
               </a:ext>
             </a:extLst>
           </p:cNvPr>
@@ -6158,7 +6158,7 @@
           <p:cNvPr id="7" name="">
             <a:extLst xmlns:a="http://schemas.openxmlformats.org/drawingml/2006/main">
               <a:ext uri="{FF2B5EF4-FFF2-40B4-BE49-F238E27FC236}">
-                <a16:creationId xmlns:a16="http://schemas.microsoft.com/office/drawing/2014/main" id="{34929815-6B17-4E7D-8F1F-FEA748D000E0}"/>
+                <a16:creationId xmlns:a16="http://schemas.microsoft.com/office/drawing/2014/main" id="{3E61F30E-9157-4717-A61B-E93A76E3321C}"/>
               </a:ext>
             </a:extLst>
           </p:cNvPr>
@@ -6208,7 +6208,7 @@
           <p:cNvPr id="8" name="">
             <a:extLst xmlns:a="http://schemas.openxmlformats.org/drawingml/2006/main">
               <a:ext uri="{FF2B5EF4-FFF2-40B4-BE49-F238E27FC236}">
-                <a16:creationId xmlns:a16="http://schemas.microsoft.com/office/drawing/2014/main" id="{4A53315F-F5C8-4983-8BDD-52AFA4968D74}"/>
+                <a16:creationId xmlns:a16="http://schemas.microsoft.com/office/drawing/2014/main" id="{53FAA238-A24E-4E66-98D8-063A63BFFB3B}"/>
               </a:ext>
             </a:extLst>
           </p:cNvPr>
@@ -6309,7 +6309,7 @@
           <p:cNvPr id="9" name="">
             <a:extLst xmlns:a="http://schemas.openxmlformats.org/drawingml/2006/main">
               <a:ext uri="{FF2B5EF4-FFF2-40B4-BE49-F238E27FC236}">
-                <a16:creationId xmlns:a16="http://schemas.microsoft.com/office/drawing/2014/main" id="{D60A88D7-6A7A-418A-A34E-C370936808E1}"/>
+                <a16:creationId xmlns:a16="http://schemas.microsoft.com/office/drawing/2014/main" id="{D9B2E24D-4D19-4ADF-9779-AF62CF93F809}"/>
               </a:ext>
             </a:extLst>
           </p:cNvPr>
@@ -6344,7 +6344,7 @@
           <p:cNvPr id="10" name="">
             <a:extLst xmlns:a="http://schemas.openxmlformats.org/drawingml/2006/main">
               <a:ext uri="{FF2B5EF4-FFF2-40B4-BE49-F238E27FC236}">
-                <a16:creationId xmlns:a16="http://schemas.microsoft.com/office/drawing/2014/main" id="{9F4AE82B-5424-4D82-A56E-55FF9A1FAA23}"/>
+                <a16:creationId xmlns:a16="http://schemas.microsoft.com/office/drawing/2014/main" id="{617E0148-1D93-4B0E-B398-39DE730E2B1D}"/>
               </a:ext>
             </a:extLst>
           </p:cNvPr>
@@ -6394,7 +6394,7 @@
           <p:cNvPr id="11" name="">
             <a:extLst xmlns:a="http://schemas.openxmlformats.org/drawingml/2006/main">
               <a:ext uri="{FF2B5EF4-FFF2-40B4-BE49-F238E27FC236}">
-                <a16:creationId xmlns:a16="http://schemas.microsoft.com/office/drawing/2014/main" id="{0D89DBC0-200F-40FF-AEDA-5D700EB74C31}"/>
+                <a16:creationId xmlns:a16="http://schemas.microsoft.com/office/drawing/2014/main" id="{BCF4CA01-00CF-4B71-B58F-B9285FD871D1}"/>
               </a:ext>
             </a:extLst>
           </p:cNvPr>
@@ -6406,30 +6406,30 @@
         <p:spPr>
           <a:xfrm xmlns:a="http://schemas.openxmlformats.org/drawingml/2006/main">
             <a:off x="6762750" y="2667000"/>
-            <a:ext cx="4000500" cy="1428750"/>
-          </a:xfrm>
-          <a:prstGeom xmlns:a="http://schemas.openxmlformats.org/drawingml/2006/main" prst="rect">
-            <a:avLst/>
-          </a:prstGeom>
-          <a:noFill xmlns:a="http://schemas.openxmlformats.org/drawingml/2006/main"/>
-          <a:ln xmlns:a="http://schemas.openxmlformats.org/drawingml/2006/main" w="0">
-            <a:noFill/>
-            <a:prstDash val="solid"/>
-          </a:ln>
-        </p:spPr>
-        <p:txBody>
-          <a:bodyPr xmlns:a="http://schemas.openxmlformats.org/drawingml/2006/main"/>
-          <a:lstStyle xmlns:a="http://schemas.openxmlformats.org/drawingml/2006/main"/>
-          <a:p xmlns:a="http://schemas.openxmlformats.org/drawingml/2006/main">
-            <a:pPr algn="l">
-              <a:defRPr sz="1650" b="0">
-                <a:solidFill>
-                  <a:srgbClr val="0B1220"/>
-                </a:solidFill>
-              </a:defRPr>
-            </a:pPr>
-            <a:r>
-              <a:rPr sz="1650" b="0">
+            <a:ext cx="4000500" cy="1571625"/>
+          </a:xfrm>
+          <a:prstGeom xmlns:a="http://schemas.openxmlformats.org/drawingml/2006/main" prst="rect">
+            <a:avLst/>
+          </a:prstGeom>
+          <a:noFill xmlns:a="http://schemas.openxmlformats.org/drawingml/2006/main"/>
+          <a:ln xmlns:a="http://schemas.openxmlformats.org/drawingml/2006/main" w="0">
+            <a:noFill/>
+            <a:prstDash val="solid"/>
+          </a:ln>
+        </p:spPr>
+        <p:txBody>
+          <a:bodyPr xmlns:a="http://schemas.openxmlformats.org/drawingml/2006/main"/>
+          <a:lstStyle xmlns:a="http://schemas.openxmlformats.org/drawingml/2006/main"/>
+          <a:p xmlns:a="http://schemas.openxmlformats.org/drawingml/2006/main">
+            <a:pPr algn="l">
+              <a:defRPr sz="1575" b="0">
+                <a:solidFill>
+                  <a:srgbClr val="0B1220"/>
+                </a:solidFill>
+              </a:defRPr>
+            </a:pPr>
+            <a:r>
+              <a:rPr sz="1575" b="0">
                 <a:solidFill>
                   <a:srgbClr val="0B1220"/>
                 </a:solidFill>
@@ -6439,14 +6439,14 @@
           </a:p>
           <a:p xmlns:a="http://schemas.openxmlformats.org/drawingml/2006/main">
             <a:pPr algn="l">
-              <a:defRPr sz="1650" b="0">
-                <a:solidFill>
-                  <a:srgbClr val="0B1220"/>
-                </a:solidFill>
-              </a:defRPr>
-            </a:pPr>
-            <a:r>
-              <a:rPr sz="1650" b="0">
+              <a:defRPr sz="1575" b="0">
+                <a:solidFill>
+                  <a:srgbClr val="0B1220"/>
+                </a:solidFill>
+              </a:defRPr>
+            </a:pPr>
+            <a:r>
+              <a:rPr sz="1575" b="0">
                 <a:solidFill>
                   <a:srgbClr val="0B1220"/>
                 </a:solidFill>
@@ -6456,14 +6456,14 @@
           </a:p>
           <a:p xmlns:a="http://schemas.openxmlformats.org/drawingml/2006/main">
             <a:pPr algn="l">
-              <a:defRPr sz="1650" b="0">
-                <a:solidFill>
-                  <a:srgbClr val="0B1220"/>
-                </a:solidFill>
-              </a:defRPr>
-            </a:pPr>
-            <a:r>
-              <a:rPr sz="1650" b="0">
+              <a:defRPr sz="1575" b="0">
+                <a:solidFill>
+                  <a:srgbClr val="0B1220"/>
+                </a:solidFill>
+              </a:defRPr>
+            </a:pPr>
+            <a:r>
+              <a:rPr sz="1575" b="0">
                 <a:solidFill>
                   <a:srgbClr val="0B1220"/>
                 </a:solidFill>
@@ -6473,19 +6473,36 @@
           </a:p>
           <a:p xmlns:a="http://schemas.openxmlformats.org/drawingml/2006/main">
             <a:pPr algn="l">
-              <a:defRPr sz="1650" b="0">
-                <a:solidFill>
-                  <a:srgbClr val="0B1220"/>
-                </a:solidFill>
-              </a:defRPr>
-            </a:pPr>
-            <a:r>
-              <a:rPr sz="1650" b="0">
-                <a:solidFill>
-                  <a:srgbClr val="0B1220"/>
-                </a:solidFill>
-              </a:rPr>
-              <a:t>• 切到复现实验指标页</a:t>
+              <a:defRPr sz="1575" b="0">
+                <a:solidFill>
+                  <a:srgbClr val="0B1220"/>
+                </a:solidFill>
+              </a:defRPr>
+            </a:pPr>
+            <a:r>
+              <a:rPr sz="1575" b="0">
+                <a:solidFill>
+                  <a:srgbClr val="0B1220"/>
+                </a:solidFill>
+              </a:rPr>
+              <a:t>• 切到分类不降验证页</a:t>
+            </a:r>
+          </a:p>
+          <a:p xmlns:a="http://schemas.openxmlformats.org/drawingml/2006/main">
+            <a:pPr algn="l">
+              <a:defRPr sz="1575" b="0">
+                <a:solidFill>
+                  <a:srgbClr val="0B1220"/>
+                </a:solidFill>
+              </a:defRPr>
+            </a:pPr>
+            <a:r>
+              <a:rPr sz="1575" b="0">
+                <a:solidFill>
+                  <a:srgbClr val="0B1220"/>
+                </a:solidFill>
+              </a:rPr>
+              <a:t>• 最后看复现实验指标页</a:t>
             </a:r>
           </a:p>
         </p:txBody>
@@ -6495,7 +6512,7 @@
           <p:cNvPr id="12" name="">
             <a:extLst xmlns:a="http://schemas.openxmlformats.org/drawingml/2006/main">
               <a:ext uri="{FF2B5EF4-FFF2-40B4-BE49-F238E27FC236}">
-                <a16:creationId xmlns:a16="http://schemas.microsoft.com/office/drawing/2014/main" id="{78D317A5-00CE-4C58-BA6E-A77928609A75}"/>
+                <a16:creationId xmlns:a16="http://schemas.microsoft.com/office/drawing/2014/main" id="{FEAA5349-C100-43FC-996F-ACD67A001759}"/>
               </a:ext>
             </a:extLst>
           </p:cNvPr>
@@ -6543,7 +6560,7 @@
     </p:spTree>
     <p:extLst>
       <p:ext uri="{BB962C8B-B14F-4D97-AF65-F5344CB8AC3E}">
-        <p14:creationId xmlns:p14="http://schemas.microsoft.com/office/powerpoint/2010/main" val="763448010"/>
+        <p14:creationId xmlns:p14="http://schemas.microsoft.com/office/powerpoint/2010/main" val="508891486"/>
       </p:ext>
     </p:extLst>
   </p:cSld>
@@ -6574,7 +6591,7 @@
           <p:cNvPr id="1" name="">
             <a:extLst xmlns:a="http://schemas.openxmlformats.org/drawingml/2006/main">
               <a:ext uri="{FF2B5EF4-FFF2-40B4-BE49-F238E27FC236}">
-                <a16:creationId xmlns:a16="http://schemas.microsoft.com/office/drawing/2014/main" id="{717BDD68-5AFA-4152-8665-99C0179B5F8B}"/>
+                <a16:creationId xmlns:a16="http://schemas.microsoft.com/office/drawing/2014/main" id="{1B9CC903-D553-45F6-BFBA-3B3FF2008307}"/>
               </a:ext>
             </a:extLst>
           </p:cNvPr>
@@ -6605,7 +6622,7 @@
           <p:cNvPr id="2" name="">
             <a:extLst xmlns:a="http://schemas.openxmlformats.org/drawingml/2006/main">
               <a:ext uri="{FF2B5EF4-FFF2-40B4-BE49-F238E27FC236}">
-                <a16:creationId xmlns:a16="http://schemas.microsoft.com/office/drawing/2014/main" id="{657F264D-6748-4D3F-A626-78B0FE4E729F}"/>
+                <a16:creationId xmlns:a16="http://schemas.microsoft.com/office/drawing/2014/main" id="{DC3F64A5-3D95-4689-B46F-C704C3BD1DC2}"/>
               </a:ext>
             </a:extLst>
           </p:cNvPr>
@@ -6655,7 +6672,7 @@
           <p:cNvPr id="3" name="">
             <a:extLst xmlns:a="http://schemas.openxmlformats.org/drawingml/2006/main">
               <a:ext uri="{FF2B5EF4-FFF2-40B4-BE49-F238E27FC236}">
-                <a16:creationId xmlns:a16="http://schemas.microsoft.com/office/drawing/2014/main" id="{08278883-92DA-43F4-8964-0527E87E5C03}"/>
+                <a16:creationId xmlns:a16="http://schemas.microsoft.com/office/drawing/2014/main" id="{09A8B78A-7CCE-4527-8498-301E13F2CDC6}"/>
               </a:ext>
             </a:extLst>
           </p:cNvPr>
@@ -6705,7 +6722,7 @@
           <p:cNvPr id="4" name="">
             <a:extLst xmlns:a="http://schemas.openxmlformats.org/drawingml/2006/main">
               <a:ext uri="{FF2B5EF4-FFF2-40B4-BE49-F238E27FC236}">
-                <a16:creationId xmlns:a16="http://schemas.microsoft.com/office/drawing/2014/main" id="{52F98811-DFAB-43C1-8D3A-870E5D5C54CF}"/>
+                <a16:creationId xmlns:a16="http://schemas.microsoft.com/office/drawing/2014/main" id="{DB8BF1CF-EAB5-4A9E-89BF-91F7FA04831E}"/>
               </a:ext>
             </a:extLst>
           </p:cNvPr>
@@ -6736,7 +6753,7 @@
           <p:cNvPr id="5" name="footer-15">
             <a:extLst xmlns:a="http://schemas.openxmlformats.org/drawingml/2006/main">
               <a:ext uri="{FF2B5EF4-FFF2-40B4-BE49-F238E27FC236}">
-                <a16:creationId xmlns:a16="http://schemas.microsoft.com/office/drawing/2014/main" id="{790A9335-D1A6-4CF8-8129-074AE01FA0FB}"/>
+                <a16:creationId xmlns:a16="http://schemas.microsoft.com/office/drawing/2014/main" id="{C361600F-65E3-4AAF-9261-5B41BFA0C73A}"/>
               </a:ext>
             </a:extLst>
           </p:cNvPr>
@@ -6786,7 +6803,7 @@
           <p:cNvPr id="6" name="">
             <a:extLst xmlns:a="http://schemas.openxmlformats.org/drawingml/2006/main">
               <a:ext uri="{FF2B5EF4-FFF2-40B4-BE49-F238E27FC236}">
-                <a16:creationId xmlns:a16="http://schemas.microsoft.com/office/drawing/2014/main" id="{71BB293A-30FF-423A-B801-BB7806FF62B4}"/>
+                <a16:creationId xmlns:a16="http://schemas.microsoft.com/office/drawing/2014/main" id="{B72AC51D-EA09-4929-97A0-F471671CAE78}"/>
               </a:ext>
             </a:extLst>
           </p:cNvPr>
@@ -6836,7 +6853,7 @@
           <p:cNvPr id="7" name="">
             <a:extLst xmlns:a="http://schemas.openxmlformats.org/drawingml/2006/main">
               <a:ext uri="{FF2B5EF4-FFF2-40B4-BE49-F238E27FC236}">
-                <a16:creationId xmlns:a16="http://schemas.microsoft.com/office/drawing/2014/main" id="{304A1B93-6895-4299-B28A-07BD7A7A17B7}"/>
+                <a16:creationId xmlns:a16="http://schemas.microsoft.com/office/drawing/2014/main" id="{6C9CF54C-C089-4669-9235-19098A1C7836}"/>
               </a:ext>
             </a:extLst>
           </p:cNvPr>
@@ -6937,7 +6954,7 @@
           <p:cNvPr id="8" name="">
             <a:extLst xmlns:a="http://schemas.openxmlformats.org/drawingml/2006/main">
               <a:ext uri="{FF2B5EF4-FFF2-40B4-BE49-F238E27FC236}">
-                <a16:creationId xmlns:a16="http://schemas.microsoft.com/office/drawing/2014/main" id="{649962CA-D78B-4985-9292-F9DC62B0F82C}"/>
+                <a16:creationId xmlns:a16="http://schemas.microsoft.com/office/drawing/2014/main" id="{50B66E06-4276-49BA-AA6D-2A02289ABE05}"/>
               </a:ext>
             </a:extLst>
           </p:cNvPr>
@@ -6972,7 +6989,7 @@
           <p:cNvPr id="9" name="">
             <a:extLst xmlns:a="http://schemas.openxmlformats.org/drawingml/2006/main">
               <a:ext uri="{FF2B5EF4-FFF2-40B4-BE49-F238E27FC236}">
-                <a16:creationId xmlns:a16="http://schemas.microsoft.com/office/drawing/2014/main" id="{E8A457D6-6D27-4E03-AAD0-B3D65AA6E8B0}"/>
+                <a16:creationId xmlns:a16="http://schemas.microsoft.com/office/drawing/2014/main" id="{340E1B8F-AA10-4FDA-AFC7-0D513316169E}"/>
               </a:ext>
             </a:extLst>
           </p:cNvPr>
@@ -7073,7 +7090,7 @@
           <p:cNvPr id="10" name="">
             <a:extLst xmlns:a="http://schemas.openxmlformats.org/drawingml/2006/main">
               <a:ext uri="{FF2B5EF4-FFF2-40B4-BE49-F238E27FC236}">
-                <a16:creationId xmlns:a16="http://schemas.microsoft.com/office/drawing/2014/main" id="{7F94121E-D6F3-40C0-A69C-5D32D9491F25}"/>
+                <a16:creationId xmlns:a16="http://schemas.microsoft.com/office/drawing/2014/main" id="{24617B63-D9F5-4A9F-882A-363FA9079AEA}"/>
               </a:ext>
             </a:extLst>
           </p:cNvPr>
@@ -7121,7 +7138,7 @@
     </p:spTree>
     <p:extLst>
       <p:ext uri="{BB962C8B-B14F-4D97-AF65-F5344CB8AC3E}">
-        <p14:creationId xmlns:p14="http://schemas.microsoft.com/office/powerpoint/2010/main" val="2129248427"/>
+        <p14:creationId xmlns:p14="http://schemas.microsoft.com/office/powerpoint/2010/main" val="2139314613"/>
       </p:ext>
     </p:extLst>
   </p:cSld>
@@ -7152,7 +7169,7 @@
           <p:cNvPr id="1" name="">
             <a:extLst xmlns:a="http://schemas.openxmlformats.org/drawingml/2006/main">
               <a:ext uri="{FF2B5EF4-FFF2-40B4-BE49-F238E27FC236}">
-                <a16:creationId xmlns:a16="http://schemas.microsoft.com/office/drawing/2014/main" id="{A39AF7C3-B4CD-4523-B0C8-49F434B1D750}"/>
+                <a16:creationId xmlns:a16="http://schemas.microsoft.com/office/drawing/2014/main" id="{4A9A36EB-F55F-456F-8785-F6F27B6A7296}"/>
               </a:ext>
             </a:extLst>
           </p:cNvPr>
@@ -7183,7 +7200,7 @@
           <p:cNvPr id="2" name="">
             <a:extLst xmlns:a="http://schemas.openxmlformats.org/drawingml/2006/main">
               <a:ext uri="{FF2B5EF4-FFF2-40B4-BE49-F238E27FC236}">
-                <a16:creationId xmlns:a16="http://schemas.microsoft.com/office/drawing/2014/main" id="{730967F0-5881-4762-BBCA-0EBF5952A585}"/>
+                <a16:creationId xmlns:a16="http://schemas.microsoft.com/office/drawing/2014/main" id="{0AC96E5C-B286-4474-BAF5-59F1B9F48C61}"/>
               </a:ext>
             </a:extLst>
           </p:cNvPr>
@@ -7233,7 +7250,7 @@
           <p:cNvPr id="3" name="">
             <a:extLst xmlns:a="http://schemas.openxmlformats.org/drawingml/2006/main">
               <a:ext uri="{FF2B5EF4-FFF2-40B4-BE49-F238E27FC236}">
-                <a16:creationId xmlns:a16="http://schemas.microsoft.com/office/drawing/2014/main" id="{352AA103-5DFF-48A9-B166-1DD62AA419D5}"/>
+                <a16:creationId xmlns:a16="http://schemas.microsoft.com/office/drawing/2014/main" id="{04BE7BE9-1E5D-421D-A795-984C16F0435B}"/>
               </a:ext>
             </a:extLst>
           </p:cNvPr>
@@ -7283,7 +7300,7 @@
           <p:cNvPr id="4" name="">
             <a:extLst xmlns:a="http://schemas.openxmlformats.org/drawingml/2006/main">
               <a:ext uri="{FF2B5EF4-FFF2-40B4-BE49-F238E27FC236}">
-                <a16:creationId xmlns:a16="http://schemas.microsoft.com/office/drawing/2014/main" id="{F55EB206-946F-45D7-B95C-590919B48EF3}"/>
+                <a16:creationId xmlns:a16="http://schemas.microsoft.com/office/drawing/2014/main" id="{2938DF87-0609-4F6F-91EB-990482D0C27A}"/>
               </a:ext>
             </a:extLst>
           </p:cNvPr>
@@ -7314,7 +7331,7 @@
           <p:cNvPr id="5" name="footer-2">
             <a:extLst xmlns:a="http://schemas.openxmlformats.org/drawingml/2006/main">
               <a:ext uri="{FF2B5EF4-FFF2-40B4-BE49-F238E27FC236}">
-                <a16:creationId xmlns:a16="http://schemas.microsoft.com/office/drawing/2014/main" id="{70102B1A-5EF0-4E47-8965-F268A755BA74}"/>
+                <a16:creationId xmlns:a16="http://schemas.microsoft.com/office/drawing/2014/main" id="{27157065-F8C8-4023-9ABC-4C2007CE3B82}"/>
               </a:ext>
             </a:extLst>
           </p:cNvPr>
@@ -7364,7 +7381,7 @@
           <p:cNvPr id="6" name="">
             <a:extLst xmlns:a="http://schemas.openxmlformats.org/drawingml/2006/main">
               <a:ext uri="{FF2B5EF4-FFF2-40B4-BE49-F238E27FC236}">
-                <a16:creationId xmlns:a16="http://schemas.microsoft.com/office/drawing/2014/main" id="{63AF9B17-AB83-44B2-834E-8813C895B133}"/>
+                <a16:creationId xmlns:a16="http://schemas.microsoft.com/office/drawing/2014/main" id="{A4C12CBF-7740-44B9-82A3-B8620DE62E91}"/>
               </a:ext>
             </a:extLst>
           </p:cNvPr>
@@ -7399,7 +7416,7 @@
           <p:cNvPr id="7" name="">
             <a:extLst xmlns:a="http://schemas.openxmlformats.org/drawingml/2006/main">
               <a:ext uri="{FF2B5EF4-FFF2-40B4-BE49-F238E27FC236}">
-                <a16:creationId xmlns:a16="http://schemas.microsoft.com/office/drawing/2014/main" id="{3C1970AD-8A42-4E5B-8DB7-49850BAA2549}"/>
+                <a16:creationId xmlns:a16="http://schemas.microsoft.com/office/drawing/2014/main" id="{F743A18E-9A8D-43B4-B51C-B5387AC46B9E}"/>
               </a:ext>
             </a:extLst>
           </p:cNvPr>
@@ -7430,7 +7447,7 @@
           <p:cNvPr id="8" name="">
             <a:extLst xmlns:a="http://schemas.openxmlformats.org/drawingml/2006/main">
               <a:ext uri="{FF2B5EF4-FFF2-40B4-BE49-F238E27FC236}">
-                <a16:creationId xmlns:a16="http://schemas.microsoft.com/office/drawing/2014/main" id="{7E7A3A8C-C372-443D-810C-1747E9589294}"/>
+                <a16:creationId xmlns:a16="http://schemas.microsoft.com/office/drawing/2014/main" id="{D29E4247-C8AE-4F1F-BF75-4410B0817D55}"/>
               </a:ext>
             </a:extLst>
           </p:cNvPr>
@@ -7480,7 +7497,7 @@
           <p:cNvPr id="9" name="">
             <a:extLst xmlns:a="http://schemas.openxmlformats.org/drawingml/2006/main">
               <a:ext uri="{FF2B5EF4-FFF2-40B4-BE49-F238E27FC236}">
-                <a16:creationId xmlns:a16="http://schemas.microsoft.com/office/drawing/2014/main" id="{B76E6303-BD55-4942-AD85-2F038141C93C}"/>
+                <a16:creationId xmlns:a16="http://schemas.microsoft.com/office/drawing/2014/main" id="{F3DF7773-7CBF-4900-9C95-B7FAC4F8E599}"/>
               </a:ext>
             </a:extLst>
           </p:cNvPr>
@@ -7530,7 +7547,7 @@
           <p:cNvPr id="10" name="">
             <a:extLst xmlns:a="http://schemas.openxmlformats.org/drawingml/2006/main">
               <a:ext uri="{FF2B5EF4-FFF2-40B4-BE49-F238E27FC236}">
-                <a16:creationId xmlns:a16="http://schemas.microsoft.com/office/drawing/2014/main" id="{263A669B-DD28-4633-8A73-862B73D180CB}"/>
+                <a16:creationId xmlns:a16="http://schemas.microsoft.com/office/drawing/2014/main" id="{A3DEB8C0-308D-4733-AAB1-4D7724EDF327}"/>
               </a:ext>
             </a:extLst>
           </p:cNvPr>
@@ -7565,7 +7582,7 @@
           <p:cNvPr id="11" name="">
             <a:extLst xmlns:a="http://schemas.openxmlformats.org/drawingml/2006/main">
               <a:ext uri="{FF2B5EF4-FFF2-40B4-BE49-F238E27FC236}">
-                <a16:creationId xmlns:a16="http://schemas.microsoft.com/office/drawing/2014/main" id="{336B5F9E-829E-4E38-965C-150A53DB7228}"/>
+                <a16:creationId xmlns:a16="http://schemas.microsoft.com/office/drawing/2014/main" id="{1851C05F-19FE-421A-8368-0730CE38F421}"/>
               </a:ext>
             </a:extLst>
           </p:cNvPr>
@@ -7596,7 +7613,7 @@
           <p:cNvPr id="12" name="">
             <a:extLst xmlns:a="http://schemas.openxmlformats.org/drawingml/2006/main">
               <a:ext uri="{FF2B5EF4-FFF2-40B4-BE49-F238E27FC236}">
-                <a16:creationId xmlns:a16="http://schemas.microsoft.com/office/drawing/2014/main" id="{45B2E945-B681-4826-AADA-A0797E1DB6FD}"/>
+                <a16:creationId xmlns:a16="http://schemas.microsoft.com/office/drawing/2014/main" id="{28687857-F44A-4F38-A2F8-9FD682F6BDBF}"/>
               </a:ext>
             </a:extLst>
           </p:cNvPr>
@@ -7646,7 +7663,7 @@
           <p:cNvPr id="13" name="">
             <a:extLst xmlns:a="http://schemas.openxmlformats.org/drawingml/2006/main">
               <a:ext uri="{FF2B5EF4-FFF2-40B4-BE49-F238E27FC236}">
-                <a16:creationId xmlns:a16="http://schemas.microsoft.com/office/drawing/2014/main" id="{5C403B77-DDD3-49E7-893F-B78D28C56CF8}"/>
+                <a16:creationId xmlns:a16="http://schemas.microsoft.com/office/drawing/2014/main" id="{D2157DE9-9415-4D00-9D22-674B922D034E}"/>
               </a:ext>
             </a:extLst>
           </p:cNvPr>
@@ -7696,7 +7713,7 @@
           <p:cNvPr id="14" name="">
             <a:extLst xmlns:a="http://schemas.openxmlformats.org/drawingml/2006/main">
               <a:ext uri="{FF2B5EF4-FFF2-40B4-BE49-F238E27FC236}">
-                <a16:creationId xmlns:a16="http://schemas.microsoft.com/office/drawing/2014/main" id="{B2A68C18-F816-4A77-92DE-8266FE1C0CC6}"/>
+                <a16:creationId xmlns:a16="http://schemas.microsoft.com/office/drawing/2014/main" id="{F93FFED2-4CEB-4183-8B58-AABE0E4BA07D}"/>
               </a:ext>
             </a:extLst>
           </p:cNvPr>
@@ -7731,7 +7748,7 @@
           <p:cNvPr id="15" name="">
             <a:extLst xmlns:a="http://schemas.openxmlformats.org/drawingml/2006/main">
               <a:ext uri="{FF2B5EF4-FFF2-40B4-BE49-F238E27FC236}">
-                <a16:creationId xmlns:a16="http://schemas.microsoft.com/office/drawing/2014/main" id="{11E1B3C7-8B02-4FFC-9D85-43F2E8A24362}"/>
+                <a16:creationId xmlns:a16="http://schemas.microsoft.com/office/drawing/2014/main" id="{D5F886BA-79E7-4DA2-86CC-EAE8EA2B1804}"/>
               </a:ext>
             </a:extLst>
           </p:cNvPr>
@@ -7762,7 +7779,7 @@
           <p:cNvPr id="16" name="">
             <a:extLst xmlns:a="http://schemas.openxmlformats.org/drawingml/2006/main">
               <a:ext uri="{FF2B5EF4-FFF2-40B4-BE49-F238E27FC236}">
-                <a16:creationId xmlns:a16="http://schemas.microsoft.com/office/drawing/2014/main" id="{39E8CAAB-3843-462C-B079-2B5F890C197A}"/>
+                <a16:creationId xmlns:a16="http://schemas.microsoft.com/office/drawing/2014/main" id="{59A4BBDA-561C-4F72-9A43-7D2A4077230E}"/>
               </a:ext>
             </a:extLst>
           </p:cNvPr>
@@ -7812,7 +7829,7 @@
           <p:cNvPr id="17" name="">
             <a:extLst xmlns:a="http://schemas.openxmlformats.org/drawingml/2006/main">
               <a:ext uri="{FF2B5EF4-FFF2-40B4-BE49-F238E27FC236}">
-                <a16:creationId xmlns:a16="http://schemas.microsoft.com/office/drawing/2014/main" id="{D4F3B8F9-7442-4F6A-9085-55F948F04064}"/>
+                <a16:creationId xmlns:a16="http://schemas.microsoft.com/office/drawing/2014/main" id="{28156A96-C52B-4DE9-B2B5-3259175C6A73}"/>
               </a:ext>
             </a:extLst>
           </p:cNvPr>
@@ -7862,7 +7879,7 @@
           <p:cNvPr id="18" name="">
             <a:extLst xmlns:a="http://schemas.openxmlformats.org/drawingml/2006/main">
               <a:ext uri="{FF2B5EF4-FFF2-40B4-BE49-F238E27FC236}">
-                <a16:creationId xmlns:a16="http://schemas.microsoft.com/office/drawing/2014/main" id="{7CE42AF0-E80E-4977-ADBD-50AEBBAEE625}"/>
+                <a16:creationId xmlns:a16="http://schemas.microsoft.com/office/drawing/2014/main" id="{D3328F53-EE32-478C-9A7F-6BB9F5373D8F}"/>
               </a:ext>
             </a:extLst>
           </p:cNvPr>
@@ -7912,7 +7929,7 @@
           <p:cNvPr id="19" name="">
             <a:extLst xmlns:a="http://schemas.openxmlformats.org/drawingml/2006/main">
               <a:ext uri="{FF2B5EF4-FFF2-40B4-BE49-F238E27FC236}">
-                <a16:creationId xmlns:a16="http://schemas.microsoft.com/office/drawing/2014/main" id="{BFA8BD1C-33EB-45FB-B737-A1A5AC12DFA4}"/>
+                <a16:creationId xmlns:a16="http://schemas.microsoft.com/office/drawing/2014/main" id="{3EAFBC4C-8840-4032-90FB-F95DCB9A8C83}"/>
               </a:ext>
             </a:extLst>
           </p:cNvPr>
@@ -8011,7 +8028,7 @@
     </p:spTree>
     <p:extLst>
       <p:ext uri="{BB962C8B-B14F-4D97-AF65-F5344CB8AC3E}">
-        <p14:creationId xmlns:p14="http://schemas.microsoft.com/office/powerpoint/2010/main" val="1038769072"/>
+        <p14:creationId xmlns:p14="http://schemas.microsoft.com/office/powerpoint/2010/main" val="1345072318"/>
       </p:ext>
     </p:extLst>
   </p:cSld>
@@ -8042,7 +8059,7 @@
           <p:cNvPr id="1" name="">
             <a:extLst xmlns:a="http://schemas.openxmlformats.org/drawingml/2006/main">
               <a:ext uri="{FF2B5EF4-FFF2-40B4-BE49-F238E27FC236}">
-                <a16:creationId xmlns:a16="http://schemas.microsoft.com/office/drawing/2014/main" id="{175E6B3B-9B04-444C-8811-7796E38823FA}"/>
+                <a16:creationId xmlns:a16="http://schemas.microsoft.com/office/drawing/2014/main" id="{DF6CD78B-75AD-450E-9C71-B724AFF936DB}"/>
               </a:ext>
             </a:extLst>
           </p:cNvPr>
@@ -8073,7 +8090,7 @@
           <p:cNvPr id="2" name="">
             <a:extLst xmlns:a="http://schemas.openxmlformats.org/drawingml/2006/main">
               <a:ext uri="{FF2B5EF4-FFF2-40B4-BE49-F238E27FC236}">
-                <a16:creationId xmlns:a16="http://schemas.microsoft.com/office/drawing/2014/main" id="{97A701B1-8B2C-4EAF-8D6F-4E5B22E9E37F}"/>
+                <a16:creationId xmlns:a16="http://schemas.microsoft.com/office/drawing/2014/main" id="{E4393594-2D6E-4B03-B79E-533BB066231D}"/>
               </a:ext>
             </a:extLst>
           </p:cNvPr>
@@ -8123,7 +8140,7 @@
           <p:cNvPr id="3" name="">
             <a:extLst xmlns:a="http://schemas.openxmlformats.org/drawingml/2006/main">
               <a:ext uri="{FF2B5EF4-FFF2-40B4-BE49-F238E27FC236}">
-                <a16:creationId xmlns:a16="http://schemas.microsoft.com/office/drawing/2014/main" id="{73DB423F-A334-498D-BFD6-C4CD1C939A65}"/>
+                <a16:creationId xmlns:a16="http://schemas.microsoft.com/office/drawing/2014/main" id="{A7602DBB-5D3C-4FFF-9AB0-925FE4E49A0C}"/>
               </a:ext>
             </a:extLst>
           </p:cNvPr>
@@ -8173,7 +8190,7 @@
           <p:cNvPr id="4" name="">
             <a:extLst xmlns:a="http://schemas.openxmlformats.org/drawingml/2006/main">
               <a:ext uri="{FF2B5EF4-FFF2-40B4-BE49-F238E27FC236}">
-                <a16:creationId xmlns:a16="http://schemas.microsoft.com/office/drawing/2014/main" id="{EEED3EF5-6A8D-4C14-B1A5-48EFDF04B656}"/>
+                <a16:creationId xmlns:a16="http://schemas.microsoft.com/office/drawing/2014/main" id="{C84D061D-C613-4C50-B164-D9DD8C44C46D}"/>
               </a:ext>
             </a:extLst>
           </p:cNvPr>
@@ -8204,7 +8221,7 @@
           <p:cNvPr id="5" name="footer-3">
             <a:extLst xmlns:a="http://schemas.openxmlformats.org/drawingml/2006/main">
               <a:ext uri="{FF2B5EF4-FFF2-40B4-BE49-F238E27FC236}">
-                <a16:creationId xmlns:a16="http://schemas.microsoft.com/office/drawing/2014/main" id="{993F9CEC-2574-4782-8200-1AFE33D60833}"/>
+                <a16:creationId xmlns:a16="http://schemas.microsoft.com/office/drawing/2014/main" id="{512A6F6D-09BF-4DA4-9535-23A0180F21D0}"/>
               </a:ext>
             </a:extLst>
           </p:cNvPr>
@@ -8254,7 +8271,7 @@
           <p:cNvPr id="6" name="">
             <a:extLst xmlns:a="http://schemas.openxmlformats.org/drawingml/2006/main">
               <a:ext uri="{FF2B5EF4-FFF2-40B4-BE49-F238E27FC236}">
-                <a16:creationId xmlns:a16="http://schemas.microsoft.com/office/drawing/2014/main" id="{0B9F6549-95B7-43C1-BE5B-A0C3341E9C08}"/>
+                <a16:creationId xmlns:a16="http://schemas.microsoft.com/office/drawing/2014/main" id="{A15A1F47-5055-4D02-9EAB-BC4779BFC1D9}"/>
               </a:ext>
             </a:extLst>
           </p:cNvPr>
@@ -8304,7 +8321,7 @@
           <p:cNvPr id="7" name="">
             <a:extLst xmlns:a="http://schemas.openxmlformats.org/drawingml/2006/main">
               <a:ext uri="{FF2B5EF4-FFF2-40B4-BE49-F238E27FC236}">
-                <a16:creationId xmlns:a16="http://schemas.microsoft.com/office/drawing/2014/main" id="{F51D64AF-34A0-4BBE-AB39-4A4A11D2CE9B}"/>
+                <a16:creationId xmlns:a16="http://schemas.microsoft.com/office/drawing/2014/main" id="{903E4CF3-AD94-4F55-9C17-033016C7F12D}"/>
               </a:ext>
             </a:extLst>
           </p:cNvPr>
@@ -8339,7 +8356,7 @@
           <p:cNvPr id="8" name="">
             <a:extLst xmlns:a="http://schemas.openxmlformats.org/drawingml/2006/main">
               <a:ext uri="{FF2B5EF4-FFF2-40B4-BE49-F238E27FC236}">
-                <a16:creationId xmlns:a16="http://schemas.microsoft.com/office/drawing/2014/main" id="{20DBD54F-23EF-4114-B704-5E841DC5FFB5}"/>
+                <a16:creationId xmlns:a16="http://schemas.microsoft.com/office/drawing/2014/main" id="{DE328679-A2C8-4376-8844-EF012679F68C}"/>
               </a:ext>
             </a:extLst>
           </p:cNvPr>
@@ -8423,7 +8440,7 @@
           <p:cNvPr id="9" name="">
             <a:extLst xmlns:a="http://schemas.openxmlformats.org/drawingml/2006/main">
               <a:ext uri="{FF2B5EF4-FFF2-40B4-BE49-F238E27FC236}">
-                <a16:creationId xmlns:a16="http://schemas.microsoft.com/office/drawing/2014/main" id="{5CA05C5B-4F5F-48B8-B857-FA3873F0429B}"/>
+                <a16:creationId xmlns:a16="http://schemas.microsoft.com/office/drawing/2014/main" id="{CCA99681-C970-416A-B68A-AA6B2E9B9FD7}"/>
               </a:ext>
             </a:extLst>
           </p:cNvPr>
@@ -8473,7 +8490,7 @@
           <p:cNvPr id="10" name="">
             <a:extLst xmlns:a="http://schemas.openxmlformats.org/drawingml/2006/main">
               <a:ext uri="{FF2B5EF4-FFF2-40B4-BE49-F238E27FC236}">
-                <a16:creationId xmlns:a16="http://schemas.microsoft.com/office/drawing/2014/main" id="{2B37374E-C64E-4390-A18B-1196061C0854}"/>
+                <a16:creationId xmlns:a16="http://schemas.microsoft.com/office/drawing/2014/main" id="{0AF0BD8D-C5B0-42E7-85A9-597901FA86B4}"/>
               </a:ext>
             </a:extLst>
           </p:cNvPr>
@@ -8508,7 +8525,7 @@
           <p:cNvPr id="11" name="">
             <a:extLst xmlns:a="http://schemas.openxmlformats.org/drawingml/2006/main">
               <a:ext uri="{FF2B5EF4-FFF2-40B4-BE49-F238E27FC236}">
-                <a16:creationId xmlns:a16="http://schemas.microsoft.com/office/drawing/2014/main" id="{C4AC5553-43DF-4420-98C6-A8134D1B2D55}"/>
+                <a16:creationId xmlns:a16="http://schemas.microsoft.com/office/drawing/2014/main" id="{D0782402-4BD2-446B-8F0A-608B435CFAB4}"/>
               </a:ext>
             </a:extLst>
           </p:cNvPr>
@@ -8609,7 +8626,7 @@
           <p:cNvPr id="12" name="">
             <a:extLst xmlns:a="http://schemas.openxmlformats.org/drawingml/2006/main">
               <a:ext uri="{FF2B5EF4-FFF2-40B4-BE49-F238E27FC236}">
-                <a16:creationId xmlns:a16="http://schemas.microsoft.com/office/drawing/2014/main" id="{0AA409DB-0FD2-4DE1-A4B2-D5AA723D074F}"/>
+                <a16:creationId xmlns:a16="http://schemas.microsoft.com/office/drawing/2014/main" id="{57BE3DFE-AC49-4072-AD9D-EFFCE1A8413E}"/>
               </a:ext>
             </a:extLst>
           </p:cNvPr>
@@ -8657,7 +8674,7 @@
     </p:spTree>
     <p:extLst>
       <p:ext uri="{BB962C8B-B14F-4D97-AF65-F5344CB8AC3E}">
-        <p14:creationId xmlns:p14="http://schemas.microsoft.com/office/powerpoint/2010/main" val="1104443013"/>
+        <p14:creationId xmlns:p14="http://schemas.microsoft.com/office/powerpoint/2010/main" val="552528777"/>
       </p:ext>
     </p:extLst>
   </p:cSld>
@@ -8688,7 +8705,7 @@
           <p:cNvPr id="1" name="">
             <a:extLst xmlns:a="http://schemas.openxmlformats.org/drawingml/2006/main">
               <a:ext uri="{FF2B5EF4-FFF2-40B4-BE49-F238E27FC236}">
-                <a16:creationId xmlns:a16="http://schemas.microsoft.com/office/drawing/2014/main" id="{8129E53D-34D0-48F2-B0B8-604913E4173B}"/>
+                <a16:creationId xmlns:a16="http://schemas.microsoft.com/office/drawing/2014/main" id="{39388BAF-46EF-43A6-8091-FAEC4D1D8042}"/>
               </a:ext>
             </a:extLst>
           </p:cNvPr>
@@ -8719,7 +8736,7 @@
           <p:cNvPr id="2" name="">
             <a:extLst xmlns:a="http://schemas.openxmlformats.org/drawingml/2006/main">
               <a:ext uri="{FF2B5EF4-FFF2-40B4-BE49-F238E27FC236}">
-                <a16:creationId xmlns:a16="http://schemas.microsoft.com/office/drawing/2014/main" id="{F2786D49-C370-4284-B311-127791590208}"/>
+                <a16:creationId xmlns:a16="http://schemas.microsoft.com/office/drawing/2014/main" id="{8B3E959D-4A6C-41A7-A994-44EAE4432B85}"/>
               </a:ext>
             </a:extLst>
           </p:cNvPr>
@@ -8769,7 +8786,7 @@
           <p:cNvPr id="3" name="">
             <a:extLst xmlns:a="http://schemas.openxmlformats.org/drawingml/2006/main">
               <a:ext uri="{FF2B5EF4-FFF2-40B4-BE49-F238E27FC236}">
-                <a16:creationId xmlns:a16="http://schemas.microsoft.com/office/drawing/2014/main" id="{0D46C5DA-E368-401C-A5B4-B9E0583842A5}"/>
+                <a16:creationId xmlns:a16="http://schemas.microsoft.com/office/drawing/2014/main" id="{42DD82D2-8D9B-4E30-B964-E6197CA80BCC}"/>
               </a:ext>
             </a:extLst>
           </p:cNvPr>
@@ -8819,7 +8836,7 @@
           <p:cNvPr id="4" name="">
             <a:extLst xmlns:a="http://schemas.openxmlformats.org/drawingml/2006/main">
               <a:ext uri="{FF2B5EF4-FFF2-40B4-BE49-F238E27FC236}">
-                <a16:creationId xmlns:a16="http://schemas.microsoft.com/office/drawing/2014/main" id="{3A7D0C01-5D36-4DFE-9FBC-9EDFB00434A1}"/>
+                <a16:creationId xmlns:a16="http://schemas.microsoft.com/office/drawing/2014/main" id="{E223638E-5B72-46CF-A8FA-DBE33BC4253D}"/>
               </a:ext>
             </a:extLst>
           </p:cNvPr>
@@ -8850,7 +8867,7 @@
           <p:cNvPr id="5" name="footer-4">
             <a:extLst xmlns:a="http://schemas.openxmlformats.org/drawingml/2006/main">
               <a:ext uri="{FF2B5EF4-FFF2-40B4-BE49-F238E27FC236}">
-                <a16:creationId xmlns:a16="http://schemas.microsoft.com/office/drawing/2014/main" id="{F966AED8-9EB4-454B-9799-6BC08ADFDC9D}"/>
+                <a16:creationId xmlns:a16="http://schemas.microsoft.com/office/drawing/2014/main" id="{C2B11BD2-FCFB-4C92-BF50-D49AA8B429BE}"/>
               </a:ext>
             </a:extLst>
           </p:cNvPr>
@@ -8900,7 +8917,7 @@
           <p:cNvPr id="6" name="">
             <a:extLst xmlns:a="http://schemas.openxmlformats.org/drawingml/2006/main">
               <a:ext uri="{FF2B5EF4-FFF2-40B4-BE49-F238E27FC236}">
-                <a16:creationId xmlns:a16="http://schemas.microsoft.com/office/drawing/2014/main" id="{8396A61B-453F-4DD3-97FA-0E52021A8A26}"/>
+                <a16:creationId xmlns:a16="http://schemas.microsoft.com/office/drawing/2014/main" id="{4B015016-44DB-42EC-86F0-3CF694FD4A10}"/>
               </a:ext>
             </a:extLst>
           </p:cNvPr>
@@ -8935,7 +8952,7 @@
           <p:cNvPr id="7" name="">
             <a:extLst xmlns:a="http://schemas.openxmlformats.org/drawingml/2006/main">
               <a:ext uri="{FF2B5EF4-FFF2-40B4-BE49-F238E27FC236}">
-                <a16:creationId xmlns:a16="http://schemas.microsoft.com/office/drawing/2014/main" id="{407BCFF4-791F-4635-8835-74EF8673DBE5}"/>
+                <a16:creationId xmlns:a16="http://schemas.microsoft.com/office/drawing/2014/main" id="{A8650753-5AFE-47CF-BC69-8E4BD4E65C89}"/>
               </a:ext>
             </a:extLst>
           </p:cNvPr>
@@ -8966,7 +8983,7 @@
           <p:cNvPr id="8" name="">
             <a:extLst xmlns:a="http://schemas.openxmlformats.org/drawingml/2006/main">
               <a:ext uri="{FF2B5EF4-FFF2-40B4-BE49-F238E27FC236}">
-                <a16:creationId xmlns:a16="http://schemas.microsoft.com/office/drawing/2014/main" id="{CFC8D5C6-6583-457E-A3F7-AE7406D22745}"/>
+                <a16:creationId xmlns:a16="http://schemas.microsoft.com/office/drawing/2014/main" id="{38A24776-4D9E-422C-94E5-74C86A75C33A}"/>
               </a:ext>
             </a:extLst>
           </p:cNvPr>
@@ -9016,7 +9033,7 @@
           <p:cNvPr id="9" name="">
             <a:extLst xmlns:a="http://schemas.openxmlformats.org/drawingml/2006/main">
               <a:ext uri="{FF2B5EF4-FFF2-40B4-BE49-F238E27FC236}">
-                <a16:creationId xmlns:a16="http://schemas.microsoft.com/office/drawing/2014/main" id="{B13B30F8-F72E-4B32-BBAD-0A179DBF19C1}"/>
+                <a16:creationId xmlns:a16="http://schemas.microsoft.com/office/drawing/2014/main" id="{B10B4947-4586-48E5-AA1C-7B5018A22012}"/>
               </a:ext>
             </a:extLst>
           </p:cNvPr>
@@ -9066,7 +9083,7 @@
           <p:cNvPr id="10" name="">
             <a:extLst xmlns:a="http://schemas.openxmlformats.org/drawingml/2006/main">
               <a:ext uri="{FF2B5EF4-FFF2-40B4-BE49-F238E27FC236}">
-                <a16:creationId xmlns:a16="http://schemas.microsoft.com/office/drawing/2014/main" id="{BFD3E08A-E44A-43E0-9300-BED5299ED417}"/>
+                <a16:creationId xmlns:a16="http://schemas.microsoft.com/office/drawing/2014/main" id="{F311F1F1-0A49-46DE-A50F-C6B5E0DA7646}"/>
               </a:ext>
             </a:extLst>
           </p:cNvPr>
@@ -9101,7 +9118,7 @@
           <p:cNvPr id="11" name="">
             <a:extLst xmlns:a="http://schemas.openxmlformats.org/drawingml/2006/main">
               <a:ext uri="{FF2B5EF4-FFF2-40B4-BE49-F238E27FC236}">
-                <a16:creationId xmlns:a16="http://schemas.microsoft.com/office/drawing/2014/main" id="{1AB6E01E-FC63-41E0-B6FA-078454C6BF24}"/>
+                <a16:creationId xmlns:a16="http://schemas.microsoft.com/office/drawing/2014/main" id="{1329CFFD-9C4E-4076-8E52-E7E4798B4A46}"/>
               </a:ext>
             </a:extLst>
           </p:cNvPr>
@@ -9132,7 +9149,7 @@
           <p:cNvPr id="12" name="">
             <a:extLst xmlns:a="http://schemas.openxmlformats.org/drawingml/2006/main">
               <a:ext uri="{FF2B5EF4-FFF2-40B4-BE49-F238E27FC236}">
-                <a16:creationId xmlns:a16="http://schemas.microsoft.com/office/drawing/2014/main" id="{3C81BDEF-9061-4604-B7B8-ACC248344112}"/>
+                <a16:creationId xmlns:a16="http://schemas.microsoft.com/office/drawing/2014/main" id="{EEF378FE-7074-4D73-9BAB-F36003B695DB}"/>
               </a:ext>
             </a:extLst>
           </p:cNvPr>
@@ -9182,7 +9199,7 @@
           <p:cNvPr id="13" name="">
             <a:extLst xmlns:a="http://schemas.openxmlformats.org/drawingml/2006/main">
               <a:ext uri="{FF2B5EF4-FFF2-40B4-BE49-F238E27FC236}">
-                <a16:creationId xmlns:a16="http://schemas.microsoft.com/office/drawing/2014/main" id="{69064768-0F5E-4B43-9ED3-D3821BD25056}"/>
+                <a16:creationId xmlns:a16="http://schemas.microsoft.com/office/drawing/2014/main" id="{2CE3BD4C-D9ED-446D-9434-10060B3B31FB}"/>
               </a:ext>
             </a:extLst>
           </p:cNvPr>
@@ -9232,7 +9249,7 @@
           <p:cNvPr id="14" name="">
             <a:extLst xmlns:a="http://schemas.openxmlformats.org/drawingml/2006/main">
               <a:ext uri="{FF2B5EF4-FFF2-40B4-BE49-F238E27FC236}">
-                <a16:creationId xmlns:a16="http://schemas.microsoft.com/office/drawing/2014/main" id="{C27E367A-64A1-47A3-A310-C32133F2D52C}"/>
+                <a16:creationId xmlns:a16="http://schemas.microsoft.com/office/drawing/2014/main" id="{42A0EA17-C24F-4797-8F03-49E00509A974}"/>
               </a:ext>
             </a:extLst>
           </p:cNvPr>
@@ -9267,7 +9284,7 @@
           <p:cNvPr id="15" name="">
             <a:extLst xmlns:a="http://schemas.openxmlformats.org/drawingml/2006/main">
               <a:ext uri="{FF2B5EF4-FFF2-40B4-BE49-F238E27FC236}">
-                <a16:creationId xmlns:a16="http://schemas.microsoft.com/office/drawing/2014/main" id="{38FAED54-B956-45CC-B784-7E95A918B3D4}"/>
+                <a16:creationId xmlns:a16="http://schemas.microsoft.com/office/drawing/2014/main" id="{D9732C08-933F-4A6F-B4F8-FD7CBBC583B0}"/>
               </a:ext>
             </a:extLst>
           </p:cNvPr>
@@ -9298,7 +9315,7 @@
           <p:cNvPr id="16" name="">
             <a:extLst xmlns:a="http://schemas.openxmlformats.org/drawingml/2006/main">
               <a:ext uri="{FF2B5EF4-FFF2-40B4-BE49-F238E27FC236}">
-                <a16:creationId xmlns:a16="http://schemas.microsoft.com/office/drawing/2014/main" id="{B62CAA56-569D-4901-9A4F-7905FF6A51E7}"/>
+                <a16:creationId xmlns:a16="http://schemas.microsoft.com/office/drawing/2014/main" id="{82288E88-513B-41DE-BCA9-081F02242C1C}"/>
               </a:ext>
             </a:extLst>
           </p:cNvPr>
@@ -9348,7 +9365,7 @@
           <p:cNvPr id="17" name="">
             <a:extLst xmlns:a="http://schemas.openxmlformats.org/drawingml/2006/main">
               <a:ext uri="{FF2B5EF4-FFF2-40B4-BE49-F238E27FC236}">
-                <a16:creationId xmlns:a16="http://schemas.microsoft.com/office/drawing/2014/main" id="{A66D55D5-2398-4637-AE7C-064479374BF9}"/>
+                <a16:creationId xmlns:a16="http://schemas.microsoft.com/office/drawing/2014/main" id="{76D792C8-FB36-4616-B9C8-96AA06C442F8}"/>
               </a:ext>
             </a:extLst>
           </p:cNvPr>
@@ -9398,7 +9415,7 @@
           <p:cNvPr id="18" name="">
             <a:extLst xmlns:a="http://schemas.openxmlformats.org/drawingml/2006/main">
               <a:ext uri="{FF2B5EF4-FFF2-40B4-BE49-F238E27FC236}">
-                <a16:creationId xmlns:a16="http://schemas.microsoft.com/office/drawing/2014/main" id="{89E46A4D-1DC4-4292-BDFE-052B6B96B32F}"/>
+                <a16:creationId xmlns:a16="http://schemas.microsoft.com/office/drawing/2014/main" id="{D5A42C4B-4CA7-438C-B823-B7CFA102695A}"/>
               </a:ext>
             </a:extLst>
           </p:cNvPr>
@@ -9446,7 +9463,7 @@
     </p:spTree>
     <p:extLst>
       <p:ext uri="{BB962C8B-B14F-4D97-AF65-F5344CB8AC3E}">
-        <p14:creationId xmlns:p14="http://schemas.microsoft.com/office/powerpoint/2010/main" val="304718044"/>
+        <p14:creationId xmlns:p14="http://schemas.microsoft.com/office/powerpoint/2010/main" val="1213431920"/>
       </p:ext>
     </p:extLst>
   </p:cSld>
@@ -9477,7 +9494,7 @@
           <p:cNvPr id="1" name="">
             <a:extLst xmlns:a="http://schemas.openxmlformats.org/drawingml/2006/main">
               <a:ext uri="{FF2B5EF4-FFF2-40B4-BE49-F238E27FC236}">
-                <a16:creationId xmlns:a16="http://schemas.microsoft.com/office/drawing/2014/main" id="{91BB32A2-B8F8-477C-8134-A02CF95C5FAE}"/>
+                <a16:creationId xmlns:a16="http://schemas.microsoft.com/office/drawing/2014/main" id="{FE7AA83E-BE42-4202-AA30-87D75CE8BAA3}"/>
               </a:ext>
             </a:extLst>
           </p:cNvPr>
@@ -9508,7 +9525,7 @@
           <p:cNvPr id="2" name="">
             <a:extLst xmlns:a="http://schemas.openxmlformats.org/drawingml/2006/main">
               <a:ext uri="{FF2B5EF4-FFF2-40B4-BE49-F238E27FC236}">
-                <a16:creationId xmlns:a16="http://schemas.microsoft.com/office/drawing/2014/main" id="{3A664464-20B4-40CB-AF09-21A1C7370900}"/>
+                <a16:creationId xmlns:a16="http://schemas.microsoft.com/office/drawing/2014/main" id="{209BD5D2-A090-4C91-8B50-65733EB0D6E8}"/>
               </a:ext>
             </a:extLst>
           </p:cNvPr>
@@ -9558,7 +9575,7 @@
           <p:cNvPr id="3" name="">
             <a:extLst xmlns:a="http://schemas.openxmlformats.org/drawingml/2006/main">
               <a:ext uri="{FF2B5EF4-FFF2-40B4-BE49-F238E27FC236}">
-                <a16:creationId xmlns:a16="http://schemas.microsoft.com/office/drawing/2014/main" id="{07711D40-DAA6-4A72-B23E-20EFE686B7BD}"/>
+                <a16:creationId xmlns:a16="http://schemas.microsoft.com/office/drawing/2014/main" id="{2969A243-E575-4B13-AE1E-4A71A8B7501E}"/>
               </a:ext>
             </a:extLst>
           </p:cNvPr>
@@ -9608,7 +9625,7 @@
           <p:cNvPr id="4" name="">
             <a:extLst xmlns:a="http://schemas.openxmlformats.org/drawingml/2006/main">
               <a:ext uri="{FF2B5EF4-FFF2-40B4-BE49-F238E27FC236}">
-                <a16:creationId xmlns:a16="http://schemas.microsoft.com/office/drawing/2014/main" id="{CAEA8CF8-799F-47A7-9616-CA27B013A5A9}"/>
+                <a16:creationId xmlns:a16="http://schemas.microsoft.com/office/drawing/2014/main" id="{FEFED1F9-6953-43E4-AAF5-4650754C0129}"/>
               </a:ext>
             </a:extLst>
           </p:cNvPr>
@@ -9639,7 +9656,7 @@
           <p:cNvPr id="5" name="footer-5">
             <a:extLst xmlns:a="http://schemas.openxmlformats.org/drawingml/2006/main">
               <a:ext uri="{FF2B5EF4-FFF2-40B4-BE49-F238E27FC236}">
-                <a16:creationId xmlns:a16="http://schemas.microsoft.com/office/drawing/2014/main" id="{51DED0B6-3D62-4065-B483-2A6AE4162AF9}"/>
+                <a16:creationId xmlns:a16="http://schemas.microsoft.com/office/drawing/2014/main" id="{AADF0D0C-BFE7-4583-84DB-EF1D40D7AE9A}"/>
               </a:ext>
             </a:extLst>
           </p:cNvPr>
@@ -9689,7 +9706,7 @@
           <p:cNvPr id="6" name="">
             <a:extLst xmlns:a="http://schemas.openxmlformats.org/drawingml/2006/main">
               <a:ext uri="{FF2B5EF4-FFF2-40B4-BE49-F238E27FC236}">
-                <a16:creationId xmlns:a16="http://schemas.microsoft.com/office/drawing/2014/main" id="{A8EAABDB-7574-4E2C-9EA0-32149F1B9FF3}"/>
+                <a16:creationId xmlns:a16="http://schemas.microsoft.com/office/drawing/2014/main" id="{6F990245-B0A3-4428-B466-93CBD8FB5B55}"/>
               </a:ext>
             </a:extLst>
           </p:cNvPr>
@@ -9739,7 +9756,7 @@
           <p:cNvPr id="7" name="">
             <a:extLst xmlns:a="http://schemas.openxmlformats.org/drawingml/2006/main">
               <a:ext uri="{FF2B5EF4-FFF2-40B4-BE49-F238E27FC236}">
-                <a16:creationId xmlns:a16="http://schemas.microsoft.com/office/drawing/2014/main" id="{DBBB6E2C-9391-400C-9BAF-379554E11F4B}"/>
+                <a16:creationId xmlns:a16="http://schemas.microsoft.com/office/drawing/2014/main" id="{F33CEA66-3EA8-4217-ABB8-A6CD332834A5}"/>
               </a:ext>
             </a:extLst>
           </p:cNvPr>
@@ -9840,7 +9857,7 @@
           <p:cNvPr id="8" name="">
             <a:extLst xmlns:a="http://schemas.openxmlformats.org/drawingml/2006/main">
               <a:ext uri="{FF2B5EF4-FFF2-40B4-BE49-F238E27FC236}">
-                <a16:creationId xmlns:a16="http://schemas.microsoft.com/office/drawing/2014/main" id="{E9B60B10-7ED2-4FF7-8321-DD54A44F5486}"/>
+                <a16:creationId xmlns:a16="http://schemas.microsoft.com/office/drawing/2014/main" id="{1594AEA1-9AF8-419C-8A18-DBFBCD34E62A}"/>
               </a:ext>
             </a:extLst>
           </p:cNvPr>
@@ -9875,7 +9892,7 @@
           <p:cNvPr id="9" name="">
             <a:extLst xmlns:a="http://schemas.openxmlformats.org/drawingml/2006/main">
               <a:ext uri="{FF2B5EF4-FFF2-40B4-BE49-F238E27FC236}">
-                <a16:creationId xmlns:a16="http://schemas.microsoft.com/office/drawing/2014/main" id="{862E0C00-BAEB-4CBE-AC2B-3EBEA3EA5DCC}"/>
+                <a16:creationId xmlns:a16="http://schemas.microsoft.com/office/drawing/2014/main" id="{E18EBCAB-7B4B-4CB1-AF15-4BA309F46813}"/>
               </a:ext>
             </a:extLst>
           </p:cNvPr>
@@ -9925,7 +9942,7 @@
           <p:cNvPr id="10" name="">
             <a:extLst xmlns:a="http://schemas.openxmlformats.org/drawingml/2006/main">
               <a:ext uri="{FF2B5EF4-FFF2-40B4-BE49-F238E27FC236}">
-                <a16:creationId xmlns:a16="http://schemas.microsoft.com/office/drawing/2014/main" id="{A2A32271-EF05-4827-8AFC-20764BC43293}"/>
+                <a16:creationId xmlns:a16="http://schemas.microsoft.com/office/drawing/2014/main" id="{95C744FE-C5C3-43F1-9938-C6C363A28F43}"/>
               </a:ext>
             </a:extLst>
           </p:cNvPr>
@@ -9992,7 +10009,7 @@
           <p:cNvPr id="11" name="">
             <a:extLst xmlns:a="http://schemas.openxmlformats.org/drawingml/2006/main">
               <a:ext uri="{FF2B5EF4-FFF2-40B4-BE49-F238E27FC236}">
-                <a16:creationId xmlns:a16="http://schemas.microsoft.com/office/drawing/2014/main" id="{9471200C-5979-4825-9CAA-BD755301E4E0}"/>
+                <a16:creationId xmlns:a16="http://schemas.microsoft.com/office/drawing/2014/main" id="{D573853E-8755-4193-A40A-E5D7AFE7DF53}"/>
               </a:ext>
             </a:extLst>
           </p:cNvPr>
@@ -10040,7 +10057,7 @@
     </p:spTree>
     <p:extLst>
       <p:ext uri="{BB962C8B-B14F-4D97-AF65-F5344CB8AC3E}">
-        <p14:creationId xmlns:p14="http://schemas.microsoft.com/office/powerpoint/2010/main" val="280742534"/>
+        <p14:creationId xmlns:p14="http://schemas.microsoft.com/office/powerpoint/2010/main" val="785415564"/>
       </p:ext>
     </p:extLst>
   </p:cSld>
@@ -10071,7 +10088,7 @@
           <p:cNvPr id="1" name="">
             <a:extLst xmlns:a="http://schemas.openxmlformats.org/drawingml/2006/main">
               <a:ext uri="{FF2B5EF4-FFF2-40B4-BE49-F238E27FC236}">
-                <a16:creationId xmlns:a16="http://schemas.microsoft.com/office/drawing/2014/main" id="{4C88E0DC-AB30-4899-AAC2-34652BFA479E}"/>
+                <a16:creationId xmlns:a16="http://schemas.microsoft.com/office/drawing/2014/main" id="{2F289977-6278-48B5-9DEE-DC0E2D5D0015}"/>
               </a:ext>
             </a:extLst>
           </p:cNvPr>
@@ -10102,7 +10119,7 @@
           <p:cNvPr id="2" name="">
             <a:extLst xmlns:a="http://schemas.openxmlformats.org/drawingml/2006/main">
               <a:ext uri="{FF2B5EF4-FFF2-40B4-BE49-F238E27FC236}">
-                <a16:creationId xmlns:a16="http://schemas.microsoft.com/office/drawing/2014/main" id="{D2A6FD5D-E170-4FFB-8C0E-D7BC3F82E769}"/>
+                <a16:creationId xmlns:a16="http://schemas.microsoft.com/office/drawing/2014/main" id="{112A9469-559C-4821-949C-A6D324298EEA}"/>
               </a:ext>
             </a:extLst>
           </p:cNvPr>
@@ -10152,7 +10169,7 @@
           <p:cNvPr id="3" name="">
             <a:extLst xmlns:a="http://schemas.openxmlformats.org/drawingml/2006/main">
               <a:ext uri="{FF2B5EF4-FFF2-40B4-BE49-F238E27FC236}">
-                <a16:creationId xmlns:a16="http://schemas.microsoft.com/office/drawing/2014/main" id="{54A5348B-DBEC-45A1-9AD1-4373BCCD3BD5}"/>
+                <a16:creationId xmlns:a16="http://schemas.microsoft.com/office/drawing/2014/main" id="{EEBEEF70-10B7-45F0-B7DD-DC566E4B9A59}"/>
               </a:ext>
             </a:extLst>
           </p:cNvPr>
@@ -10202,7 +10219,7 @@
           <p:cNvPr id="4" name="">
             <a:extLst xmlns:a="http://schemas.openxmlformats.org/drawingml/2006/main">
               <a:ext uri="{FF2B5EF4-FFF2-40B4-BE49-F238E27FC236}">
-                <a16:creationId xmlns:a16="http://schemas.microsoft.com/office/drawing/2014/main" id="{3D4942C2-FC94-447B-BC67-AD8B3CFE91FE}"/>
+                <a16:creationId xmlns:a16="http://schemas.microsoft.com/office/drawing/2014/main" id="{0953FB6E-4CF2-42DB-A92C-6AF6E39F22B1}"/>
               </a:ext>
             </a:extLst>
           </p:cNvPr>
@@ -10233,7 +10250,7 @@
           <p:cNvPr id="5" name="footer-6">
             <a:extLst xmlns:a="http://schemas.openxmlformats.org/drawingml/2006/main">
               <a:ext uri="{FF2B5EF4-FFF2-40B4-BE49-F238E27FC236}">
-                <a16:creationId xmlns:a16="http://schemas.microsoft.com/office/drawing/2014/main" id="{7369BD8F-591D-468D-B87E-1B60FEEA9AAB}"/>
+                <a16:creationId xmlns:a16="http://schemas.microsoft.com/office/drawing/2014/main" id="{E1162CF6-BA53-4918-8434-7C0C51602AD1}"/>
               </a:ext>
             </a:extLst>
           </p:cNvPr>
@@ -10283,7 +10300,7 @@
           <p:cNvPr id="6" name="">
             <a:extLst xmlns:a="http://schemas.openxmlformats.org/drawingml/2006/main">
               <a:ext uri="{FF2B5EF4-FFF2-40B4-BE49-F238E27FC236}">
-                <a16:creationId xmlns:a16="http://schemas.microsoft.com/office/drawing/2014/main" id="{5B2A9308-C2DB-4311-8037-663FB706260D}"/>
+                <a16:creationId xmlns:a16="http://schemas.microsoft.com/office/drawing/2014/main" id="{315FCE94-77D9-4901-9CE5-D27FC7553B09}"/>
               </a:ext>
             </a:extLst>
           </p:cNvPr>
@@ -10318,7 +10335,7 @@
           <p:cNvPr id="7" name="">
             <a:extLst xmlns:a="http://schemas.openxmlformats.org/drawingml/2006/main">
               <a:ext uri="{FF2B5EF4-FFF2-40B4-BE49-F238E27FC236}">
-                <a16:creationId xmlns:a16="http://schemas.microsoft.com/office/drawing/2014/main" id="{26A123DD-901C-4B4F-9DC4-D7A4F1BD3661}"/>
+                <a16:creationId xmlns:a16="http://schemas.microsoft.com/office/drawing/2014/main" id="{2107431F-49CB-4209-9A4D-82402A22DEDA}"/>
               </a:ext>
             </a:extLst>
           </p:cNvPr>
@@ -10368,7 +10385,7 @@
           <p:cNvPr id="8" name="">
             <a:extLst xmlns:a="http://schemas.openxmlformats.org/drawingml/2006/main">
               <a:ext uri="{FF2B5EF4-FFF2-40B4-BE49-F238E27FC236}">
-                <a16:creationId xmlns:a16="http://schemas.microsoft.com/office/drawing/2014/main" id="{A0A53946-5256-43F4-B30B-B56C4B0EFD4C}"/>
+                <a16:creationId xmlns:a16="http://schemas.microsoft.com/office/drawing/2014/main" id="{1FA89575-3C2C-48BC-ABCF-09B2417984A3}"/>
               </a:ext>
             </a:extLst>
           </p:cNvPr>
@@ -10403,7 +10420,7 @@
           <p:cNvPr id="9" name="">
             <a:extLst xmlns:a="http://schemas.openxmlformats.org/drawingml/2006/main">
               <a:ext uri="{FF2B5EF4-FFF2-40B4-BE49-F238E27FC236}">
-                <a16:creationId xmlns:a16="http://schemas.microsoft.com/office/drawing/2014/main" id="{FE2232F0-4B4B-4DC3-A14A-2B2605C13DD3}"/>
+                <a16:creationId xmlns:a16="http://schemas.microsoft.com/office/drawing/2014/main" id="{09C71B58-E718-43E8-AA4D-8F3707D2C2F6}"/>
               </a:ext>
             </a:extLst>
           </p:cNvPr>
@@ -10453,7 +10470,7 @@
           <p:cNvPr id="10" name="">
             <a:extLst xmlns:a="http://schemas.openxmlformats.org/drawingml/2006/main">
               <a:ext uri="{FF2B5EF4-FFF2-40B4-BE49-F238E27FC236}">
-                <a16:creationId xmlns:a16="http://schemas.microsoft.com/office/drawing/2014/main" id="{2E28E59E-1F71-4283-98F6-AA9FD7A36F89}"/>
+                <a16:creationId xmlns:a16="http://schemas.microsoft.com/office/drawing/2014/main" id="{204E392A-A756-4D69-A887-3183AC578187}"/>
               </a:ext>
             </a:extLst>
           </p:cNvPr>
@@ -10488,7 +10505,7 @@
           <p:cNvPr id="11" name="">
             <a:extLst xmlns:a="http://schemas.openxmlformats.org/drawingml/2006/main">
               <a:ext uri="{FF2B5EF4-FFF2-40B4-BE49-F238E27FC236}">
-                <a16:creationId xmlns:a16="http://schemas.microsoft.com/office/drawing/2014/main" id="{2AE5185D-F2C9-414E-952B-5649C51B9F4E}"/>
+                <a16:creationId xmlns:a16="http://schemas.microsoft.com/office/drawing/2014/main" id="{C44421E8-8B70-49FC-B7E9-3AD0CA35CE43}"/>
               </a:ext>
             </a:extLst>
           </p:cNvPr>
@@ -10538,7 +10555,7 @@
           <p:cNvPr id="12" name="">
             <a:extLst xmlns:a="http://schemas.openxmlformats.org/drawingml/2006/main">
               <a:ext uri="{FF2B5EF4-FFF2-40B4-BE49-F238E27FC236}">
-                <a16:creationId xmlns:a16="http://schemas.microsoft.com/office/drawing/2014/main" id="{9EA99E99-D606-47B7-8226-A28750715D4F}"/>
+                <a16:creationId xmlns:a16="http://schemas.microsoft.com/office/drawing/2014/main" id="{DDFF0B4E-7FCF-4D23-B8AB-6C3DDCFA8ADA}"/>
               </a:ext>
             </a:extLst>
           </p:cNvPr>
@@ -10573,7 +10590,7 @@
           <p:cNvPr id="13" name="">
             <a:extLst xmlns:a="http://schemas.openxmlformats.org/drawingml/2006/main">
               <a:ext uri="{FF2B5EF4-FFF2-40B4-BE49-F238E27FC236}">
-                <a16:creationId xmlns:a16="http://schemas.microsoft.com/office/drawing/2014/main" id="{91834BFB-3442-44A0-9803-2AED18A4C813}"/>
+                <a16:creationId xmlns:a16="http://schemas.microsoft.com/office/drawing/2014/main" id="{2B2937BF-9EB2-4415-BF57-4AB84604B794}"/>
               </a:ext>
             </a:extLst>
           </p:cNvPr>
@@ -10623,7 +10640,7 @@
           <p:cNvPr id="14" name="">
             <a:extLst xmlns:a="http://schemas.openxmlformats.org/drawingml/2006/main">
               <a:ext uri="{FF2B5EF4-FFF2-40B4-BE49-F238E27FC236}">
-                <a16:creationId xmlns:a16="http://schemas.microsoft.com/office/drawing/2014/main" id="{22BAA98F-E9A5-4DA7-ADAD-19EBECC84C1D}"/>
+                <a16:creationId xmlns:a16="http://schemas.microsoft.com/office/drawing/2014/main" id="{388D3E45-CA88-486F-AE66-5B131CE147F2}"/>
               </a:ext>
             </a:extLst>
           </p:cNvPr>
@@ -10724,7 +10741,7 @@
           <p:cNvPr id="15" name="">
             <a:extLst xmlns:a="http://schemas.openxmlformats.org/drawingml/2006/main">
               <a:ext uri="{FF2B5EF4-FFF2-40B4-BE49-F238E27FC236}">
-                <a16:creationId xmlns:a16="http://schemas.microsoft.com/office/drawing/2014/main" id="{6E0659D0-15DA-4781-B41E-3993433F7937}"/>
+                <a16:creationId xmlns:a16="http://schemas.microsoft.com/office/drawing/2014/main" id="{72DD9749-D663-457E-BE8D-1AD815C765BA}"/>
               </a:ext>
             </a:extLst>
           </p:cNvPr>
@@ -10755,7 +10772,7 @@
           <p:cNvPr id="16" name="">
             <a:extLst xmlns:a="http://schemas.openxmlformats.org/drawingml/2006/main">
               <a:ext uri="{FF2B5EF4-FFF2-40B4-BE49-F238E27FC236}">
-                <a16:creationId xmlns:a16="http://schemas.microsoft.com/office/drawing/2014/main" id="{4A134224-EC01-4153-9E51-05EB2199828B}"/>
+                <a16:creationId xmlns:a16="http://schemas.microsoft.com/office/drawing/2014/main" id="{E89555B8-17AC-4431-BF84-F83F9A04E6A6}"/>
               </a:ext>
             </a:extLst>
           </p:cNvPr>
@@ -10786,7 +10803,7 @@
           <p:cNvPr id="17" name="">
             <a:extLst xmlns:a="http://schemas.openxmlformats.org/drawingml/2006/main">
               <a:ext uri="{FF2B5EF4-FFF2-40B4-BE49-F238E27FC236}">
-                <a16:creationId xmlns:a16="http://schemas.microsoft.com/office/drawing/2014/main" id="{26F517BF-FB42-4D6D-85DB-EF6A95B61775}"/>
+                <a16:creationId xmlns:a16="http://schemas.microsoft.com/office/drawing/2014/main" id="{5D2A783F-517E-41DE-A397-15B2F8372BF4}"/>
               </a:ext>
             </a:extLst>
           </p:cNvPr>
@@ -10817,7 +10834,7 @@
           <p:cNvPr id="18" name="">
             <a:extLst xmlns:a="http://schemas.openxmlformats.org/drawingml/2006/main">
               <a:ext uri="{FF2B5EF4-FFF2-40B4-BE49-F238E27FC236}">
-                <a16:creationId xmlns:a16="http://schemas.microsoft.com/office/drawing/2014/main" id="{AB604D91-A5E6-43CB-9710-A6BF508D63B5}"/>
+                <a16:creationId xmlns:a16="http://schemas.microsoft.com/office/drawing/2014/main" id="{09A2BAD2-C9A0-40A5-BB61-F299334C2483}"/>
               </a:ext>
             </a:extLst>
           </p:cNvPr>
@@ -10867,7 +10884,7 @@
           <p:cNvPr id="19" name="">
             <a:extLst xmlns:a="http://schemas.openxmlformats.org/drawingml/2006/main">
               <a:ext uri="{FF2B5EF4-FFF2-40B4-BE49-F238E27FC236}">
-                <a16:creationId xmlns:a16="http://schemas.microsoft.com/office/drawing/2014/main" id="{D6BAD5B1-04C6-4BFC-A58B-1D89DA2D19CA}"/>
+                <a16:creationId xmlns:a16="http://schemas.microsoft.com/office/drawing/2014/main" id="{7A15B573-1634-4011-B36D-EAA968CF7588}"/>
               </a:ext>
             </a:extLst>
           </p:cNvPr>
@@ -10915,7 +10932,7 @@
     </p:spTree>
     <p:extLst>
       <p:ext uri="{BB962C8B-B14F-4D97-AF65-F5344CB8AC3E}">
-        <p14:creationId xmlns:p14="http://schemas.microsoft.com/office/powerpoint/2010/main" val="935170409"/>
+        <p14:creationId xmlns:p14="http://schemas.microsoft.com/office/powerpoint/2010/main" val="464523770"/>
       </p:ext>
     </p:extLst>
   </p:cSld>
@@ -10946,7 +10963,7 @@
           <p:cNvPr id="1" name="">
             <a:extLst xmlns:a="http://schemas.openxmlformats.org/drawingml/2006/main">
               <a:ext uri="{FF2B5EF4-FFF2-40B4-BE49-F238E27FC236}">
-                <a16:creationId xmlns:a16="http://schemas.microsoft.com/office/drawing/2014/main" id="{99EC895E-2467-4862-84EC-62B8929C583A}"/>
+                <a16:creationId xmlns:a16="http://schemas.microsoft.com/office/drawing/2014/main" id="{5B4D73A9-3844-4E5B-A167-F5C6F41193F2}"/>
               </a:ext>
             </a:extLst>
           </p:cNvPr>
@@ -10977,7 +10994,7 @@
           <p:cNvPr id="2" name="">
             <a:extLst xmlns:a="http://schemas.openxmlformats.org/drawingml/2006/main">
               <a:ext uri="{FF2B5EF4-FFF2-40B4-BE49-F238E27FC236}">
-                <a16:creationId xmlns:a16="http://schemas.microsoft.com/office/drawing/2014/main" id="{B04039D4-9083-4B6A-9F4F-A15C53E0DA43}"/>
+                <a16:creationId xmlns:a16="http://schemas.microsoft.com/office/drawing/2014/main" id="{46B0D665-16CE-4D4C-8FC9-29728065D0E5}"/>
               </a:ext>
             </a:extLst>
           </p:cNvPr>
@@ -11027,7 +11044,7 @@
           <p:cNvPr id="3" name="">
             <a:extLst xmlns:a="http://schemas.openxmlformats.org/drawingml/2006/main">
               <a:ext uri="{FF2B5EF4-FFF2-40B4-BE49-F238E27FC236}">
-                <a16:creationId xmlns:a16="http://schemas.microsoft.com/office/drawing/2014/main" id="{C2C54EB5-D1A4-41FD-A55C-0A7429EC1672}"/>
+                <a16:creationId xmlns:a16="http://schemas.microsoft.com/office/drawing/2014/main" id="{9FD3AE99-43AD-4EF6-8982-9BC1B7460FBB}"/>
               </a:ext>
             </a:extLst>
           </p:cNvPr>
@@ -11077,7 +11094,7 @@
           <p:cNvPr id="4" name="">
             <a:extLst xmlns:a="http://schemas.openxmlformats.org/drawingml/2006/main">
               <a:ext uri="{FF2B5EF4-FFF2-40B4-BE49-F238E27FC236}">
-                <a16:creationId xmlns:a16="http://schemas.microsoft.com/office/drawing/2014/main" id="{D8DC643B-FAC9-4C2A-81DF-F48D3D52B860}"/>
+                <a16:creationId xmlns:a16="http://schemas.microsoft.com/office/drawing/2014/main" id="{599E1A7F-2E4D-4D1D-97C9-65804AA7D000}"/>
               </a:ext>
             </a:extLst>
           </p:cNvPr>
@@ -11108,7 +11125,7 @@
           <p:cNvPr id="5" name="footer-7">
             <a:extLst xmlns:a="http://schemas.openxmlformats.org/drawingml/2006/main">
               <a:ext uri="{FF2B5EF4-FFF2-40B4-BE49-F238E27FC236}">
-                <a16:creationId xmlns:a16="http://schemas.microsoft.com/office/drawing/2014/main" id="{49C73205-202C-43F1-BB7D-62366A9D0EFE}"/>
+                <a16:creationId xmlns:a16="http://schemas.microsoft.com/office/drawing/2014/main" id="{603A6902-A84B-4DC2-8364-773A36876A44}"/>
               </a:ext>
             </a:extLst>
           </p:cNvPr>
@@ -11158,7 +11175,7 @@
           <p:cNvPr id="6" name="">
             <a:extLst xmlns:a="http://schemas.openxmlformats.org/drawingml/2006/main">
               <a:ext uri="{FF2B5EF4-FFF2-40B4-BE49-F238E27FC236}">
-                <a16:creationId xmlns:a16="http://schemas.microsoft.com/office/drawing/2014/main" id="{D0BD1DCC-2C8F-4CD4-AFCF-3167504D362D}"/>
+                <a16:creationId xmlns:a16="http://schemas.microsoft.com/office/drawing/2014/main" id="{4A7F1E62-35E5-4688-8D90-4CC72CBA6102}"/>
               </a:ext>
             </a:extLst>
           </p:cNvPr>
@@ -11193,7 +11210,7 @@
           <p:cNvPr id="7" name="">
             <a:extLst xmlns:a="http://schemas.openxmlformats.org/drawingml/2006/main">
               <a:ext uri="{FF2B5EF4-FFF2-40B4-BE49-F238E27FC236}">
-                <a16:creationId xmlns:a16="http://schemas.microsoft.com/office/drawing/2014/main" id="{D6B939A6-6D8A-4E03-892D-32D4C79E713E}"/>
+                <a16:creationId xmlns:a16="http://schemas.microsoft.com/office/drawing/2014/main" id="{606BCBE2-143D-4A59-B182-336A0205CEF6}"/>
               </a:ext>
             </a:extLst>
           </p:cNvPr>
@@ -11243,7 +11260,7 @@
           <p:cNvPr id="8" name="">
             <a:extLst xmlns:a="http://schemas.openxmlformats.org/drawingml/2006/main">
               <a:ext uri="{FF2B5EF4-FFF2-40B4-BE49-F238E27FC236}">
-                <a16:creationId xmlns:a16="http://schemas.microsoft.com/office/drawing/2014/main" id="{D072E701-D06F-4207-8355-4BA0BD47649F}"/>
+                <a16:creationId xmlns:a16="http://schemas.microsoft.com/office/drawing/2014/main" id="{6F871BC3-5BBA-4FE1-97A4-5699228D562A}"/>
               </a:ext>
             </a:extLst>
           </p:cNvPr>
@@ -11310,7 +11327,7 @@
           <p:cNvPr id="9" name="">
             <a:extLst xmlns:a="http://schemas.openxmlformats.org/drawingml/2006/main">
               <a:ext uri="{FF2B5EF4-FFF2-40B4-BE49-F238E27FC236}">
-                <a16:creationId xmlns:a16="http://schemas.microsoft.com/office/drawing/2014/main" id="{60422962-21D9-44D5-B488-DCC300FE1250}"/>
+                <a16:creationId xmlns:a16="http://schemas.microsoft.com/office/drawing/2014/main" id="{EC976377-D525-4888-BA7A-00FF28B60E53}"/>
               </a:ext>
             </a:extLst>
           </p:cNvPr>
@@ -11345,7 +11362,7 @@
           <p:cNvPr id="10" name="">
             <a:extLst xmlns:a="http://schemas.openxmlformats.org/drawingml/2006/main">
               <a:ext uri="{FF2B5EF4-FFF2-40B4-BE49-F238E27FC236}">
-                <a16:creationId xmlns:a16="http://schemas.microsoft.com/office/drawing/2014/main" id="{6523B061-37DC-4741-AEEB-885AECB1660D}"/>
+                <a16:creationId xmlns:a16="http://schemas.microsoft.com/office/drawing/2014/main" id="{3537E92A-DE2C-49E3-ABA0-71ECFC8A0E3A}"/>
               </a:ext>
             </a:extLst>
           </p:cNvPr>
@@ -11395,7 +11412,7 @@
           <p:cNvPr id="11" name="">
             <a:extLst xmlns:a="http://schemas.openxmlformats.org/drawingml/2006/main">
               <a:ext uri="{FF2B5EF4-FFF2-40B4-BE49-F238E27FC236}">
-                <a16:creationId xmlns:a16="http://schemas.microsoft.com/office/drawing/2014/main" id="{765A6EA9-BC43-493D-A8BF-A5DFE1E158A7}"/>
+                <a16:creationId xmlns:a16="http://schemas.microsoft.com/office/drawing/2014/main" id="{6D8137F6-4BEC-472D-84EC-415C5CC3F03B}"/>
               </a:ext>
             </a:extLst>
           </p:cNvPr>
@@ -11445,7 +11462,7 @@
           <p:cNvPr id="12" name="">
             <a:extLst xmlns:a="http://schemas.openxmlformats.org/drawingml/2006/main">
               <a:ext uri="{FF2B5EF4-FFF2-40B4-BE49-F238E27FC236}">
-                <a16:creationId xmlns:a16="http://schemas.microsoft.com/office/drawing/2014/main" id="{08177811-CEF3-4247-BC14-3921AC83825E}"/>
+                <a16:creationId xmlns:a16="http://schemas.microsoft.com/office/drawing/2014/main" id="{25AA6218-8DC4-4092-A53B-B65842D67D6D}"/>
               </a:ext>
             </a:extLst>
           </p:cNvPr>
@@ -11495,7 +11512,7 @@
           <p:cNvPr id="13" name="">
             <a:extLst xmlns:a="http://schemas.openxmlformats.org/drawingml/2006/main">
               <a:ext uri="{FF2B5EF4-FFF2-40B4-BE49-F238E27FC236}">
-                <a16:creationId xmlns:a16="http://schemas.microsoft.com/office/drawing/2014/main" id="{9493D2F2-665C-4FAA-9221-D315D38FB039}"/>
+                <a16:creationId xmlns:a16="http://schemas.microsoft.com/office/drawing/2014/main" id="{0DA0F635-2603-4665-AD2A-D02EBD9847A6}"/>
               </a:ext>
             </a:extLst>
           </p:cNvPr>
@@ -11562,7 +11579,7 @@
           <p:cNvPr id="14" name="">
             <a:extLst xmlns:a="http://schemas.openxmlformats.org/drawingml/2006/main">
               <a:ext uri="{FF2B5EF4-FFF2-40B4-BE49-F238E27FC236}">
-                <a16:creationId xmlns:a16="http://schemas.microsoft.com/office/drawing/2014/main" id="{FA1EA5EF-1A20-4999-96CA-363726D15B56}"/>
+                <a16:creationId xmlns:a16="http://schemas.microsoft.com/office/drawing/2014/main" id="{1566DA08-765C-4B2F-B8C9-717E8C13402D}"/>
               </a:ext>
             </a:extLst>
           </p:cNvPr>
@@ -11610,7 +11627,7 @@
     </p:spTree>
     <p:extLst>
       <p:ext uri="{BB962C8B-B14F-4D97-AF65-F5344CB8AC3E}">
-        <p14:creationId xmlns:p14="http://schemas.microsoft.com/office/powerpoint/2010/main" val="1846021521"/>
+        <p14:creationId xmlns:p14="http://schemas.microsoft.com/office/powerpoint/2010/main" val="2097387919"/>
       </p:ext>
     </p:extLst>
   </p:cSld>
@@ -11641,7 +11658,7 @@
           <p:cNvPr id="1" name="">
             <a:extLst xmlns:a="http://schemas.openxmlformats.org/drawingml/2006/main">
               <a:ext uri="{FF2B5EF4-FFF2-40B4-BE49-F238E27FC236}">
-                <a16:creationId xmlns:a16="http://schemas.microsoft.com/office/drawing/2014/main" id="{148B37B1-53F4-4A26-B964-005C2DE80A3A}"/>
+                <a16:creationId xmlns:a16="http://schemas.microsoft.com/office/drawing/2014/main" id="{6D18EF72-D4CB-4E4D-8497-BD42AC39239B}"/>
               </a:ext>
             </a:extLst>
           </p:cNvPr>
@@ -11672,7 +11689,7 @@
           <p:cNvPr id="2" name="">
             <a:extLst xmlns:a="http://schemas.openxmlformats.org/drawingml/2006/main">
               <a:ext uri="{FF2B5EF4-FFF2-40B4-BE49-F238E27FC236}">
-                <a16:creationId xmlns:a16="http://schemas.microsoft.com/office/drawing/2014/main" id="{9625ADE8-6B91-461A-A406-F360AE24D176}"/>
+                <a16:creationId xmlns:a16="http://schemas.microsoft.com/office/drawing/2014/main" id="{69B3F311-9D88-475A-AA41-C28FA5020477}"/>
               </a:ext>
             </a:extLst>
           </p:cNvPr>
@@ -11722,7 +11739,7 @@
           <p:cNvPr id="3" name="">
             <a:extLst xmlns:a="http://schemas.openxmlformats.org/drawingml/2006/main">
               <a:ext uri="{FF2B5EF4-FFF2-40B4-BE49-F238E27FC236}">
-                <a16:creationId xmlns:a16="http://schemas.microsoft.com/office/drawing/2014/main" id="{D1F70790-F6FD-4439-9CD9-BCD59C04839D}"/>
+                <a16:creationId xmlns:a16="http://schemas.microsoft.com/office/drawing/2014/main" id="{B6FC7DAA-6F15-40F9-8F60-CB2816C8933E}"/>
               </a:ext>
             </a:extLst>
           </p:cNvPr>
@@ -11772,7 +11789,7 @@
           <p:cNvPr id="4" name="">
             <a:extLst xmlns:a="http://schemas.openxmlformats.org/drawingml/2006/main">
               <a:ext uri="{FF2B5EF4-FFF2-40B4-BE49-F238E27FC236}">
-                <a16:creationId xmlns:a16="http://schemas.microsoft.com/office/drawing/2014/main" id="{24B4B65E-AE4F-4173-BBE5-B883CE1DDE43}"/>
+                <a16:creationId xmlns:a16="http://schemas.microsoft.com/office/drawing/2014/main" id="{DF58C4AF-B3F4-4D4E-953A-CF3CDACCF86D}"/>
               </a:ext>
             </a:extLst>
           </p:cNvPr>
@@ -11803,7 +11820,7 @@
           <p:cNvPr id="5" name="footer-8">
             <a:extLst xmlns:a="http://schemas.openxmlformats.org/drawingml/2006/main">
               <a:ext uri="{FF2B5EF4-FFF2-40B4-BE49-F238E27FC236}">
-                <a16:creationId xmlns:a16="http://schemas.microsoft.com/office/drawing/2014/main" id="{10F5D44B-5C8E-41AF-B083-2AF933C41541}"/>
+                <a16:creationId xmlns:a16="http://schemas.microsoft.com/office/drawing/2014/main" id="{513E2D05-0EC2-48B1-8C49-F080A66B18EB}"/>
               </a:ext>
             </a:extLst>
           </p:cNvPr>
@@ -11853,7 +11870,7 @@
           <p:cNvPr id="6" name="">
             <a:extLst xmlns:a="http://schemas.openxmlformats.org/drawingml/2006/main">
               <a:ext uri="{FF2B5EF4-FFF2-40B4-BE49-F238E27FC236}">
-                <a16:creationId xmlns:a16="http://schemas.microsoft.com/office/drawing/2014/main" id="{3CF85C0C-3F4E-4977-B611-BABE7820F149}"/>
+                <a16:creationId xmlns:a16="http://schemas.microsoft.com/office/drawing/2014/main" id="{81453465-BBA1-46DB-A6CC-D8541FA12547}"/>
               </a:ext>
             </a:extLst>
           </p:cNvPr>
@@ -11888,7 +11905,7 @@
           <p:cNvPr id="7" name="">
             <a:extLst xmlns:a="http://schemas.openxmlformats.org/drawingml/2006/main">
               <a:ext uri="{FF2B5EF4-FFF2-40B4-BE49-F238E27FC236}">
-                <a16:creationId xmlns:a16="http://schemas.microsoft.com/office/drawing/2014/main" id="{CBD7040B-2B5F-4C85-8933-A44382FA177C}"/>
+                <a16:creationId xmlns:a16="http://schemas.microsoft.com/office/drawing/2014/main" id="{ADE56CCA-77B5-4ECF-9A55-88F78F6F2418}"/>
               </a:ext>
             </a:extLst>
           </p:cNvPr>
@@ -11938,7 +11955,7 @@
           <p:cNvPr id="8" name="">
             <a:extLst xmlns:a="http://schemas.openxmlformats.org/drawingml/2006/main">
               <a:ext uri="{FF2B5EF4-FFF2-40B4-BE49-F238E27FC236}">
-                <a16:creationId xmlns:a16="http://schemas.microsoft.com/office/drawing/2014/main" id="{DC53C4D6-4274-41ED-A73A-B81D5B2DB0C0}"/>
+                <a16:creationId xmlns:a16="http://schemas.microsoft.com/office/drawing/2014/main" id="{EF5E4B90-8D40-436A-8DE7-47E3F249D441}"/>
               </a:ext>
             </a:extLst>
           </p:cNvPr>
@@ -11988,7 +12005,7 @@
           <p:cNvPr id="9" name="">
             <a:extLst xmlns:a="http://schemas.openxmlformats.org/drawingml/2006/main">
               <a:ext uri="{FF2B5EF4-FFF2-40B4-BE49-F238E27FC236}">
-                <a16:creationId xmlns:a16="http://schemas.microsoft.com/office/drawing/2014/main" id="{41A18D12-AD66-4112-8B11-322895423012}"/>
+                <a16:creationId xmlns:a16="http://schemas.microsoft.com/office/drawing/2014/main" id="{C6CB8F71-A0B8-4AE5-8CEC-63B7BCC83E36}"/>
               </a:ext>
             </a:extLst>
           </p:cNvPr>
@@ -12023,7 +12040,7 @@
           <p:cNvPr id="10" name="">
             <a:extLst xmlns:a="http://schemas.openxmlformats.org/drawingml/2006/main">
               <a:ext uri="{FF2B5EF4-FFF2-40B4-BE49-F238E27FC236}">
-                <a16:creationId xmlns:a16="http://schemas.microsoft.com/office/drawing/2014/main" id="{504A10B0-DD9A-4B6E-878E-1CA0AC518E7F}"/>
+                <a16:creationId xmlns:a16="http://schemas.microsoft.com/office/drawing/2014/main" id="{1620358B-B486-4DF0-8C38-090480DE26F7}"/>
               </a:ext>
             </a:extLst>
           </p:cNvPr>
@@ -12073,7 +12090,7 @@
           <p:cNvPr id="11" name="">
             <a:extLst xmlns:a="http://schemas.openxmlformats.org/drawingml/2006/main">
               <a:ext uri="{FF2B5EF4-FFF2-40B4-BE49-F238E27FC236}">
-                <a16:creationId xmlns:a16="http://schemas.microsoft.com/office/drawing/2014/main" id="{EBB10FB9-9DD8-4D94-902A-6162A21891C6}"/>
+                <a16:creationId xmlns:a16="http://schemas.microsoft.com/office/drawing/2014/main" id="{607FC3F2-5B20-464C-9F9A-F8320ED8A807}"/>
               </a:ext>
             </a:extLst>
           </p:cNvPr>
@@ -12123,7 +12140,7 @@
           <p:cNvPr id="12" name="">
             <a:extLst xmlns:a="http://schemas.openxmlformats.org/drawingml/2006/main">
               <a:ext uri="{FF2B5EF4-FFF2-40B4-BE49-F238E27FC236}">
-                <a16:creationId xmlns:a16="http://schemas.microsoft.com/office/drawing/2014/main" id="{2618BEE6-0BFD-49DB-B6C2-9BA5FD94257D}"/>
+                <a16:creationId xmlns:a16="http://schemas.microsoft.com/office/drawing/2014/main" id="{06E9079D-FD86-47BE-AED6-92EE8183A2E6}"/>
               </a:ext>
             </a:extLst>
           </p:cNvPr>
@@ -12158,7 +12175,7 @@
           <p:cNvPr id="13" name="">
             <a:extLst xmlns:a="http://schemas.openxmlformats.org/drawingml/2006/main">
               <a:ext uri="{FF2B5EF4-FFF2-40B4-BE49-F238E27FC236}">
-                <a16:creationId xmlns:a16="http://schemas.microsoft.com/office/drawing/2014/main" id="{03D4EAE1-8BDA-4EAD-A8C2-B439879CB0C0}"/>
+                <a16:creationId xmlns:a16="http://schemas.microsoft.com/office/drawing/2014/main" id="{9528D6D5-ECC9-484A-B924-959EAADFE279}"/>
               </a:ext>
             </a:extLst>
           </p:cNvPr>
@@ -12208,7 +12225,7 @@
           <p:cNvPr id="14" name="">
             <a:extLst xmlns:a="http://schemas.openxmlformats.org/drawingml/2006/main">
               <a:ext uri="{FF2B5EF4-FFF2-40B4-BE49-F238E27FC236}">
-                <a16:creationId xmlns:a16="http://schemas.microsoft.com/office/drawing/2014/main" id="{E33F0BE9-ADD8-401B-A62B-C3F7FEF117DB}"/>
+                <a16:creationId xmlns:a16="http://schemas.microsoft.com/office/drawing/2014/main" id="{70606273-5039-4E10-AD97-AF1ED217249C}"/>
               </a:ext>
             </a:extLst>
           </p:cNvPr>
@@ -12258,7 +12275,7 @@
           <p:cNvPr id="15" name="">
             <a:extLst xmlns:a="http://schemas.openxmlformats.org/drawingml/2006/main">
               <a:ext uri="{FF2B5EF4-FFF2-40B4-BE49-F238E27FC236}">
-                <a16:creationId xmlns:a16="http://schemas.microsoft.com/office/drawing/2014/main" id="{BF6ABABE-D0F3-4FC2-8534-488773131B90}"/>
+                <a16:creationId xmlns:a16="http://schemas.microsoft.com/office/drawing/2014/main" id="{98C506F3-6628-4251-B6B0-ED688466D6FB}"/>
               </a:ext>
             </a:extLst>
           </p:cNvPr>
@@ -12293,7 +12310,7 @@
           <p:cNvPr id="16" name="">
             <a:extLst xmlns:a="http://schemas.openxmlformats.org/drawingml/2006/main">
               <a:ext uri="{FF2B5EF4-FFF2-40B4-BE49-F238E27FC236}">
-                <a16:creationId xmlns:a16="http://schemas.microsoft.com/office/drawing/2014/main" id="{4ACCDA33-D04C-405A-ADEF-07E5C72DB15D}"/>
+                <a16:creationId xmlns:a16="http://schemas.microsoft.com/office/drawing/2014/main" id="{56C025C5-488D-4BAC-96A8-07D1A29EB331}"/>
               </a:ext>
             </a:extLst>
           </p:cNvPr>
@@ -12343,7 +12360,7 @@
           <p:cNvPr id="17" name="">
             <a:extLst xmlns:a="http://schemas.openxmlformats.org/drawingml/2006/main">
               <a:ext uri="{FF2B5EF4-FFF2-40B4-BE49-F238E27FC236}">
-                <a16:creationId xmlns:a16="http://schemas.microsoft.com/office/drawing/2014/main" id="{5FAD6FC6-3A60-4CC4-ABB6-17BEBA13EB15}"/>
+                <a16:creationId xmlns:a16="http://schemas.microsoft.com/office/drawing/2014/main" id="{2E7920F3-C140-43E5-91D5-D0E791F69B87}"/>
               </a:ext>
             </a:extLst>
           </p:cNvPr>
@@ -12393,7 +12410,7 @@
           <p:cNvPr id="18" name="">
             <a:extLst xmlns:a="http://schemas.openxmlformats.org/drawingml/2006/main">
               <a:ext uri="{FF2B5EF4-FFF2-40B4-BE49-F238E27FC236}">
-                <a16:creationId xmlns:a16="http://schemas.microsoft.com/office/drawing/2014/main" id="{2D1F69DA-2B91-4553-834E-E74D528C8265}"/>
+                <a16:creationId xmlns:a16="http://schemas.microsoft.com/office/drawing/2014/main" id="{8D40608F-3F30-440B-BD63-A73767ED65EC}"/>
               </a:ext>
             </a:extLst>
           </p:cNvPr>
@@ -12428,7 +12445,7 @@
           <p:cNvPr id="19" name="">
             <a:extLst xmlns:a="http://schemas.openxmlformats.org/drawingml/2006/main">
               <a:ext uri="{FF2B5EF4-FFF2-40B4-BE49-F238E27FC236}">
-                <a16:creationId xmlns:a16="http://schemas.microsoft.com/office/drawing/2014/main" id="{B208E323-6053-42FB-9235-EE236FB1C674}"/>
+                <a16:creationId xmlns:a16="http://schemas.microsoft.com/office/drawing/2014/main" id="{9217F3F6-14DF-4CDA-9F9A-8948173BC5C5}"/>
               </a:ext>
             </a:extLst>
           </p:cNvPr>
@@ -12478,7 +12495,7 @@
           <p:cNvPr id="20" name="">
             <a:extLst xmlns:a="http://schemas.openxmlformats.org/drawingml/2006/main">
               <a:ext uri="{FF2B5EF4-FFF2-40B4-BE49-F238E27FC236}">
-                <a16:creationId xmlns:a16="http://schemas.microsoft.com/office/drawing/2014/main" id="{BD676625-E252-4F75-8B59-8B66EA82FB48}"/>
+                <a16:creationId xmlns:a16="http://schemas.microsoft.com/office/drawing/2014/main" id="{8FEE88D7-3D73-4D9A-B988-49A33FD6BCFB}"/>
               </a:ext>
             </a:extLst>
           </p:cNvPr>
@@ -12528,7 +12545,7 @@
           <p:cNvPr id="21" name="">
             <a:extLst xmlns:a="http://schemas.openxmlformats.org/drawingml/2006/main">
               <a:ext uri="{FF2B5EF4-FFF2-40B4-BE49-F238E27FC236}">
-                <a16:creationId xmlns:a16="http://schemas.microsoft.com/office/drawing/2014/main" id="{61DF60BB-9A93-4B51-9AFF-2F266A97A227}"/>
+                <a16:creationId xmlns:a16="http://schemas.microsoft.com/office/drawing/2014/main" id="{FE10F07C-9C9C-4793-B007-E4EB9200E58A}"/>
               </a:ext>
             </a:extLst>
           </p:cNvPr>
@@ -12578,7 +12595,7 @@
           <p:cNvPr id="22" name="">
             <a:extLst xmlns:a="http://schemas.openxmlformats.org/drawingml/2006/main">
               <a:ext uri="{FF2B5EF4-FFF2-40B4-BE49-F238E27FC236}">
-                <a16:creationId xmlns:a16="http://schemas.microsoft.com/office/drawing/2014/main" id="{08B0A59D-8626-4F77-BC46-3FB16A0229BD}"/>
+                <a16:creationId xmlns:a16="http://schemas.microsoft.com/office/drawing/2014/main" id="{68CB7633-DDED-4273-8D19-DBFD1A53D890}"/>
               </a:ext>
             </a:extLst>
           </p:cNvPr>
@@ -12626,7 +12643,7 @@
     </p:spTree>
     <p:extLst>
       <p:ext uri="{BB962C8B-B14F-4D97-AF65-F5344CB8AC3E}">
-        <p14:creationId xmlns:p14="http://schemas.microsoft.com/office/powerpoint/2010/main" val="2042961983"/>
+        <p14:creationId xmlns:p14="http://schemas.microsoft.com/office/powerpoint/2010/main" val="1622397707"/>
       </p:ext>
     </p:extLst>
   </p:cSld>
@@ -12657,7 +12674,7 @@
           <p:cNvPr id="1" name="">
             <a:extLst xmlns:a="http://schemas.openxmlformats.org/drawingml/2006/main">
               <a:ext uri="{FF2B5EF4-FFF2-40B4-BE49-F238E27FC236}">
-                <a16:creationId xmlns:a16="http://schemas.microsoft.com/office/drawing/2014/main" id="{DEED188F-3500-46A7-8C3C-271AABE1711C}"/>
+                <a16:creationId xmlns:a16="http://schemas.microsoft.com/office/drawing/2014/main" id="{87DCF60F-DCA8-463D-BACD-9FFECD890D8A}"/>
               </a:ext>
             </a:extLst>
           </p:cNvPr>
@@ -12688,7 +12705,7 @@
           <p:cNvPr id="2" name="">
             <a:extLst xmlns:a="http://schemas.openxmlformats.org/drawingml/2006/main">
               <a:ext uri="{FF2B5EF4-FFF2-40B4-BE49-F238E27FC236}">
-                <a16:creationId xmlns:a16="http://schemas.microsoft.com/office/drawing/2014/main" id="{427428D9-39F8-47AA-931F-8991730224AE}"/>
+                <a16:creationId xmlns:a16="http://schemas.microsoft.com/office/drawing/2014/main" id="{EF780674-429A-47AE-A458-BEFB95A3E4CD}"/>
               </a:ext>
             </a:extLst>
           </p:cNvPr>
@@ -12738,7 +12755,7 @@
           <p:cNvPr id="3" name="">
             <a:extLst xmlns:a="http://schemas.openxmlformats.org/drawingml/2006/main">
               <a:ext uri="{FF2B5EF4-FFF2-40B4-BE49-F238E27FC236}">
-                <a16:creationId xmlns:a16="http://schemas.microsoft.com/office/drawing/2014/main" id="{E53578DF-BBDA-4B70-973B-A6169CF3872C}"/>
+                <a16:creationId xmlns:a16="http://schemas.microsoft.com/office/drawing/2014/main" id="{4786C423-A030-4BD2-9D6D-E4E6F2B58A39}"/>
               </a:ext>
             </a:extLst>
           </p:cNvPr>
@@ -12788,7 +12805,7 @@
           <p:cNvPr id="4" name="">
             <a:extLst xmlns:a="http://schemas.openxmlformats.org/drawingml/2006/main">
               <a:ext uri="{FF2B5EF4-FFF2-40B4-BE49-F238E27FC236}">
-                <a16:creationId xmlns:a16="http://schemas.microsoft.com/office/drawing/2014/main" id="{6972AED9-1B17-4A71-8980-5C7FFCFC79C3}"/>
+                <a16:creationId xmlns:a16="http://schemas.microsoft.com/office/drawing/2014/main" id="{A3D12C83-E280-4FB2-BE9D-755736B493C3}"/>
               </a:ext>
             </a:extLst>
           </p:cNvPr>
@@ -12819,7 +12836,7 @@
           <p:cNvPr id="5" name="footer-9">
             <a:extLst xmlns:a="http://schemas.openxmlformats.org/drawingml/2006/main">
               <a:ext uri="{FF2B5EF4-FFF2-40B4-BE49-F238E27FC236}">
-                <a16:creationId xmlns:a16="http://schemas.microsoft.com/office/drawing/2014/main" id="{C6D0492E-476D-4A4D-9F27-8582999EA477}"/>
+                <a16:creationId xmlns:a16="http://schemas.microsoft.com/office/drawing/2014/main" id="{43F26315-148D-4233-9AA6-DC115ABA74BF}"/>
               </a:ext>
             </a:extLst>
           </p:cNvPr>
@@ -12869,7 +12886,7 @@
           <p:cNvPr id="6" name="">
             <a:extLst xmlns:a="http://schemas.openxmlformats.org/drawingml/2006/main">
               <a:ext uri="{FF2B5EF4-FFF2-40B4-BE49-F238E27FC236}">
-                <a16:creationId xmlns:a16="http://schemas.microsoft.com/office/drawing/2014/main" id="{9F3C4161-1834-4ACC-BD92-D8C184337DF2}"/>
+                <a16:creationId xmlns:a16="http://schemas.microsoft.com/office/drawing/2014/main" id="{C0E28CC5-AB9E-402B-91EC-00B8F37BD72B}"/>
               </a:ext>
             </a:extLst>
           </p:cNvPr>
@@ -12904,7 +12921,7 @@
           <p:cNvPr id="7" name="">
             <a:extLst xmlns:a="http://schemas.openxmlformats.org/drawingml/2006/main">
               <a:ext uri="{FF2B5EF4-FFF2-40B4-BE49-F238E27FC236}">
-                <a16:creationId xmlns:a16="http://schemas.microsoft.com/office/drawing/2014/main" id="{D7FEC880-114E-494D-9D0B-7348D1D28981}"/>
+                <a16:creationId xmlns:a16="http://schemas.microsoft.com/office/drawing/2014/main" id="{C4F98AA7-D374-45DA-9987-B7E898650BC2}"/>
               </a:ext>
             </a:extLst>
           </p:cNvPr>
@@ -12935,7 +12952,7 @@
           <p:cNvPr id="8" name="">
             <a:extLst xmlns:a="http://schemas.openxmlformats.org/drawingml/2006/main">
               <a:ext uri="{FF2B5EF4-FFF2-40B4-BE49-F238E27FC236}">
-                <a16:creationId xmlns:a16="http://schemas.microsoft.com/office/drawing/2014/main" id="{22DAF311-C425-4B2F-A1B0-DFBB90042E3B}"/>
+                <a16:creationId xmlns:a16="http://schemas.microsoft.com/office/drawing/2014/main" id="{0F59152B-E53D-44FA-88EA-5D644FE239FB}"/>
               </a:ext>
             </a:extLst>
           </p:cNvPr>
@@ -12985,7 +13002,7 @@
           <p:cNvPr id="9" name="">
             <a:extLst xmlns:a="http://schemas.openxmlformats.org/drawingml/2006/main">
               <a:ext uri="{FF2B5EF4-FFF2-40B4-BE49-F238E27FC236}">
-                <a16:creationId xmlns:a16="http://schemas.microsoft.com/office/drawing/2014/main" id="{094DF0D7-F0E3-4979-BE42-6C5AC3372839}"/>
+                <a16:creationId xmlns:a16="http://schemas.microsoft.com/office/drawing/2014/main" id="{ED8B4F68-958F-4D9B-99C2-CFBB21736892}"/>
               </a:ext>
             </a:extLst>
           </p:cNvPr>
@@ -13035,7 +13052,7 @@
           <p:cNvPr id="10" name="">
             <a:extLst xmlns:a="http://schemas.openxmlformats.org/drawingml/2006/main">
               <a:ext uri="{FF2B5EF4-FFF2-40B4-BE49-F238E27FC236}">
-                <a16:creationId xmlns:a16="http://schemas.microsoft.com/office/drawing/2014/main" id="{FDD27B48-094B-4623-B679-B5C5B5FB4FEC}"/>
+                <a16:creationId xmlns:a16="http://schemas.microsoft.com/office/drawing/2014/main" id="{D4181204-3B13-45F9-AA87-E338E18335D8}"/>
               </a:ext>
             </a:extLst>
           </p:cNvPr>
@@ -13070,7 +13087,7 @@
           <p:cNvPr id="11" name="">
             <a:extLst xmlns:a="http://schemas.openxmlformats.org/drawingml/2006/main">
               <a:ext uri="{FF2B5EF4-FFF2-40B4-BE49-F238E27FC236}">
-                <a16:creationId xmlns:a16="http://schemas.microsoft.com/office/drawing/2014/main" id="{98535AD1-D508-4D67-BCB0-402AF507C82E}"/>
+                <a16:creationId xmlns:a16="http://schemas.microsoft.com/office/drawing/2014/main" id="{39564172-4544-4242-A078-CDC1B00E4B51}"/>
               </a:ext>
             </a:extLst>
           </p:cNvPr>
@@ -13101,7 +13118,7 @@
           <p:cNvPr id="12" name="">
             <a:extLst xmlns:a="http://schemas.openxmlformats.org/drawingml/2006/main">
               <a:ext uri="{FF2B5EF4-FFF2-40B4-BE49-F238E27FC236}">
-                <a16:creationId xmlns:a16="http://schemas.microsoft.com/office/drawing/2014/main" id="{E9CD09ED-0979-4D24-8752-9AC8B04833AE}"/>
+                <a16:creationId xmlns:a16="http://schemas.microsoft.com/office/drawing/2014/main" id="{64CDBB9C-C970-4839-99D2-2908E1684940}"/>
               </a:ext>
             </a:extLst>
           </p:cNvPr>
@@ -13151,7 +13168,7 @@
           <p:cNvPr id="13" name="">
             <a:extLst xmlns:a="http://schemas.openxmlformats.org/drawingml/2006/main">
               <a:ext uri="{FF2B5EF4-FFF2-40B4-BE49-F238E27FC236}">
-                <a16:creationId xmlns:a16="http://schemas.microsoft.com/office/drawing/2014/main" id="{A8BBB0B7-7B3D-4931-8EE9-C3E7FE1DDA78}"/>
+                <a16:creationId xmlns:a16="http://schemas.microsoft.com/office/drawing/2014/main" id="{88F5209D-A8E9-4F29-908A-D9C3414BA228}"/>
               </a:ext>
             </a:extLst>
           </p:cNvPr>
@@ -13201,7 +13218,7 @@
           <p:cNvPr id="14" name="">
             <a:extLst xmlns:a="http://schemas.openxmlformats.org/drawingml/2006/main">
               <a:ext uri="{FF2B5EF4-FFF2-40B4-BE49-F238E27FC236}">
-                <a16:creationId xmlns:a16="http://schemas.microsoft.com/office/drawing/2014/main" id="{9C751B38-E52C-4587-A266-D9A55EB5A996}"/>
+                <a16:creationId xmlns:a16="http://schemas.microsoft.com/office/drawing/2014/main" id="{EC5F1216-473C-498E-B8D9-6FDEED74E160}"/>
               </a:ext>
             </a:extLst>
           </p:cNvPr>
@@ -13236,7 +13253,7 @@
           <p:cNvPr id="15" name="">
             <a:extLst xmlns:a="http://schemas.openxmlformats.org/drawingml/2006/main">
               <a:ext uri="{FF2B5EF4-FFF2-40B4-BE49-F238E27FC236}">
-                <a16:creationId xmlns:a16="http://schemas.microsoft.com/office/drawing/2014/main" id="{1F0A3DF0-3735-4460-980B-FFF33E39CE8A}"/>
+                <a16:creationId xmlns:a16="http://schemas.microsoft.com/office/drawing/2014/main" id="{B9DB145B-F7D1-4FFD-8BBF-A77DA78E34C2}"/>
               </a:ext>
             </a:extLst>
           </p:cNvPr>
@@ -13267,7 +13284,7 @@
           <p:cNvPr id="16" name="">
             <a:extLst xmlns:a="http://schemas.openxmlformats.org/drawingml/2006/main">
               <a:ext uri="{FF2B5EF4-FFF2-40B4-BE49-F238E27FC236}">
-                <a16:creationId xmlns:a16="http://schemas.microsoft.com/office/drawing/2014/main" id="{68BDCC31-902A-4813-A778-11459BFD11D8}"/>
+                <a16:creationId xmlns:a16="http://schemas.microsoft.com/office/drawing/2014/main" id="{BE76C7D3-E96D-4DEF-97CE-018B70B9A9EF}"/>
               </a:ext>
             </a:extLst>
           </p:cNvPr>
@@ -13317,7 +13334,7 @@
           <p:cNvPr id="17" name="">
             <a:extLst xmlns:a="http://schemas.openxmlformats.org/drawingml/2006/main">
               <a:ext uri="{FF2B5EF4-FFF2-40B4-BE49-F238E27FC236}">
-                <a16:creationId xmlns:a16="http://schemas.microsoft.com/office/drawing/2014/main" id="{8D45AB00-991F-44FB-A9D7-9E4F1E891E15}"/>
+                <a16:creationId xmlns:a16="http://schemas.microsoft.com/office/drawing/2014/main" id="{41DBADD0-5001-4AFE-B731-E3D0DCCD7140}"/>
               </a:ext>
             </a:extLst>
           </p:cNvPr>
@@ -13367,7 +13384,7 @@
           <p:cNvPr id="18" name="">
             <a:extLst xmlns:a="http://schemas.openxmlformats.org/drawingml/2006/main">
               <a:ext uri="{FF2B5EF4-FFF2-40B4-BE49-F238E27FC236}">
-                <a16:creationId xmlns:a16="http://schemas.microsoft.com/office/drawing/2014/main" id="{2E6A1FA7-647A-4BA1-B1EE-22CE715FA251}"/>
+                <a16:creationId xmlns:a16="http://schemas.microsoft.com/office/drawing/2014/main" id="{FD92BAF7-2BF5-4E06-ADDA-ACF28DABB19E}"/>
               </a:ext>
             </a:extLst>
           </p:cNvPr>
@@ -13415,7 +13432,7 @@
     </p:spTree>
     <p:extLst>
       <p:ext uri="{BB962C8B-B14F-4D97-AF65-F5344CB8AC3E}">
-        <p14:creationId xmlns:p14="http://schemas.microsoft.com/office/powerpoint/2010/main" val="30154027"/>
+        <p14:creationId xmlns:p14="http://schemas.microsoft.com/office/powerpoint/2010/main" val="577138303"/>
       </p:ext>
     </p:extLst>
   </p:cSld>

</xml_diff>

<commit_message>
docs: finalize VDT reproduction metrics
</commit_message>
<xml_diff>
--- a/docs/ppt/E3-VDT-OOC-答辩PPT初稿.pptx
+++ b/docs/ppt/E3-VDT-OOC-答辩PPT初稿.pptx
@@ -2,27 +2,27 @@
 <file path=ppt/presentation.xml><?xml version="1.0" encoding="utf-8"?>
 <p:presentation xmlns:p="http://schemas.openxmlformats.org/presentationml/2006/main">
   <p:sldMasterIdLst>
-    <p:sldMasterId xmlns:r="http://schemas.openxmlformats.org/officeDocument/2006/relationships" id="2147483648" r:id="Rb9b36cdc477341b2"/>
+    <p:sldMasterId xmlns:r="http://schemas.openxmlformats.org/officeDocument/2006/relationships" id="2147483648" r:id="Rb7b9d9d2d1ee493c"/>
   </p:sldMasterIdLst>
   <p:notesMasterIdLst>
-    <p:notesMasterId xmlns:r="http://schemas.openxmlformats.org/officeDocument/2006/relationships" r:id="Rc833cd9d121246e4"/>
+    <p:notesMasterId xmlns:r="http://schemas.openxmlformats.org/officeDocument/2006/relationships" r:id="Rcb6a344045f54afb"/>
   </p:notesMasterIdLst>
   <p:sldIdLst>
-    <p:sldId xmlns:r="http://schemas.openxmlformats.org/officeDocument/2006/relationships" id="256" r:id="Rdeb1b712ab6246a0"/>
-    <p:sldId xmlns:r="http://schemas.openxmlformats.org/officeDocument/2006/relationships" id="257" r:id="R54dd219a177e4e7e"/>
-    <p:sldId xmlns:r="http://schemas.openxmlformats.org/officeDocument/2006/relationships" id="258" r:id="R71fb8a83a5134b8c"/>
-    <p:sldId xmlns:r="http://schemas.openxmlformats.org/officeDocument/2006/relationships" id="259" r:id="R32fda03676cb4686"/>
-    <p:sldId xmlns:r="http://schemas.openxmlformats.org/officeDocument/2006/relationships" id="260" r:id="R46430f30b9a9498f"/>
-    <p:sldId xmlns:r="http://schemas.openxmlformats.org/officeDocument/2006/relationships" id="261" r:id="R0490810819e448f0"/>
-    <p:sldId xmlns:r="http://schemas.openxmlformats.org/officeDocument/2006/relationships" id="262" r:id="Rd927c2d466c64f78"/>
-    <p:sldId xmlns:r="http://schemas.openxmlformats.org/officeDocument/2006/relationships" id="263" r:id="Ra423ca1af409402a"/>
-    <p:sldId xmlns:r="http://schemas.openxmlformats.org/officeDocument/2006/relationships" id="264" r:id="R3dea78a104394e3b"/>
-    <p:sldId xmlns:r="http://schemas.openxmlformats.org/officeDocument/2006/relationships" id="265" r:id="R847796703bbe4bc4"/>
-    <p:sldId xmlns:r="http://schemas.openxmlformats.org/officeDocument/2006/relationships" id="266" r:id="Rf5f480a075084a8c"/>
-    <p:sldId xmlns:r="http://schemas.openxmlformats.org/officeDocument/2006/relationships" id="267" r:id="Ra645df97645749d2"/>
-    <p:sldId xmlns:r="http://schemas.openxmlformats.org/officeDocument/2006/relationships" id="268" r:id="R35f0897c0c38496f"/>
-    <p:sldId xmlns:r="http://schemas.openxmlformats.org/officeDocument/2006/relationships" id="269" r:id="R224b8d8694c54e2c"/>
-    <p:sldId xmlns:r="http://schemas.openxmlformats.org/officeDocument/2006/relationships" id="270" r:id="R717880b4ac274f51"/>
+    <p:sldId xmlns:r="http://schemas.openxmlformats.org/officeDocument/2006/relationships" id="256" r:id="R90a2c6848c60450f"/>
+    <p:sldId xmlns:r="http://schemas.openxmlformats.org/officeDocument/2006/relationships" id="257" r:id="R3156f96c9396422e"/>
+    <p:sldId xmlns:r="http://schemas.openxmlformats.org/officeDocument/2006/relationships" id="258" r:id="Ra1f2d289cbb24f06"/>
+    <p:sldId xmlns:r="http://schemas.openxmlformats.org/officeDocument/2006/relationships" id="259" r:id="Rc3c1e8596bf74abb"/>
+    <p:sldId xmlns:r="http://schemas.openxmlformats.org/officeDocument/2006/relationships" id="260" r:id="R4eee163123b54f23"/>
+    <p:sldId xmlns:r="http://schemas.openxmlformats.org/officeDocument/2006/relationships" id="261" r:id="R2473acb622244853"/>
+    <p:sldId xmlns:r="http://schemas.openxmlformats.org/officeDocument/2006/relationships" id="262" r:id="R26fa128d9eb248d9"/>
+    <p:sldId xmlns:r="http://schemas.openxmlformats.org/officeDocument/2006/relationships" id="263" r:id="R779489e1a2e04a72"/>
+    <p:sldId xmlns:r="http://schemas.openxmlformats.org/officeDocument/2006/relationships" id="264" r:id="R378a4f7ed9224a66"/>
+    <p:sldId xmlns:r="http://schemas.openxmlformats.org/officeDocument/2006/relationships" id="265" r:id="Re45fa3e8d5de4ae2"/>
+    <p:sldId xmlns:r="http://schemas.openxmlformats.org/officeDocument/2006/relationships" id="266" r:id="R43d803e7f0144484"/>
+    <p:sldId xmlns:r="http://schemas.openxmlformats.org/officeDocument/2006/relationships" id="267" r:id="R6c312be7052b435b"/>
+    <p:sldId xmlns:r="http://schemas.openxmlformats.org/officeDocument/2006/relationships" id="268" r:id="Rc32692449bec425e"/>
+    <p:sldId xmlns:r="http://schemas.openxmlformats.org/officeDocument/2006/relationships" id="269" r:id="R31efcfe5878d42cd"/>
+    <p:sldId xmlns:r="http://schemas.openxmlformats.org/officeDocument/2006/relationships" id="270" r:id="Re42399f3d6134536"/>
   </p:sldIdLst>
   <p:sldSz cx="12192000" cy="6858000"/>
   <p:notesSz cx="6858000" cy="9144000"/>
@@ -1539,7 +1539,7 @@
   </p:cSld>
   <p:clrMap bg1="lt1" tx1="dk1" bg2="lt2" tx2="dk2" accent1="accent1" accent2="accent2" accent3="accent3" accent4="accent4" accent5="accent5" accent6="accent6" hlink="hlink" folHlink="folHlink"/>
   <p:sldLayoutIdLst>
-    <p:sldLayoutId xmlns:r="http://schemas.openxmlformats.org/officeDocument/2006/relationships" id="2147483649" r:id="Rc3c0c9f0e627420c"/>
+    <p:sldLayoutId xmlns:r="http://schemas.openxmlformats.org/officeDocument/2006/relationships" id="2147483649" r:id="R42d95a64145a4243"/>
   </p:sldLayoutIdLst>
   <p:txStyles>
     <p:titleStyle>
@@ -2090,7 +2090,7 @@
           <p:cNvPr id="1" name="">
             <a:extLst xmlns:a="http://schemas.openxmlformats.org/drawingml/2006/main">
               <a:ext uri="{FF2B5EF4-FFF2-40B4-BE49-F238E27FC236}">
-                <a16:creationId xmlns:a16="http://schemas.microsoft.com/office/drawing/2014/main" id="{5B894035-1652-4184-B80C-F8DC673478D4}"/>
+                <a16:creationId xmlns:a16="http://schemas.microsoft.com/office/drawing/2014/main" id="{8E618655-BE15-4575-9C73-5D0A68047B27}"/>
               </a:ext>
             </a:extLst>
           </p:cNvPr>
@@ -2121,7 +2121,7 @@
           <p:cNvPr id="2" name="">
             <a:extLst xmlns:a="http://schemas.openxmlformats.org/drawingml/2006/main">
               <a:ext uri="{FF2B5EF4-FFF2-40B4-BE49-F238E27FC236}">
-                <a16:creationId xmlns:a16="http://schemas.microsoft.com/office/drawing/2014/main" id="{9155F9FC-6A6C-4C1B-85EA-AC5A04072E86}"/>
+                <a16:creationId xmlns:a16="http://schemas.microsoft.com/office/drawing/2014/main" id="{1D8951E5-53F4-476D-B912-108038EFA6B7}"/>
               </a:ext>
             </a:extLst>
           </p:cNvPr>
@@ -2152,7 +2152,7 @@
           <p:cNvPr id="3" name="">
             <a:extLst xmlns:a="http://schemas.openxmlformats.org/drawingml/2006/main">
               <a:ext uri="{FF2B5EF4-FFF2-40B4-BE49-F238E27FC236}">
-                <a16:creationId xmlns:a16="http://schemas.microsoft.com/office/drawing/2014/main" id="{CBE38574-8D2F-4918-B5D7-28FCA4E7E4C4}"/>
+                <a16:creationId xmlns:a16="http://schemas.microsoft.com/office/drawing/2014/main" id="{D095990F-0AC1-4EA8-AA2C-A7A668DEB4BB}"/>
               </a:ext>
             </a:extLst>
           </p:cNvPr>
@@ -2202,7 +2202,7 @@
           <p:cNvPr id="4" name="">
             <a:extLst xmlns:a="http://schemas.openxmlformats.org/drawingml/2006/main">
               <a:ext uri="{FF2B5EF4-FFF2-40B4-BE49-F238E27FC236}">
-                <a16:creationId xmlns:a16="http://schemas.microsoft.com/office/drawing/2014/main" id="{EBF42A7D-7FD0-4A7D-81C4-2727AFF01B6F}"/>
+                <a16:creationId xmlns:a16="http://schemas.microsoft.com/office/drawing/2014/main" id="{915D2790-A069-420A-9E54-D3B00E291E57}"/>
               </a:ext>
             </a:extLst>
           </p:cNvPr>
@@ -2269,7 +2269,7 @@
           <p:cNvPr id="5" name="">
             <a:extLst xmlns:a="http://schemas.openxmlformats.org/drawingml/2006/main">
               <a:ext uri="{FF2B5EF4-FFF2-40B4-BE49-F238E27FC236}">
-                <a16:creationId xmlns:a16="http://schemas.microsoft.com/office/drawing/2014/main" id="{D276A461-8C40-4BE2-88F7-7CE87F253D1F}"/>
+                <a16:creationId xmlns:a16="http://schemas.microsoft.com/office/drawing/2014/main" id="{4963C788-8ECE-461B-9E42-457AEEF9105E}"/>
               </a:ext>
             </a:extLst>
           </p:cNvPr>
@@ -2319,7 +2319,7 @@
           <p:cNvPr id="6" name="">
             <a:extLst xmlns:a="http://schemas.openxmlformats.org/drawingml/2006/main">
               <a:ext uri="{FF2B5EF4-FFF2-40B4-BE49-F238E27FC236}">
-                <a16:creationId xmlns:a16="http://schemas.microsoft.com/office/drawing/2014/main" id="{4D8AC592-A444-4F01-B2CE-477101EA1BBC}"/>
+                <a16:creationId xmlns:a16="http://schemas.microsoft.com/office/drawing/2014/main" id="{8F3960E8-75FB-40AE-9706-C3B05787579F}"/>
               </a:ext>
             </a:extLst>
           </p:cNvPr>
@@ -2369,7 +2369,7 @@
           <p:cNvPr id="7" name="">
             <a:extLst xmlns:a="http://schemas.openxmlformats.org/drawingml/2006/main">
               <a:ext uri="{FF2B5EF4-FFF2-40B4-BE49-F238E27FC236}">
-                <a16:creationId xmlns:a16="http://schemas.microsoft.com/office/drawing/2014/main" id="{08C613DA-0096-4AD0-B925-30BC534D6195}"/>
+                <a16:creationId xmlns:a16="http://schemas.microsoft.com/office/drawing/2014/main" id="{2F0A55D2-34C2-4918-9C2B-3730DABF4418}"/>
               </a:ext>
             </a:extLst>
           </p:cNvPr>
@@ -2404,7 +2404,7 @@
           <p:cNvPr id="8" name="">
             <a:extLst xmlns:a="http://schemas.openxmlformats.org/drawingml/2006/main">
               <a:ext uri="{FF2B5EF4-FFF2-40B4-BE49-F238E27FC236}">
-                <a16:creationId xmlns:a16="http://schemas.microsoft.com/office/drawing/2014/main" id="{13B4EEB9-AC1C-46AA-B0C6-5B899D092685}"/>
+                <a16:creationId xmlns:a16="http://schemas.microsoft.com/office/drawing/2014/main" id="{9090E14E-821B-4E91-A2C7-5771E7669C82}"/>
               </a:ext>
             </a:extLst>
           </p:cNvPr>
@@ -2522,7 +2522,7 @@
           <p:cNvPr id="9" name="">
             <a:extLst xmlns:a="http://schemas.openxmlformats.org/drawingml/2006/main">
               <a:ext uri="{FF2B5EF4-FFF2-40B4-BE49-F238E27FC236}">
-                <a16:creationId xmlns:a16="http://schemas.microsoft.com/office/drawing/2014/main" id="{BD6EB965-F9F5-4E89-AD51-B1C39F95F839}"/>
+                <a16:creationId xmlns:a16="http://schemas.microsoft.com/office/drawing/2014/main" id="{5D843FE2-D748-4BAF-BBEA-BE6D600B4E38}"/>
               </a:ext>
             </a:extLst>
           </p:cNvPr>
@@ -2570,7 +2570,7 @@
     </p:spTree>
     <p:extLst>
       <p:ext uri="{BB962C8B-B14F-4D97-AF65-F5344CB8AC3E}">
-        <p14:creationId xmlns:p14="http://schemas.microsoft.com/office/powerpoint/2010/main" val="874911019"/>
+        <p14:creationId xmlns:p14="http://schemas.microsoft.com/office/powerpoint/2010/main" val="1636269012"/>
       </p:ext>
     </p:extLst>
   </p:cSld>
@@ -2601,7 +2601,7 @@
           <p:cNvPr id="1" name="">
             <a:extLst xmlns:a="http://schemas.openxmlformats.org/drawingml/2006/main">
               <a:ext uri="{FF2B5EF4-FFF2-40B4-BE49-F238E27FC236}">
-                <a16:creationId xmlns:a16="http://schemas.microsoft.com/office/drawing/2014/main" id="{07524FF5-F7AA-4AA8-8BB0-F77C03A60920}"/>
+                <a16:creationId xmlns:a16="http://schemas.microsoft.com/office/drawing/2014/main" id="{15EA5C97-2968-4FDD-9EF8-AC835D014E82}"/>
               </a:ext>
             </a:extLst>
           </p:cNvPr>
@@ -2632,7 +2632,7 @@
           <p:cNvPr id="2" name="">
             <a:extLst xmlns:a="http://schemas.openxmlformats.org/drawingml/2006/main">
               <a:ext uri="{FF2B5EF4-FFF2-40B4-BE49-F238E27FC236}">
-                <a16:creationId xmlns:a16="http://schemas.microsoft.com/office/drawing/2014/main" id="{517B6BBB-7895-4EED-9439-282694DA2009}"/>
+                <a16:creationId xmlns:a16="http://schemas.microsoft.com/office/drawing/2014/main" id="{A4FC6229-8113-448B-9E19-F8E12697BE15}"/>
               </a:ext>
             </a:extLst>
           </p:cNvPr>
@@ -2682,7 +2682,7 @@
           <p:cNvPr id="3" name="">
             <a:extLst xmlns:a="http://schemas.openxmlformats.org/drawingml/2006/main">
               <a:ext uri="{FF2B5EF4-FFF2-40B4-BE49-F238E27FC236}">
-                <a16:creationId xmlns:a16="http://schemas.microsoft.com/office/drawing/2014/main" id="{E438042D-7AB0-4258-9909-BCBB196BAD63}"/>
+                <a16:creationId xmlns:a16="http://schemas.microsoft.com/office/drawing/2014/main" id="{E3FD1D40-7207-4F26-8BE8-71B428258938}"/>
               </a:ext>
             </a:extLst>
           </p:cNvPr>
@@ -2732,7 +2732,7 @@
           <p:cNvPr id="4" name="">
             <a:extLst xmlns:a="http://schemas.openxmlformats.org/drawingml/2006/main">
               <a:ext uri="{FF2B5EF4-FFF2-40B4-BE49-F238E27FC236}">
-                <a16:creationId xmlns:a16="http://schemas.microsoft.com/office/drawing/2014/main" id="{336ECF69-53B5-4A10-89E2-DC7AD2441EB6}"/>
+                <a16:creationId xmlns:a16="http://schemas.microsoft.com/office/drawing/2014/main" id="{DD01180C-455D-4230-A119-7DE83724900B}"/>
               </a:ext>
             </a:extLst>
           </p:cNvPr>
@@ -2763,7 +2763,7 @@
           <p:cNvPr id="5" name="footer-10">
             <a:extLst xmlns:a="http://schemas.openxmlformats.org/drawingml/2006/main">
               <a:ext uri="{FF2B5EF4-FFF2-40B4-BE49-F238E27FC236}">
-                <a16:creationId xmlns:a16="http://schemas.microsoft.com/office/drawing/2014/main" id="{8509376E-B4E1-410B-BC25-792826436AAB}"/>
+                <a16:creationId xmlns:a16="http://schemas.microsoft.com/office/drawing/2014/main" id="{270D5566-C16E-4B71-B60D-E54C269F3A3E}"/>
               </a:ext>
             </a:extLst>
           </p:cNvPr>
@@ -2813,7 +2813,7 @@
           <p:cNvPr id="6" name="">
             <a:extLst xmlns:a="http://schemas.openxmlformats.org/drawingml/2006/main">
               <a:ext uri="{FF2B5EF4-FFF2-40B4-BE49-F238E27FC236}">
-                <a16:creationId xmlns:a16="http://schemas.microsoft.com/office/drawing/2014/main" id="{84F52515-0439-4F99-88B8-1CD6A44F5B35}"/>
+                <a16:creationId xmlns:a16="http://schemas.microsoft.com/office/drawing/2014/main" id="{372865BE-16E1-4048-A4DD-1EFD86DE4306}"/>
               </a:ext>
             </a:extLst>
           </p:cNvPr>
@@ -2846,7 +2846,7 @@
           <p:cNvPr id="7" name="">
             <a:extLst xmlns:a="http://schemas.openxmlformats.org/drawingml/2006/main">
               <a:ext uri="{FF2B5EF4-FFF2-40B4-BE49-F238E27FC236}">
-                <a16:creationId xmlns:a16="http://schemas.microsoft.com/office/drawing/2014/main" id="{5B075ABE-691B-4D17-9F5D-ECA8D252151E}"/>
+                <a16:creationId xmlns:a16="http://schemas.microsoft.com/office/drawing/2014/main" id="{BE7A9341-0504-4EE1-BBCA-86F169FB8C6C}"/>
               </a:ext>
             </a:extLst>
           </p:cNvPr>
@@ -3015,7 +3015,7 @@
           <p:cNvPr id="8" name="">
             <a:extLst xmlns:a="http://schemas.openxmlformats.org/drawingml/2006/main">
               <a:ext uri="{FF2B5EF4-FFF2-40B4-BE49-F238E27FC236}">
-                <a16:creationId xmlns:a16="http://schemas.microsoft.com/office/drawing/2014/main" id="{45090909-1A07-4F86-8B4B-37874D680B22}"/>
+                <a16:creationId xmlns:a16="http://schemas.microsoft.com/office/drawing/2014/main" id="{DCC257E5-5F56-49B5-A430-819F6244042F}"/>
               </a:ext>
             </a:extLst>
           </p:cNvPr>
@@ -3065,7 +3065,7 @@
           <p:cNvPr id="9" name="">
             <a:extLst xmlns:a="http://schemas.openxmlformats.org/drawingml/2006/main">
               <a:ext uri="{FF2B5EF4-FFF2-40B4-BE49-F238E27FC236}">
-                <a16:creationId xmlns:a16="http://schemas.microsoft.com/office/drawing/2014/main" id="{157E8FAF-7991-41D9-95E5-6BCBF3CC5210}"/>
+                <a16:creationId xmlns:a16="http://schemas.microsoft.com/office/drawing/2014/main" id="{3FBAB9D5-27B1-4F58-965F-955122345AD8}"/>
               </a:ext>
             </a:extLst>
           </p:cNvPr>
@@ -3164,7 +3164,7 @@
     </p:spTree>
     <p:extLst>
       <p:ext uri="{BB962C8B-B14F-4D97-AF65-F5344CB8AC3E}">
-        <p14:creationId xmlns:p14="http://schemas.microsoft.com/office/powerpoint/2010/main" val="320608163"/>
+        <p14:creationId xmlns:p14="http://schemas.microsoft.com/office/powerpoint/2010/main" val="1406626911"/>
       </p:ext>
     </p:extLst>
   </p:cSld>
@@ -3195,7 +3195,7 @@
           <p:cNvPr id="1" name="">
             <a:extLst xmlns:a="http://schemas.openxmlformats.org/drawingml/2006/main">
               <a:ext uri="{FF2B5EF4-FFF2-40B4-BE49-F238E27FC236}">
-                <a16:creationId xmlns:a16="http://schemas.microsoft.com/office/drawing/2014/main" id="{837572EC-FB98-49E6-A6E6-5968E82A53C2}"/>
+                <a16:creationId xmlns:a16="http://schemas.microsoft.com/office/drawing/2014/main" id="{69DE3333-3595-4B63-880B-398A3A4D77BE}"/>
               </a:ext>
             </a:extLst>
           </p:cNvPr>
@@ -3226,7 +3226,7 @@
           <p:cNvPr id="2" name="">
             <a:extLst xmlns:a="http://schemas.openxmlformats.org/drawingml/2006/main">
               <a:ext uri="{FF2B5EF4-FFF2-40B4-BE49-F238E27FC236}">
-                <a16:creationId xmlns:a16="http://schemas.microsoft.com/office/drawing/2014/main" id="{A526FC30-76D2-4305-ACBA-FAD4AD5ECC5B}"/>
+                <a16:creationId xmlns:a16="http://schemas.microsoft.com/office/drawing/2014/main" id="{B64AB67D-F6B3-4B1D-A259-D76E2C0084DD}"/>
               </a:ext>
             </a:extLst>
           </p:cNvPr>
@@ -3276,7 +3276,7 @@
           <p:cNvPr id="3" name="">
             <a:extLst xmlns:a="http://schemas.openxmlformats.org/drawingml/2006/main">
               <a:ext uri="{FF2B5EF4-FFF2-40B4-BE49-F238E27FC236}">
-                <a16:creationId xmlns:a16="http://schemas.microsoft.com/office/drawing/2014/main" id="{9C5BBB83-6511-4735-900F-E36AD2E65318}"/>
+                <a16:creationId xmlns:a16="http://schemas.microsoft.com/office/drawing/2014/main" id="{86E1C140-31A5-4591-AF6C-11ADA7EE713B}"/>
               </a:ext>
             </a:extLst>
           </p:cNvPr>
@@ -3326,7 +3326,7 @@
           <p:cNvPr id="4" name="">
             <a:extLst xmlns:a="http://schemas.openxmlformats.org/drawingml/2006/main">
               <a:ext uri="{FF2B5EF4-FFF2-40B4-BE49-F238E27FC236}">
-                <a16:creationId xmlns:a16="http://schemas.microsoft.com/office/drawing/2014/main" id="{68C691C4-48D9-4370-8511-5115F8038332}"/>
+                <a16:creationId xmlns:a16="http://schemas.microsoft.com/office/drawing/2014/main" id="{35CCA39A-7286-4D15-844C-B33291D805A3}"/>
               </a:ext>
             </a:extLst>
           </p:cNvPr>
@@ -3357,7 +3357,7 @@
           <p:cNvPr id="5" name="footer-11">
             <a:extLst xmlns:a="http://schemas.openxmlformats.org/drawingml/2006/main">
               <a:ext uri="{FF2B5EF4-FFF2-40B4-BE49-F238E27FC236}">
-                <a16:creationId xmlns:a16="http://schemas.microsoft.com/office/drawing/2014/main" id="{BFE01FF8-3A23-40D3-AB48-10BA1994DC88}"/>
+                <a16:creationId xmlns:a16="http://schemas.microsoft.com/office/drawing/2014/main" id="{0135C48D-D40C-4FEC-A663-3115E5B13D4D}"/>
               </a:ext>
             </a:extLst>
           </p:cNvPr>
@@ -3407,7 +3407,7 @@
           <p:cNvPr id="6" name="">
             <a:extLst xmlns:a="http://schemas.openxmlformats.org/drawingml/2006/main">
               <a:ext uri="{FF2B5EF4-FFF2-40B4-BE49-F238E27FC236}">
-                <a16:creationId xmlns:a16="http://schemas.microsoft.com/office/drawing/2014/main" id="{A4696E9F-494C-40CE-A72C-6C1157795E4C}"/>
+                <a16:creationId xmlns:a16="http://schemas.microsoft.com/office/drawing/2014/main" id="{CB6FD123-87B0-42C8-AB32-C07017C65929}"/>
               </a:ext>
             </a:extLst>
           </p:cNvPr>
@@ -3442,7 +3442,7 @@
           <p:cNvPr id="7" name="">
             <a:extLst xmlns:a="http://schemas.openxmlformats.org/drawingml/2006/main">
               <a:ext uri="{FF2B5EF4-FFF2-40B4-BE49-F238E27FC236}">
-                <a16:creationId xmlns:a16="http://schemas.microsoft.com/office/drawing/2014/main" id="{5AA61BFF-1473-4E1A-87F7-C3FC419E7C83}"/>
+                <a16:creationId xmlns:a16="http://schemas.microsoft.com/office/drawing/2014/main" id="{192614B3-0E15-4EED-83E8-764A78CCDF6D}"/>
               </a:ext>
             </a:extLst>
           </p:cNvPr>
@@ -3492,7 +3492,7 @@
           <p:cNvPr id="8" name="">
             <a:extLst xmlns:a="http://schemas.openxmlformats.org/drawingml/2006/main">
               <a:ext uri="{FF2B5EF4-FFF2-40B4-BE49-F238E27FC236}">
-                <a16:creationId xmlns:a16="http://schemas.microsoft.com/office/drawing/2014/main" id="{3011DE5E-1162-4FE6-A401-F578F1AF1E09}"/>
+                <a16:creationId xmlns:a16="http://schemas.microsoft.com/office/drawing/2014/main" id="{B03DAC69-2710-42E4-9A78-C9AEF7DB6B9E}"/>
               </a:ext>
             </a:extLst>
           </p:cNvPr>
@@ -3593,7 +3593,7 @@
           <p:cNvPr id="9" name="">
             <a:extLst xmlns:a="http://schemas.openxmlformats.org/drawingml/2006/main">
               <a:ext uri="{FF2B5EF4-FFF2-40B4-BE49-F238E27FC236}">
-                <a16:creationId xmlns:a16="http://schemas.microsoft.com/office/drawing/2014/main" id="{AA59BE28-1030-42C1-B80D-F5F873FB9CCD}"/>
+                <a16:creationId xmlns:a16="http://schemas.microsoft.com/office/drawing/2014/main" id="{9F59E663-6C27-43FB-9F0E-1BC2D2E3C532}"/>
               </a:ext>
             </a:extLst>
           </p:cNvPr>
@@ -3628,7 +3628,7 @@
           <p:cNvPr id="10" name="">
             <a:extLst xmlns:a="http://schemas.openxmlformats.org/drawingml/2006/main">
               <a:ext uri="{FF2B5EF4-FFF2-40B4-BE49-F238E27FC236}">
-                <a16:creationId xmlns:a16="http://schemas.microsoft.com/office/drawing/2014/main" id="{88ABA95B-B538-45C6-BF68-3CE00099F1B2}"/>
+                <a16:creationId xmlns:a16="http://schemas.microsoft.com/office/drawing/2014/main" id="{97B4C240-D1B4-4D72-ADD1-00BB6FF88A2C}"/>
               </a:ext>
             </a:extLst>
           </p:cNvPr>
@@ -3678,7 +3678,7 @@
           <p:cNvPr id="11" name="">
             <a:extLst xmlns:a="http://schemas.openxmlformats.org/drawingml/2006/main">
               <a:ext uri="{FF2B5EF4-FFF2-40B4-BE49-F238E27FC236}">
-                <a16:creationId xmlns:a16="http://schemas.microsoft.com/office/drawing/2014/main" id="{FD31B269-6746-48D4-9FBA-E65844B78829}"/>
+                <a16:creationId xmlns:a16="http://schemas.microsoft.com/office/drawing/2014/main" id="{107287AF-2B83-4271-B92F-47F54EB3B2C8}"/>
               </a:ext>
             </a:extLst>
           </p:cNvPr>
@@ -3777,7 +3777,7 @@
     </p:spTree>
     <p:extLst>
       <p:ext uri="{BB962C8B-B14F-4D97-AF65-F5344CB8AC3E}">
-        <p14:creationId xmlns:p14="http://schemas.microsoft.com/office/powerpoint/2010/main" val="138378098"/>
+        <p14:creationId xmlns:p14="http://schemas.microsoft.com/office/powerpoint/2010/main" val="1867750812"/>
       </p:ext>
     </p:extLst>
   </p:cSld>
@@ -3808,7 +3808,7 @@
           <p:cNvPr id="1" name="">
             <a:extLst xmlns:a="http://schemas.openxmlformats.org/drawingml/2006/main">
               <a:ext uri="{FF2B5EF4-FFF2-40B4-BE49-F238E27FC236}">
-                <a16:creationId xmlns:a16="http://schemas.microsoft.com/office/drawing/2014/main" id="{6DE786F9-C2B1-45B7-A90B-0722A1D9672C}"/>
+                <a16:creationId xmlns:a16="http://schemas.microsoft.com/office/drawing/2014/main" id="{96637B95-8EF8-4A28-8831-BDE4BAE6C810}"/>
               </a:ext>
             </a:extLst>
           </p:cNvPr>
@@ -3839,7 +3839,7 @@
           <p:cNvPr id="2" name="">
             <a:extLst xmlns:a="http://schemas.openxmlformats.org/drawingml/2006/main">
               <a:ext uri="{FF2B5EF4-FFF2-40B4-BE49-F238E27FC236}">
-                <a16:creationId xmlns:a16="http://schemas.microsoft.com/office/drawing/2014/main" id="{BC8F0C3D-CCC4-4CCB-9C1A-BC0ED4ED13F4}"/>
+                <a16:creationId xmlns:a16="http://schemas.microsoft.com/office/drawing/2014/main" id="{5EA08640-8660-4948-845B-8A862B2BECA2}"/>
               </a:ext>
             </a:extLst>
           </p:cNvPr>
@@ -3889,7 +3889,7 @@
           <p:cNvPr id="3" name="">
             <a:extLst xmlns:a="http://schemas.openxmlformats.org/drawingml/2006/main">
               <a:ext uri="{FF2B5EF4-FFF2-40B4-BE49-F238E27FC236}">
-                <a16:creationId xmlns:a16="http://schemas.microsoft.com/office/drawing/2014/main" id="{71533D07-1431-4436-B704-AF14476A37EB}"/>
+                <a16:creationId xmlns:a16="http://schemas.microsoft.com/office/drawing/2014/main" id="{7D7CF61C-15AC-42C3-8160-C1543BB27948}"/>
               </a:ext>
             </a:extLst>
           </p:cNvPr>
@@ -3929,7 +3929,7 @@
                   <a:srgbClr val="0B1220"/>
                 </a:solidFill>
               </a:rPr>
-              <a:t>当前复现结果：已有可汇报 VDT baseline</a:t>
+              <a:t>当前复现结果：两组 VDT baseline 已完成</a:t>
             </a:r>
           </a:p>
         </p:txBody>
@@ -3939,7 +3939,7 @@
           <p:cNvPr id="4" name="">
             <a:extLst xmlns:a="http://schemas.openxmlformats.org/drawingml/2006/main">
               <a:ext uri="{FF2B5EF4-FFF2-40B4-BE49-F238E27FC236}">
-                <a16:creationId xmlns:a16="http://schemas.microsoft.com/office/drawing/2014/main" id="{D97A6DF2-3F1B-408C-AFFF-BB8B27212D58}"/>
+                <a16:creationId xmlns:a16="http://schemas.microsoft.com/office/drawing/2014/main" id="{BBB2B76D-1248-48E4-A3B8-AC09F00B7F24}"/>
               </a:ext>
             </a:extLst>
           </p:cNvPr>
@@ -3970,7 +3970,7 @@
           <p:cNvPr id="5" name="footer-12">
             <a:extLst xmlns:a="http://schemas.openxmlformats.org/drawingml/2006/main">
               <a:ext uri="{FF2B5EF4-FFF2-40B4-BE49-F238E27FC236}">
-                <a16:creationId xmlns:a16="http://schemas.microsoft.com/office/drawing/2014/main" id="{9402E720-7F35-462C-8DA7-34D26BE92D4B}"/>
+                <a16:creationId xmlns:a16="http://schemas.microsoft.com/office/drawing/2014/main" id="{847428FD-11CC-480E-AA93-8785899E9DB6}"/>
               </a:ext>
             </a:extLst>
           </p:cNvPr>
@@ -4020,7 +4020,7 @@
           <p:cNvPr id="6" name="">
             <a:extLst xmlns:a="http://schemas.openxmlformats.org/drawingml/2006/main">
               <a:ext uri="{FF2B5EF4-FFF2-40B4-BE49-F238E27FC236}">
-                <a16:creationId xmlns:a16="http://schemas.microsoft.com/office/drawing/2014/main" id="{F995FF62-7FFD-4D39-B14F-128DDBE8535E}"/>
+                <a16:creationId xmlns:a16="http://schemas.microsoft.com/office/drawing/2014/main" id="{30E8BCFA-D473-4C03-9270-2A0F915B78C1}"/>
               </a:ext>
             </a:extLst>
           </p:cNvPr>
@@ -4055,7 +4055,7 @@
           <p:cNvPr id="7" name="">
             <a:extLst xmlns:a="http://schemas.openxmlformats.org/drawingml/2006/main">
               <a:ext uri="{FF2B5EF4-FFF2-40B4-BE49-F238E27FC236}">
-                <a16:creationId xmlns:a16="http://schemas.microsoft.com/office/drawing/2014/main" id="{98CA05D8-8930-4A3D-B6E8-352CE5EC1F3C}"/>
+                <a16:creationId xmlns:a16="http://schemas.microsoft.com/office/drawing/2014/main" id="{FE518FCB-15B6-4542-9DF4-76C5BE097CBF}"/>
               </a:ext>
             </a:extLst>
           </p:cNvPr>
@@ -4105,7 +4105,7 @@
           <p:cNvPr id="8" name="">
             <a:extLst xmlns:a="http://schemas.openxmlformats.org/drawingml/2006/main">
               <a:ext uri="{FF2B5EF4-FFF2-40B4-BE49-F238E27FC236}">
-                <a16:creationId xmlns:a16="http://schemas.microsoft.com/office/drawing/2014/main" id="{43EE3D3F-5AF4-4540-9908-19468FDD49E1}"/>
+                <a16:creationId xmlns:a16="http://schemas.microsoft.com/office/drawing/2014/main" id="{3B4DDDAE-849A-4C59-99D8-EA1EBE4E4E6B}"/>
               </a:ext>
             </a:extLst>
           </p:cNvPr>
@@ -4155,7 +4155,7 @@
           <p:cNvPr id="9" name="">
             <a:extLst xmlns:a="http://schemas.openxmlformats.org/drawingml/2006/main">
               <a:ext uri="{FF2B5EF4-FFF2-40B4-BE49-F238E27FC236}">
-                <a16:creationId xmlns:a16="http://schemas.microsoft.com/office/drawing/2014/main" id="{BF64E8EF-63A5-4FA9-98BA-71B4A7E090BC}"/>
+                <a16:creationId xmlns:a16="http://schemas.microsoft.com/office/drawing/2014/main" id="{7E9319D3-2F0A-4F23-AE87-F737EB323A63}"/>
               </a:ext>
             </a:extLst>
           </p:cNvPr>
@@ -4205,7 +4205,7 @@
           <p:cNvPr id="10" name="">
             <a:extLst xmlns:a="http://schemas.openxmlformats.org/drawingml/2006/main">
               <a:ext uri="{FF2B5EF4-FFF2-40B4-BE49-F238E27FC236}">
-                <a16:creationId xmlns:a16="http://schemas.microsoft.com/office/drawing/2014/main" id="{03052495-7299-4598-A408-4B691FE270E9}"/>
+                <a16:creationId xmlns:a16="http://schemas.microsoft.com/office/drawing/2014/main" id="{1E122815-5E9D-45AC-AFD6-E1FF9C14C841}"/>
               </a:ext>
             </a:extLst>
           </p:cNvPr>
@@ -4255,7 +4255,7 @@
           <p:cNvPr id="11" name="">
             <a:extLst xmlns:a="http://schemas.openxmlformats.org/drawingml/2006/main">
               <a:ext uri="{FF2B5EF4-FFF2-40B4-BE49-F238E27FC236}">
-                <a16:creationId xmlns:a16="http://schemas.microsoft.com/office/drawing/2014/main" id="{5E91800B-D647-4B4A-9495-222B6174C2C8}"/>
+                <a16:creationId xmlns:a16="http://schemas.microsoft.com/office/drawing/2014/main" id="{104DC64F-AC56-425B-BCB5-DC8427A2D98E}"/>
               </a:ext>
             </a:extLst>
           </p:cNvPr>
@@ -4305,7 +4305,7 @@
           <p:cNvPr id="12" name="">
             <a:extLst xmlns:a="http://schemas.openxmlformats.org/drawingml/2006/main">
               <a:ext uri="{FF2B5EF4-FFF2-40B4-BE49-F238E27FC236}">
-                <a16:creationId xmlns:a16="http://schemas.microsoft.com/office/drawing/2014/main" id="{CDCB5C80-A6DC-46DD-9C03-A3A518590BAA}"/>
+                <a16:creationId xmlns:a16="http://schemas.microsoft.com/office/drawing/2014/main" id="{1C55662E-0E92-46C7-8CE6-8E6D02B121BC}"/>
               </a:ext>
             </a:extLst>
           </p:cNvPr>
@@ -4355,7 +4355,7 @@
           <p:cNvPr id="13" name="">
             <a:extLst xmlns:a="http://schemas.openxmlformats.org/drawingml/2006/main">
               <a:ext uri="{FF2B5EF4-FFF2-40B4-BE49-F238E27FC236}">
-                <a16:creationId xmlns:a16="http://schemas.microsoft.com/office/drawing/2014/main" id="{C2F62D7F-A280-4A72-BA5F-57E285C1A9D4}"/>
+                <a16:creationId xmlns:a16="http://schemas.microsoft.com/office/drawing/2014/main" id="{6E4BE632-D4B5-438A-AE6D-AE8AA8827F85}"/>
               </a:ext>
             </a:extLst>
           </p:cNvPr>
@@ -4405,7 +4405,7 @@
           <p:cNvPr id="14" name="">
             <a:extLst xmlns:a="http://schemas.openxmlformats.org/drawingml/2006/main">
               <a:ext uri="{FF2B5EF4-FFF2-40B4-BE49-F238E27FC236}">
-                <a16:creationId xmlns:a16="http://schemas.microsoft.com/office/drawing/2014/main" id="{5AF89871-6A48-430D-AC81-3AAFFF3CDDE5}"/>
+                <a16:creationId xmlns:a16="http://schemas.microsoft.com/office/drawing/2014/main" id="{4FA91E7F-6203-4050-A782-D4E7C67C75BE}"/>
               </a:ext>
             </a:extLst>
           </p:cNvPr>
@@ -4455,47 +4455,64 @@
           <p:cNvPr id="15" name="">
             <a:extLst xmlns:a="http://schemas.openxmlformats.org/drawingml/2006/main">
               <a:ext uri="{FF2B5EF4-FFF2-40B4-BE49-F238E27FC236}">
-                <a16:creationId xmlns:a16="http://schemas.microsoft.com/office/drawing/2014/main" id="{112B560F-9748-4A94-B112-C596DDF36188}"/>
-              </a:ext>
-            </a:extLst>
-          </p:cNvPr>
-          <p:cNvSpPr>
-            <a:spLocks xmlns:a="http://schemas.openxmlformats.org/drawingml/2006/main" noGrp="1"/>
-          </p:cNvSpPr>
-          <p:nvPr/>
-        </p:nvSpPr>
-        <p:spPr>
-          <a:xfrm xmlns:a="http://schemas.openxmlformats.org/drawingml/2006/main">
-            <a:off x="876300" y="4810125"/>
-            <a:ext cx="9906000" cy="419100"/>
-          </a:xfrm>
-          <a:prstGeom xmlns:a="http://schemas.openxmlformats.org/drawingml/2006/main" prst="rect">
-            <a:avLst/>
-          </a:prstGeom>
-          <a:noFill xmlns:a="http://schemas.openxmlformats.org/drawingml/2006/main"/>
-          <a:ln xmlns:a="http://schemas.openxmlformats.org/drawingml/2006/main" w="0">
-            <a:noFill/>
-            <a:prstDash val="solid"/>
-          </a:ln>
-        </p:spPr>
-        <p:txBody>
-          <a:bodyPr xmlns:a="http://schemas.openxmlformats.org/drawingml/2006/main"/>
-          <a:lstStyle xmlns:a="http://schemas.openxmlformats.org/drawingml/2006/main"/>
-          <a:p xmlns:a="http://schemas.openxmlformats.org/drawingml/2006/main">
-            <a:pPr algn="l">
-              <a:defRPr sz="1950" b="1">
-                <a:solidFill>
-                  <a:srgbClr val="0B1220"/>
-                </a:solidFill>
-              </a:defRPr>
-            </a:pPr>
-            <a:r>
-              <a:rPr sz="1950" b="1">
-                <a:solidFill>
-                  <a:srgbClr val="0B1220"/>
-                </a:solidFill>
-              </a:rPr>
-              <a:t>第二组 usa_today,washington_post bs64 running_partial：F1=0.8013，Acc=0.8017，AUC=0.8006；最终以进程结束后日志为准。</a:t>
+                <a16:creationId xmlns:a16="http://schemas.microsoft.com/office/drawing/2014/main" id="{EBD19984-5B15-4834-8975-3C7347AD1BA1}"/>
+              </a:ext>
+            </a:extLst>
+          </p:cNvPr>
+          <p:cNvSpPr>
+            <a:spLocks xmlns:a="http://schemas.openxmlformats.org/drawingml/2006/main" noGrp="1"/>
+          </p:cNvSpPr>
+          <p:nvPr/>
+        </p:nvSpPr>
+        <p:spPr>
+          <a:xfrm xmlns:a="http://schemas.openxmlformats.org/drawingml/2006/main">
+            <a:off x="876300" y="4686300"/>
+            <a:ext cx="9906000" cy="704850"/>
+          </a:xfrm>
+          <a:prstGeom xmlns:a="http://schemas.openxmlformats.org/drawingml/2006/main" prst="rect">
+            <a:avLst/>
+          </a:prstGeom>
+          <a:noFill xmlns:a="http://schemas.openxmlformats.org/drawingml/2006/main"/>
+          <a:ln xmlns:a="http://schemas.openxmlformats.org/drawingml/2006/main" w="0">
+            <a:noFill/>
+            <a:prstDash val="solid"/>
+          </a:ln>
+        </p:spPr>
+        <p:txBody>
+          <a:bodyPr xmlns:a="http://schemas.openxmlformats.org/drawingml/2006/main"/>
+          <a:lstStyle xmlns:a="http://schemas.openxmlformats.org/drawingml/2006/main"/>
+          <a:p xmlns:a="http://schemas.openxmlformats.org/drawingml/2006/main">
+            <a:pPr algn="l">
+              <a:defRPr sz="1800" b="1">
+                <a:solidFill>
+                  <a:srgbClr val="0B1220"/>
+                </a:solidFill>
+              </a:defRPr>
+            </a:pPr>
+            <a:r>
+              <a:rPr sz="1800" b="1">
+                <a:solidFill>
+                  <a:srgbClr val="0B1220"/>
+                </a:solidFill>
+              </a:rPr>
+              <a:t>第二组 usa_today,washington_post bs64 completed：F1=0.8032，Acc=0.8032，AUC=0.8028；</a:t>
+            </a:r>
+          </a:p>
+          <a:p xmlns:a="http://schemas.openxmlformats.org/drawingml/2006/main">
+            <a:pPr algn="l">
+              <a:defRPr sz="1800" b="1">
+                <a:solidFill>
+                  <a:srgbClr val="0B1220"/>
+                </a:solidFill>
+              </a:defRPr>
+            </a:pPr>
+            <a:r>
+              <a:rPr sz="1800" b="1">
+                <a:solidFill>
+                  <a:srgbClr val="0B1220"/>
+                </a:solidFill>
+              </a:rPr>
+              <a:t>13 个 validation blocks，最佳来自第 9 个 block。</a:t>
             </a:r>
           </a:p>
         </p:txBody>
@@ -4505,18 +4522,18 @@
           <p:cNvPr id="16" name="">
             <a:extLst xmlns:a="http://schemas.openxmlformats.org/drawingml/2006/main">
               <a:ext uri="{FF2B5EF4-FFF2-40B4-BE49-F238E27FC236}">
-                <a16:creationId xmlns:a16="http://schemas.microsoft.com/office/drawing/2014/main" id="{ED93DDFF-9257-42C7-9D4D-1DFA13301841}"/>
-              </a:ext>
-            </a:extLst>
-          </p:cNvPr>
-          <p:cNvSpPr>
-            <a:spLocks xmlns:a="http://schemas.openxmlformats.org/drawingml/2006/main" noGrp="1"/>
-          </p:cNvSpPr>
-          <p:nvPr/>
-        </p:nvSpPr>
-        <p:spPr>
-          <a:xfrm xmlns:a="http://schemas.openxmlformats.org/drawingml/2006/main">
-            <a:off x="876300" y="5381625"/>
+                <a16:creationId xmlns:a16="http://schemas.microsoft.com/office/drawing/2014/main" id="{320FFCBC-9E1C-4610-8ED3-8DDC7D27773C}"/>
+              </a:ext>
+            </a:extLst>
+          </p:cNvPr>
+          <p:cNvSpPr>
+            <a:spLocks xmlns:a="http://schemas.openxmlformats.org/drawingml/2006/main" noGrp="1"/>
+          </p:cNvSpPr>
+          <p:nvPr/>
+        </p:nvSpPr>
+        <p:spPr>
+          <a:xfrm xmlns:a="http://schemas.openxmlformats.org/drawingml/2006/main">
+            <a:off x="876300" y="5734050"/>
             <a:ext cx="9906000" cy="342900"/>
           </a:xfrm>
           <a:prstGeom xmlns:a="http://schemas.openxmlformats.org/drawingml/2006/main" prst="rect">
@@ -4533,19 +4550,19 @@
           <a:lstStyle xmlns:a="http://schemas.openxmlformats.org/drawingml/2006/main"/>
           <a:p xmlns:a="http://schemas.openxmlformats.org/drawingml/2006/main">
             <a:pPr algn="l">
-              <a:defRPr sz="1650" b="1">
+              <a:defRPr sz="1575" b="1">
                 <a:solidFill>
                   <a:srgbClr val="DC2626"/>
                 </a:solidFill>
               </a:defRPr>
             </a:pPr>
             <a:r>
-              <a:rPr sz="1650" b="1">
+              <a:rPr sz="1575" b="1">
                 <a:solidFill>
                   <a:srgbClr val="DC2626"/>
                 </a:solidFill>
               </a:rPr>
-              <a:t>注意：目前是核心 strict setting 复现，不夸大为完整论文所有设置全部复现。</a:t>
+              <a:t>注意：这是核心 strict setting 复现；bs128 OOM 作为硬件约束记录，不夸大为论文全部设置。</a:t>
             </a:r>
           </a:p>
         </p:txBody>
@@ -4553,7 +4570,7 @@
     </p:spTree>
     <p:extLst>
       <p:ext uri="{BB962C8B-B14F-4D97-AF65-F5344CB8AC3E}">
-        <p14:creationId xmlns:p14="http://schemas.microsoft.com/office/powerpoint/2010/main" val="184946464"/>
+        <p14:creationId xmlns:p14="http://schemas.microsoft.com/office/powerpoint/2010/main" val="300393818"/>
       </p:ext>
     </p:extLst>
   </p:cSld>
@@ -4584,7 +4601,7 @@
           <p:cNvPr id="1" name="">
             <a:extLst xmlns:a="http://schemas.openxmlformats.org/drawingml/2006/main">
               <a:ext uri="{FF2B5EF4-FFF2-40B4-BE49-F238E27FC236}">
-                <a16:creationId xmlns:a16="http://schemas.microsoft.com/office/drawing/2014/main" id="{D4589B04-5A83-4D01-AC4C-C82C783662DE}"/>
+                <a16:creationId xmlns:a16="http://schemas.microsoft.com/office/drawing/2014/main" id="{1B929064-736C-4702-9175-4F193DCEE66B}"/>
               </a:ext>
             </a:extLst>
           </p:cNvPr>
@@ -4615,7 +4632,7 @@
           <p:cNvPr id="2" name="">
             <a:extLst xmlns:a="http://schemas.openxmlformats.org/drawingml/2006/main">
               <a:ext uri="{FF2B5EF4-FFF2-40B4-BE49-F238E27FC236}">
-                <a16:creationId xmlns:a16="http://schemas.microsoft.com/office/drawing/2014/main" id="{324BA72D-5D83-4C19-8EC9-4794A0086A34}"/>
+                <a16:creationId xmlns:a16="http://schemas.microsoft.com/office/drawing/2014/main" id="{ED772DEE-453E-415A-8EA0-7A60C56F1240}"/>
               </a:ext>
             </a:extLst>
           </p:cNvPr>
@@ -4665,7 +4682,7 @@
           <p:cNvPr id="3" name="">
             <a:extLst xmlns:a="http://schemas.openxmlformats.org/drawingml/2006/main">
               <a:ext uri="{FF2B5EF4-FFF2-40B4-BE49-F238E27FC236}">
-                <a16:creationId xmlns:a16="http://schemas.microsoft.com/office/drawing/2014/main" id="{F817B52A-E52A-4909-B178-5C0644D63D02}"/>
+                <a16:creationId xmlns:a16="http://schemas.microsoft.com/office/drawing/2014/main" id="{9E0B8EF0-C4C9-4E2B-91C3-AD2FFAF9F8AF}"/>
               </a:ext>
             </a:extLst>
           </p:cNvPr>
@@ -4715,7 +4732,7 @@
           <p:cNvPr id="4" name="">
             <a:extLst xmlns:a="http://schemas.openxmlformats.org/drawingml/2006/main">
               <a:ext uri="{FF2B5EF4-FFF2-40B4-BE49-F238E27FC236}">
-                <a16:creationId xmlns:a16="http://schemas.microsoft.com/office/drawing/2014/main" id="{F3C9D148-193B-4A7E-AECF-EF88B7D28802}"/>
+                <a16:creationId xmlns:a16="http://schemas.microsoft.com/office/drawing/2014/main" id="{994F2E51-31EF-454A-AE1C-15E4E8D4DB89}"/>
               </a:ext>
             </a:extLst>
           </p:cNvPr>
@@ -4746,7 +4763,7 @@
           <p:cNvPr id="5" name="footer-13">
             <a:extLst xmlns:a="http://schemas.openxmlformats.org/drawingml/2006/main">
               <a:ext uri="{FF2B5EF4-FFF2-40B4-BE49-F238E27FC236}">
-                <a16:creationId xmlns:a16="http://schemas.microsoft.com/office/drawing/2014/main" id="{13E951DF-8ABA-4AA8-95E1-FA0DC4B06C6E}"/>
+                <a16:creationId xmlns:a16="http://schemas.microsoft.com/office/drawing/2014/main" id="{95C97BC7-F183-4582-B597-ABC158266345}"/>
               </a:ext>
             </a:extLst>
           </p:cNvPr>
@@ -4796,7 +4813,7 @@
           <p:cNvPr id="6" name="">
             <a:extLst xmlns:a="http://schemas.openxmlformats.org/drawingml/2006/main">
               <a:ext uri="{FF2B5EF4-FFF2-40B4-BE49-F238E27FC236}">
-                <a16:creationId xmlns:a16="http://schemas.microsoft.com/office/drawing/2014/main" id="{FDF41ABA-840D-4BC2-A49D-27024AC06132}"/>
+                <a16:creationId xmlns:a16="http://schemas.microsoft.com/office/drawing/2014/main" id="{564998F0-DBD7-44EA-A5AF-82BD39945189}"/>
               </a:ext>
             </a:extLst>
           </p:cNvPr>
@@ -4846,7 +4863,7 @@
           <p:cNvPr id="7" name="">
             <a:extLst xmlns:a="http://schemas.openxmlformats.org/drawingml/2006/main">
               <a:ext uri="{FF2B5EF4-FFF2-40B4-BE49-F238E27FC236}">
-                <a16:creationId xmlns:a16="http://schemas.microsoft.com/office/drawing/2014/main" id="{0DFF0E3C-A1A4-48DA-9BCA-65AFB8DCEBB7}"/>
+                <a16:creationId xmlns:a16="http://schemas.microsoft.com/office/drawing/2014/main" id="{7BC691DD-3981-4903-9388-3088A7E2D695}"/>
               </a:ext>
             </a:extLst>
           </p:cNvPr>
@@ -4896,7 +4913,7 @@
           <p:cNvPr id="8" name="">
             <a:extLst xmlns:a="http://schemas.openxmlformats.org/drawingml/2006/main">
               <a:ext uri="{FF2B5EF4-FFF2-40B4-BE49-F238E27FC236}">
-                <a16:creationId xmlns:a16="http://schemas.microsoft.com/office/drawing/2014/main" id="{E8D86486-5694-4665-8B31-0BE9E9AA6349}"/>
+                <a16:creationId xmlns:a16="http://schemas.microsoft.com/office/drawing/2014/main" id="{D523FB30-66B5-4740-B13F-D3A5003200EC}"/>
               </a:ext>
             </a:extLst>
           </p:cNvPr>
@@ -4946,7 +4963,7 @@
           <p:cNvPr id="9" name="">
             <a:extLst xmlns:a="http://schemas.openxmlformats.org/drawingml/2006/main">
               <a:ext uri="{FF2B5EF4-FFF2-40B4-BE49-F238E27FC236}">
-                <a16:creationId xmlns:a16="http://schemas.microsoft.com/office/drawing/2014/main" id="{4B1850F2-E00A-47A6-B967-28977510BAB3}"/>
+                <a16:creationId xmlns:a16="http://schemas.microsoft.com/office/drawing/2014/main" id="{B889DF24-43D1-4345-8391-13AFA353C298}"/>
               </a:ext>
             </a:extLst>
           </p:cNvPr>
@@ -4977,7 +4994,7 @@
           <p:cNvPr id="10" name="">
             <a:extLst xmlns:a="http://schemas.openxmlformats.org/drawingml/2006/main">
               <a:ext uri="{FF2B5EF4-FFF2-40B4-BE49-F238E27FC236}">
-                <a16:creationId xmlns:a16="http://schemas.microsoft.com/office/drawing/2014/main" id="{A4ED954E-C48E-46FF-9B13-6C2E0E982038}"/>
+                <a16:creationId xmlns:a16="http://schemas.microsoft.com/office/drawing/2014/main" id="{283FAFF4-40FD-4BCF-B80A-DBF3175C543A}"/>
               </a:ext>
             </a:extLst>
           </p:cNvPr>
@@ -5027,7 +5044,7 @@
           <p:cNvPr id="11" name="">
             <a:extLst xmlns:a="http://schemas.openxmlformats.org/drawingml/2006/main">
               <a:ext uri="{FF2B5EF4-FFF2-40B4-BE49-F238E27FC236}">
-                <a16:creationId xmlns:a16="http://schemas.microsoft.com/office/drawing/2014/main" id="{BFE00847-6380-436E-9537-6024ED1586E9}"/>
+                <a16:creationId xmlns:a16="http://schemas.microsoft.com/office/drawing/2014/main" id="{D1970F1C-1996-4F7D-9877-38D6E1215F8E}"/>
               </a:ext>
             </a:extLst>
           </p:cNvPr>
@@ -5077,7 +5094,7 @@
           <p:cNvPr id="12" name="">
             <a:extLst xmlns:a="http://schemas.openxmlformats.org/drawingml/2006/main">
               <a:ext uri="{FF2B5EF4-FFF2-40B4-BE49-F238E27FC236}">
-                <a16:creationId xmlns:a16="http://schemas.microsoft.com/office/drawing/2014/main" id="{422D8C21-0027-4E2F-BE35-2D5CFE600984}"/>
+                <a16:creationId xmlns:a16="http://schemas.microsoft.com/office/drawing/2014/main" id="{ACC4DAB7-96E1-4CFD-A57A-68A745A26575}"/>
               </a:ext>
             </a:extLst>
           </p:cNvPr>
@@ -5127,7 +5144,7 @@
           <p:cNvPr id="13" name="">
             <a:extLst xmlns:a="http://schemas.openxmlformats.org/drawingml/2006/main">
               <a:ext uri="{FF2B5EF4-FFF2-40B4-BE49-F238E27FC236}">
-                <a16:creationId xmlns:a16="http://schemas.microsoft.com/office/drawing/2014/main" id="{9F7606ED-1171-4D31-925C-C503F407F758}"/>
+                <a16:creationId xmlns:a16="http://schemas.microsoft.com/office/drawing/2014/main" id="{B1A880F1-D462-4D4B-AA0E-C0C8A371A0FE}"/>
               </a:ext>
             </a:extLst>
           </p:cNvPr>
@@ -5158,7 +5175,7 @@
           <p:cNvPr id="14" name="">
             <a:extLst xmlns:a="http://schemas.openxmlformats.org/drawingml/2006/main">
               <a:ext uri="{FF2B5EF4-FFF2-40B4-BE49-F238E27FC236}">
-                <a16:creationId xmlns:a16="http://schemas.microsoft.com/office/drawing/2014/main" id="{C1E25F24-FCFA-4DC7-9514-F4DA0FCD2E0B}"/>
+                <a16:creationId xmlns:a16="http://schemas.microsoft.com/office/drawing/2014/main" id="{77D66625-BDCA-4D1F-BFB0-81C0AFD61932}"/>
               </a:ext>
             </a:extLst>
           </p:cNvPr>
@@ -5208,7 +5225,7 @@
           <p:cNvPr id="15" name="">
             <a:extLst xmlns:a="http://schemas.openxmlformats.org/drawingml/2006/main">
               <a:ext uri="{FF2B5EF4-FFF2-40B4-BE49-F238E27FC236}">
-                <a16:creationId xmlns:a16="http://schemas.microsoft.com/office/drawing/2014/main" id="{B379410D-02A9-4707-A897-031FD7A89ED4}"/>
+                <a16:creationId xmlns:a16="http://schemas.microsoft.com/office/drawing/2014/main" id="{13AEFE6A-A9DF-4C60-BB95-985657130FDC}"/>
               </a:ext>
             </a:extLst>
           </p:cNvPr>
@@ -5258,7 +5275,7 @@
           <p:cNvPr id="16" name="">
             <a:extLst xmlns:a="http://schemas.openxmlformats.org/drawingml/2006/main">
               <a:ext uri="{FF2B5EF4-FFF2-40B4-BE49-F238E27FC236}">
-                <a16:creationId xmlns:a16="http://schemas.microsoft.com/office/drawing/2014/main" id="{D6E942B0-7777-453B-A4E9-C0F86363F8E8}"/>
+                <a16:creationId xmlns:a16="http://schemas.microsoft.com/office/drawing/2014/main" id="{122D738A-E4D2-406A-A893-3246EB98F944}"/>
               </a:ext>
             </a:extLst>
           </p:cNvPr>
@@ -5308,7 +5325,7 @@
           <p:cNvPr id="17" name="">
             <a:extLst xmlns:a="http://schemas.openxmlformats.org/drawingml/2006/main">
               <a:ext uri="{FF2B5EF4-FFF2-40B4-BE49-F238E27FC236}">
-                <a16:creationId xmlns:a16="http://schemas.microsoft.com/office/drawing/2014/main" id="{0D6B69F5-24F6-4164-9721-9B75A59CD77A}"/>
+                <a16:creationId xmlns:a16="http://schemas.microsoft.com/office/drawing/2014/main" id="{47EDEBB9-F0D3-4218-AC9E-4BB451B9643F}"/>
               </a:ext>
             </a:extLst>
           </p:cNvPr>
@@ -5339,7 +5356,7 @@
           <p:cNvPr id="18" name="">
             <a:extLst xmlns:a="http://schemas.openxmlformats.org/drawingml/2006/main">
               <a:ext uri="{FF2B5EF4-FFF2-40B4-BE49-F238E27FC236}">
-                <a16:creationId xmlns:a16="http://schemas.microsoft.com/office/drawing/2014/main" id="{B3D2E46E-7B00-4FA9-ABDC-1B21BE900553}"/>
+                <a16:creationId xmlns:a16="http://schemas.microsoft.com/office/drawing/2014/main" id="{C8BB6F8B-F741-419A-BC0B-C9560905270D}"/>
               </a:ext>
             </a:extLst>
           </p:cNvPr>
@@ -5389,7 +5406,7 @@
           <p:cNvPr id="19" name="">
             <a:extLst xmlns:a="http://schemas.openxmlformats.org/drawingml/2006/main">
               <a:ext uri="{FF2B5EF4-FFF2-40B4-BE49-F238E27FC236}">
-                <a16:creationId xmlns:a16="http://schemas.microsoft.com/office/drawing/2014/main" id="{5EEF110A-00D2-4ED0-8FAA-B0D3445861F0}"/>
+                <a16:creationId xmlns:a16="http://schemas.microsoft.com/office/drawing/2014/main" id="{76C826D8-4D36-407D-8AD4-E849F91FB27D}"/>
               </a:ext>
             </a:extLst>
           </p:cNvPr>
@@ -5439,7 +5456,7 @@
           <p:cNvPr id="20" name="">
             <a:extLst xmlns:a="http://schemas.openxmlformats.org/drawingml/2006/main">
               <a:ext uri="{FF2B5EF4-FFF2-40B4-BE49-F238E27FC236}">
-                <a16:creationId xmlns:a16="http://schemas.microsoft.com/office/drawing/2014/main" id="{43AAE7F7-9A48-466B-B0C2-A3A495FEC200}"/>
+                <a16:creationId xmlns:a16="http://schemas.microsoft.com/office/drawing/2014/main" id="{71624B7F-3B35-429C-B782-3787506530FB}"/>
               </a:ext>
             </a:extLst>
           </p:cNvPr>
@@ -5489,7 +5506,7 @@
           <p:cNvPr id="21" name="">
             <a:extLst xmlns:a="http://schemas.openxmlformats.org/drawingml/2006/main">
               <a:ext uri="{FF2B5EF4-FFF2-40B4-BE49-F238E27FC236}">
-                <a16:creationId xmlns:a16="http://schemas.microsoft.com/office/drawing/2014/main" id="{A67B98F3-9E7B-48F4-95D1-F77115F708D6}"/>
+                <a16:creationId xmlns:a16="http://schemas.microsoft.com/office/drawing/2014/main" id="{7D110AF0-ADAE-4089-91E3-F8BA3595121F}"/>
               </a:ext>
             </a:extLst>
           </p:cNvPr>
@@ -5520,7 +5537,7 @@
           <p:cNvPr id="22" name="">
             <a:extLst xmlns:a="http://schemas.openxmlformats.org/drawingml/2006/main">
               <a:ext uri="{FF2B5EF4-FFF2-40B4-BE49-F238E27FC236}">
-                <a16:creationId xmlns:a16="http://schemas.microsoft.com/office/drawing/2014/main" id="{F07449EB-2358-4EC1-9183-8DE808D9399A}"/>
+                <a16:creationId xmlns:a16="http://schemas.microsoft.com/office/drawing/2014/main" id="{AB446645-63A0-4E85-9055-A122D4792142}"/>
               </a:ext>
             </a:extLst>
           </p:cNvPr>
@@ -5570,7 +5587,7 @@
           <p:cNvPr id="23" name="">
             <a:extLst xmlns:a="http://schemas.openxmlformats.org/drawingml/2006/main">
               <a:ext uri="{FF2B5EF4-FFF2-40B4-BE49-F238E27FC236}">
-                <a16:creationId xmlns:a16="http://schemas.microsoft.com/office/drawing/2014/main" id="{9262DDEA-5AE0-417F-8EB5-CB1EA1D22770}"/>
+                <a16:creationId xmlns:a16="http://schemas.microsoft.com/office/drawing/2014/main" id="{1DE995CC-33E1-44BB-8682-84A1269C8994}"/>
               </a:ext>
             </a:extLst>
           </p:cNvPr>
@@ -5620,7 +5637,7 @@
           <p:cNvPr id="24" name="">
             <a:extLst xmlns:a="http://schemas.openxmlformats.org/drawingml/2006/main">
               <a:ext uri="{FF2B5EF4-FFF2-40B4-BE49-F238E27FC236}">
-                <a16:creationId xmlns:a16="http://schemas.microsoft.com/office/drawing/2014/main" id="{D2AABC25-C2F6-443F-9082-57ECFC8C3498}"/>
+                <a16:creationId xmlns:a16="http://schemas.microsoft.com/office/drawing/2014/main" id="{E2BBA15F-1DD3-4A4E-945F-B43EAA663F7B}"/>
               </a:ext>
             </a:extLst>
           </p:cNvPr>
@@ -5670,7 +5687,7 @@
           <p:cNvPr id="25" name="">
             <a:extLst xmlns:a="http://schemas.openxmlformats.org/drawingml/2006/main">
               <a:ext uri="{FF2B5EF4-FFF2-40B4-BE49-F238E27FC236}">
-                <a16:creationId xmlns:a16="http://schemas.microsoft.com/office/drawing/2014/main" id="{3C3E18D2-2728-42B1-A4AA-C06774597CC9}"/>
+                <a16:creationId xmlns:a16="http://schemas.microsoft.com/office/drawing/2014/main" id="{813F6697-0AAC-4516-B4B0-704C93CFDC18}"/>
               </a:ext>
             </a:extLst>
           </p:cNvPr>
@@ -5701,7 +5718,7 @@
           <p:cNvPr id="26" name="">
             <a:extLst xmlns:a="http://schemas.openxmlformats.org/drawingml/2006/main">
               <a:ext uri="{FF2B5EF4-FFF2-40B4-BE49-F238E27FC236}">
-                <a16:creationId xmlns:a16="http://schemas.microsoft.com/office/drawing/2014/main" id="{8941505A-B5C0-4C72-82DC-F47C1481A3B7}"/>
+                <a16:creationId xmlns:a16="http://schemas.microsoft.com/office/drawing/2014/main" id="{3CD6404C-8DFC-41F3-A51F-4653EF7EFDBE}"/>
               </a:ext>
             </a:extLst>
           </p:cNvPr>
@@ -5751,7 +5768,7 @@
           <p:cNvPr id="27" name="">
             <a:extLst xmlns:a="http://schemas.openxmlformats.org/drawingml/2006/main">
               <a:ext uri="{FF2B5EF4-FFF2-40B4-BE49-F238E27FC236}">
-                <a16:creationId xmlns:a16="http://schemas.microsoft.com/office/drawing/2014/main" id="{FC1DBE03-50AA-414E-A765-4EDA3BD8D831}"/>
+                <a16:creationId xmlns:a16="http://schemas.microsoft.com/office/drawing/2014/main" id="{55D0BC3F-B4A2-4233-AA20-11C4B1F41676}"/>
               </a:ext>
             </a:extLst>
           </p:cNvPr>
@@ -5801,7 +5818,7 @@
           <p:cNvPr id="28" name="">
             <a:extLst xmlns:a="http://schemas.openxmlformats.org/drawingml/2006/main">
               <a:ext uri="{FF2B5EF4-FFF2-40B4-BE49-F238E27FC236}">
-                <a16:creationId xmlns:a16="http://schemas.microsoft.com/office/drawing/2014/main" id="{92B5338D-4870-4CDE-A5BB-5D9BDB944DA3}"/>
+                <a16:creationId xmlns:a16="http://schemas.microsoft.com/office/drawing/2014/main" id="{07B31F3D-F117-48CD-A0B1-6705F3D46245}"/>
               </a:ext>
             </a:extLst>
           </p:cNvPr>
@@ -5851,7 +5868,7 @@
           <p:cNvPr id="29" name="">
             <a:extLst xmlns:a="http://schemas.openxmlformats.org/drawingml/2006/main">
               <a:ext uri="{FF2B5EF4-FFF2-40B4-BE49-F238E27FC236}">
-                <a16:creationId xmlns:a16="http://schemas.microsoft.com/office/drawing/2014/main" id="{6EBC3631-310F-4518-9493-505BC782AD02}"/>
+                <a16:creationId xmlns:a16="http://schemas.microsoft.com/office/drawing/2014/main" id="{C640A06F-70A9-4F3C-BA07-9A52E7EDA049}"/>
               </a:ext>
             </a:extLst>
           </p:cNvPr>
@@ -5880,7 +5897,7 @@
     </p:spTree>
     <p:extLst>
       <p:ext uri="{BB962C8B-B14F-4D97-AF65-F5344CB8AC3E}">
-        <p14:creationId xmlns:p14="http://schemas.microsoft.com/office/powerpoint/2010/main" val="986092403"/>
+        <p14:creationId xmlns:p14="http://schemas.microsoft.com/office/powerpoint/2010/main" val="2130929410"/>
       </p:ext>
     </p:extLst>
   </p:cSld>
@@ -5911,7 +5928,7 @@
           <p:cNvPr id="1" name="">
             <a:extLst xmlns:a="http://schemas.openxmlformats.org/drawingml/2006/main">
               <a:ext uri="{FF2B5EF4-FFF2-40B4-BE49-F238E27FC236}">
-                <a16:creationId xmlns:a16="http://schemas.microsoft.com/office/drawing/2014/main" id="{E07E6B1C-0EF5-47D9-B37F-9192D3E6D917}"/>
+                <a16:creationId xmlns:a16="http://schemas.microsoft.com/office/drawing/2014/main" id="{62D23E22-D570-4AE7-99E4-BFF14529ED0B}"/>
               </a:ext>
             </a:extLst>
           </p:cNvPr>
@@ -5942,7 +5959,7 @@
           <p:cNvPr id="2" name="">
             <a:extLst xmlns:a="http://schemas.openxmlformats.org/drawingml/2006/main">
               <a:ext uri="{FF2B5EF4-FFF2-40B4-BE49-F238E27FC236}">
-                <a16:creationId xmlns:a16="http://schemas.microsoft.com/office/drawing/2014/main" id="{80C9C4E2-68D4-4638-B655-949C799A341D}"/>
+                <a16:creationId xmlns:a16="http://schemas.microsoft.com/office/drawing/2014/main" id="{06F10138-0B70-434E-BDEC-E67248EFE812}"/>
               </a:ext>
             </a:extLst>
           </p:cNvPr>
@@ -5992,7 +6009,7 @@
           <p:cNvPr id="3" name="">
             <a:extLst xmlns:a="http://schemas.openxmlformats.org/drawingml/2006/main">
               <a:ext uri="{FF2B5EF4-FFF2-40B4-BE49-F238E27FC236}">
-                <a16:creationId xmlns:a16="http://schemas.microsoft.com/office/drawing/2014/main" id="{AA398FEB-B03B-48AA-A0DA-B9834BD496D0}"/>
+                <a16:creationId xmlns:a16="http://schemas.microsoft.com/office/drawing/2014/main" id="{A5448D08-E4EB-481F-AEF9-2C7A0474940C}"/>
               </a:ext>
             </a:extLst>
           </p:cNvPr>
@@ -6042,7 +6059,7 @@
           <p:cNvPr id="4" name="">
             <a:extLst xmlns:a="http://schemas.openxmlformats.org/drawingml/2006/main">
               <a:ext uri="{FF2B5EF4-FFF2-40B4-BE49-F238E27FC236}">
-                <a16:creationId xmlns:a16="http://schemas.microsoft.com/office/drawing/2014/main" id="{E0D9BCEF-032D-47EC-A5B8-D6381C8C1B45}"/>
+                <a16:creationId xmlns:a16="http://schemas.microsoft.com/office/drawing/2014/main" id="{B11D1A5F-3DE3-4A0A-BB68-41119E046D4B}"/>
               </a:ext>
             </a:extLst>
           </p:cNvPr>
@@ -6073,7 +6090,7 @@
           <p:cNvPr id="5" name="footer-14">
             <a:extLst xmlns:a="http://schemas.openxmlformats.org/drawingml/2006/main">
               <a:ext uri="{FF2B5EF4-FFF2-40B4-BE49-F238E27FC236}">
-                <a16:creationId xmlns:a16="http://schemas.microsoft.com/office/drawing/2014/main" id="{B7E45824-C61A-42B0-A142-48856077B27A}"/>
+                <a16:creationId xmlns:a16="http://schemas.microsoft.com/office/drawing/2014/main" id="{7BF347E1-F8BE-49DE-9CB2-464DE077ED76}"/>
               </a:ext>
             </a:extLst>
           </p:cNvPr>
@@ -6123,7 +6140,7 @@
           <p:cNvPr id="6" name="">
             <a:extLst xmlns:a="http://schemas.openxmlformats.org/drawingml/2006/main">
               <a:ext uri="{FF2B5EF4-FFF2-40B4-BE49-F238E27FC236}">
-                <a16:creationId xmlns:a16="http://schemas.microsoft.com/office/drawing/2014/main" id="{94C261A1-6190-41FD-B798-25C15558A2C6}"/>
+                <a16:creationId xmlns:a16="http://schemas.microsoft.com/office/drawing/2014/main" id="{857ECB52-B189-4CAA-B29B-8B493BF43CBD}"/>
               </a:ext>
             </a:extLst>
           </p:cNvPr>
@@ -6158,7 +6175,7 @@
           <p:cNvPr id="7" name="">
             <a:extLst xmlns:a="http://schemas.openxmlformats.org/drawingml/2006/main">
               <a:ext uri="{FF2B5EF4-FFF2-40B4-BE49-F238E27FC236}">
-                <a16:creationId xmlns:a16="http://schemas.microsoft.com/office/drawing/2014/main" id="{3E61F30E-9157-4717-A61B-E93A76E3321C}"/>
+                <a16:creationId xmlns:a16="http://schemas.microsoft.com/office/drawing/2014/main" id="{20F0D7C8-8FDD-415B-A8DF-E89845915B64}"/>
               </a:ext>
             </a:extLst>
           </p:cNvPr>
@@ -6208,7 +6225,7 @@
           <p:cNvPr id="8" name="">
             <a:extLst xmlns:a="http://schemas.openxmlformats.org/drawingml/2006/main">
               <a:ext uri="{FF2B5EF4-FFF2-40B4-BE49-F238E27FC236}">
-                <a16:creationId xmlns:a16="http://schemas.microsoft.com/office/drawing/2014/main" id="{53FAA238-A24E-4E66-98D8-063A63BFFB3B}"/>
+                <a16:creationId xmlns:a16="http://schemas.microsoft.com/office/drawing/2014/main" id="{2E329A2B-17AC-4B4F-B8DD-288048BECBBB}"/>
               </a:ext>
             </a:extLst>
           </p:cNvPr>
@@ -6309,7 +6326,7 @@
           <p:cNvPr id="9" name="">
             <a:extLst xmlns:a="http://schemas.openxmlformats.org/drawingml/2006/main">
               <a:ext uri="{FF2B5EF4-FFF2-40B4-BE49-F238E27FC236}">
-                <a16:creationId xmlns:a16="http://schemas.microsoft.com/office/drawing/2014/main" id="{D9B2E24D-4D19-4ADF-9779-AF62CF93F809}"/>
+                <a16:creationId xmlns:a16="http://schemas.microsoft.com/office/drawing/2014/main" id="{C7109EB6-FD3B-4380-9FEE-ACC85510305D}"/>
               </a:ext>
             </a:extLst>
           </p:cNvPr>
@@ -6344,7 +6361,7 @@
           <p:cNvPr id="10" name="">
             <a:extLst xmlns:a="http://schemas.openxmlformats.org/drawingml/2006/main">
               <a:ext uri="{FF2B5EF4-FFF2-40B4-BE49-F238E27FC236}">
-                <a16:creationId xmlns:a16="http://schemas.microsoft.com/office/drawing/2014/main" id="{617E0148-1D93-4B0E-B398-39DE730E2B1D}"/>
+                <a16:creationId xmlns:a16="http://schemas.microsoft.com/office/drawing/2014/main" id="{125E9F28-FC69-48D7-9CD9-35CB8FA0F12C}"/>
               </a:ext>
             </a:extLst>
           </p:cNvPr>
@@ -6394,7 +6411,7 @@
           <p:cNvPr id="11" name="">
             <a:extLst xmlns:a="http://schemas.openxmlformats.org/drawingml/2006/main">
               <a:ext uri="{FF2B5EF4-FFF2-40B4-BE49-F238E27FC236}">
-                <a16:creationId xmlns:a16="http://schemas.microsoft.com/office/drawing/2014/main" id="{BCF4CA01-00CF-4B71-B58F-B9285FD871D1}"/>
+                <a16:creationId xmlns:a16="http://schemas.microsoft.com/office/drawing/2014/main" id="{8097FC09-D5E8-404B-8389-168A2624947D}"/>
               </a:ext>
             </a:extLst>
           </p:cNvPr>
@@ -6512,7 +6529,7 @@
           <p:cNvPr id="12" name="">
             <a:extLst xmlns:a="http://schemas.openxmlformats.org/drawingml/2006/main">
               <a:ext uri="{FF2B5EF4-FFF2-40B4-BE49-F238E27FC236}">
-                <a16:creationId xmlns:a16="http://schemas.microsoft.com/office/drawing/2014/main" id="{FEAA5349-C100-43FC-996F-ACD67A001759}"/>
+                <a16:creationId xmlns:a16="http://schemas.microsoft.com/office/drawing/2014/main" id="{9CD6569D-FE33-4CAD-87AC-1E675A08E559}"/>
               </a:ext>
             </a:extLst>
           </p:cNvPr>
@@ -6560,7 +6577,7 @@
     </p:spTree>
     <p:extLst>
       <p:ext uri="{BB962C8B-B14F-4D97-AF65-F5344CB8AC3E}">
-        <p14:creationId xmlns:p14="http://schemas.microsoft.com/office/powerpoint/2010/main" val="508891486"/>
+        <p14:creationId xmlns:p14="http://schemas.microsoft.com/office/powerpoint/2010/main" val="724106891"/>
       </p:ext>
     </p:extLst>
   </p:cSld>
@@ -6591,7 +6608,7 @@
           <p:cNvPr id="1" name="">
             <a:extLst xmlns:a="http://schemas.openxmlformats.org/drawingml/2006/main">
               <a:ext uri="{FF2B5EF4-FFF2-40B4-BE49-F238E27FC236}">
-                <a16:creationId xmlns:a16="http://schemas.microsoft.com/office/drawing/2014/main" id="{1B9CC903-D553-45F6-BFBA-3B3FF2008307}"/>
+                <a16:creationId xmlns:a16="http://schemas.microsoft.com/office/drawing/2014/main" id="{FE88640E-8C81-40EF-8BBD-10AEAE623E6E}"/>
               </a:ext>
             </a:extLst>
           </p:cNvPr>
@@ -6622,7 +6639,7 @@
           <p:cNvPr id="2" name="">
             <a:extLst xmlns:a="http://schemas.openxmlformats.org/drawingml/2006/main">
               <a:ext uri="{FF2B5EF4-FFF2-40B4-BE49-F238E27FC236}">
-                <a16:creationId xmlns:a16="http://schemas.microsoft.com/office/drawing/2014/main" id="{DC3F64A5-3D95-4689-B46F-C704C3BD1DC2}"/>
+                <a16:creationId xmlns:a16="http://schemas.microsoft.com/office/drawing/2014/main" id="{6B851BFA-0D89-44D7-91D1-21364CBAC194}"/>
               </a:ext>
             </a:extLst>
           </p:cNvPr>
@@ -6672,7 +6689,7 @@
           <p:cNvPr id="3" name="">
             <a:extLst xmlns:a="http://schemas.openxmlformats.org/drawingml/2006/main">
               <a:ext uri="{FF2B5EF4-FFF2-40B4-BE49-F238E27FC236}">
-                <a16:creationId xmlns:a16="http://schemas.microsoft.com/office/drawing/2014/main" id="{09A8B78A-7CCE-4527-8498-301E13F2CDC6}"/>
+                <a16:creationId xmlns:a16="http://schemas.microsoft.com/office/drawing/2014/main" id="{34C9E114-7671-42A1-8FE3-B4EDBC7BFBC2}"/>
               </a:ext>
             </a:extLst>
           </p:cNvPr>
@@ -6722,7 +6739,7 @@
           <p:cNvPr id="4" name="">
             <a:extLst xmlns:a="http://schemas.openxmlformats.org/drawingml/2006/main">
               <a:ext uri="{FF2B5EF4-FFF2-40B4-BE49-F238E27FC236}">
-                <a16:creationId xmlns:a16="http://schemas.microsoft.com/office/drawing/2014/main" id="{DB8BF1CF-EAB5-4A9E-89BF-91F7FA04831E}"/>
+                <a16:creationId xmlns:a16="http://schemas.microsoft.com/office/drawing/2014/main" id="{F974725B-D2A1-462F-84A6-B4D03A3BA579}"/>
               </a:ext>
             </a:extLst>
           </p:cNvPr>
@@ -6753,7 +6770,7 @@
           <p:cNvPr id="5" name="footer-15">
             <a:extLst xmlns:a="http://schemas.openxmlformats.org/drawingml/2006/main">
               <a:ext uri="{FF2B5EF4-FFF2-40B4-BE49-F238E27FC236}">
-                <a16:creationId xmlns:a16="http://schemas.microsoft.com/office/drawing/2014/main" id="{C361600F-65E3-4AAF-9261-5B41BFA0C73A}"/>
+                <a16:creationId xmlns:a16="http://schemas.microsoft.com/office/drawing/2014/main" id="{08498863-8CF9-4764-A006-62CDB5D991D0}"/>
               </a:ext>
             </a:extLst>
           </p:cNvPr>
@@ -6803,7 +6820,7 @@
           <p:cNvPr id="6" name="">
             <a:extLst xmlns:a="http://schemas.openxmlformats.org/drawingml/2006/main">
               <a:ext uri="{FF2B5EF4-FFF2-40B4-BE49-F238E27FC236}">
-                <a16:creationId xmlns:a16="http://schemas.microsoft.com/office/drawing/2014/main" id="{B72AC51D-EA09-4929-97A0-F471671CAE78}"/>
+                <a16:creationId xmlns:a16="http://schemas.microsoft.com/office/drawing/2014/main" id="{1C5552F5-B148-43D1-9A0C-DECC28D60E35}"/>
               </a:ext>
             </a:extLst>
           </p:cNvPr>
@@ -6853,7 +6870,7 @@
           <p:cNvPr id="7" name="">
             <a:extLst xmlns:a="http://schemas.openxmlformats.org/drawingml/2006/main">
               <a:ext uri="{FF2B5EF4-FFF2-40B4-BE49-F238E27FC236}">
-                <a16:creationId xmlns:a16="http://schemas.microsoft.com/office/drawing/2014/main" id="{6C9CF54C-C089-4669-9235-19098A1C7836}"/>
+                <a16:creationId xmlns:a16="http://schemas.microsoft.com/office/drawing/2014/main" id="{151E18EC-1BFD-4509-B4C6-17B7EB5B6592}"/>
               </a:ext>
             </a:extLst>
           </p:cNvPr>
@@ -6954,7 +6971,7 @@
           <p:cNvPr id="8" name="">
             <a:extLst xmlns:a="http://schemas.openxmlformats.org/drawingml/2006/main">
               <a:ext uri="{FF2B5EF4-FFF2-40B4-BE49-F238E27FC236}">
-                <a16:creationId xmlns:a16="http://schemas.microsoft.com/office/drawing/2014/main" id="{50B66E06-4276-49BA-AA6D-2A02289ABE05}"/>
+                <a16:creationId xmlns:a16="http://schemas.microsoft.com/office/drawing/2014/main" id="{E5470A86-2B5A-4E47-ABBE-417AFF0DDA57}"/>
               </a:ext>
             </a:extLst>
           </p:cNvPr>
@@ -6989,7 +7006,7 @@
           <p:cNvPr id="9" name="">
             <a:extLst xmlns:a="http://schemas.openxmlformats.org/drawingml/2006/main">
               <a:ext uri="{FF2B5EF4-FFF2-40B4-BE49-F238E27FC236}">
-                <a16:creationId xmlns:a16="http://schemas.microsoft.com/office/drawing/2014/main" id="{340E1B8F-AA10-4FDA-AFC7-0D513316169E}"/>
+                <a16:creationId xmlns:a16="http://schemas.microsoft.com/office/drawing/2014/main" id="{06331B37-05A0-4C44-8BBA-6A3D9036BAD4}"/>
               </a:ext>
             </a:extLst>
           </p:cNvPr>
@@ -7090,7 +7107,7 @@
           <p:cNvPr id="10" name="">
             <a:extLst xmlns:a="http://schemas.openxmlformats.org/drawingml/2006/main">
               <a:ext uri="{FF2B5EF4-FFF2-40B4-BE49-F238E27FC236}">
-                <a16:creationId xmlns:a16="http://schemas.microsoft.com/office/drawing/2014/main" id="{24617B63-D9F5-4A9F-882A-363FA9079AEA}"/>
+                <a16:creationId xmlns:a16="http://schemas.microsoft.com/office/drawing/2014/main" id="{8D2996AD-3DEB-49CF-A2FD-635FC8FE77E9}"/>
               </a:ext>
             </a:extLst>
           </p:cNvPr>
@@ -7130,7 +7147,7 @@
                   <a:srgbClr val="0B1220"/>
                 </a:solidFill>
               </a:rPr>
-              <a:t>下一步：等待第二组训练跑完，更新最终指标；如验证集证明 fusion 不降 Acc/F1，再作为可选增强。</a:t>
+              <a:t>下一步：完善弱监督错配标签评测；如验证集证明 fusion 不降 Acc/F1，再作为可选增强。</a:t>
             </a:r>
           </a:p>
         </p:txBody>
@@ -7138,7 +7155,7 @@
     </p:spTree>
     <p:extLst>
       <p:ext uri="{BB962C8B-B14F-4D97-AF65-F5344CB8AC3E}">
-        <p14:creationId xmlns:p14="http://schemas.microsoft.com/office/powerpoint/2010/main" val="2139314613"/>
+        <p14:creationId xmlns:p14="http://schemas.microsoft.com/office/powerpoint/2010/main" val="420323994"/>
       </p:ext>
     </p:extLst>
   </p:cSld>
@@ -7169,7 +7186,7 @@
           <p:cNvPr id="1" name="">
             <a:extLst xmlns:a="http://schemas.openxmlformats.org/drawingml/2006/main">
               <a:ext uri="{FF2B5EF4-FFF2-40B4-BE49-F238E27FC236}">
-                <a16:creationId xmlns:a16="http://schemas.microsoft.com/office/drawing/2014/main" id="{4A9A36EB-F55F-456F-8785-F6F27B6A7296}"/>
+                <a16:creationId xmlns:a16="http://schemas.microsoft.com/office/drawing/2014/main" id="{30210C90-9280-44D2-94B4-561A6073CE60}"/>
               </a:ext>
             </a:extLst>
           </p:cNvPr>
@@ -7200,7 +7217,7 @@
           <p:cNvPr id="2" name="">
             <a:extLst xmlns:a="http://schemas.openxmlformats.org/drawingml/2006/main">
               <a:ext uri="{FF2B5EF4-FFF2-40B4-BE49-F238E27FC236}">
-                <a16:creationId xmlns:a16="http://schemas.microsoft.com/office/drawing/2014/main" id="{0AC96E5C-B286-4474-BAF5-59F1B9F48C61}"/>
+                <a16:creationId xmlns:a16="http://schemas.microsoft.com/office/drawing/2014/main" id="{CB5C9D09-8525-4C84-8533-129F9E448818}"/>
               </a:ext>
             </a:extLst>
           </p:cNvPr>
@@ -7250,7 +7267,7 @@
           <p:cNvPr id="3" name="">
             <a:extLst xmlns:a="http://schemas.openxmlformats.org/drawingml/2006/main">
               <a:ext uri="{FF2B5EF4-FFF2-40B4-BE49-F238E27FC236}">
-                <a16:creationId xmlns:a16="http://schemas.microsoft.com/office/drawing/2014/main" id="{04BE7BE9-1E5D-421D-A795-984C16F0435B}"/>
+                <a16:creationId xmlns:a16="http://schemas.microsoft.com/office/drawing/2014/main" id="{5F187A13-A917-497B-92C9-CD03E3DC4DC0}"/>
               </a:ext>
             </a:extLst>
           </p:cNvPr>
@@ -7300,7 +7317,7 @@
           <p:cNvPr id="4" name="">
             <a:extLst xmlns:a="http://schemas.openxmlformats.org/drawingml/2006/main">
               <a:ext uri="{FF2B5EF4-FFF2-40B4-BE49-F238E27FC236}">
-                <a16:creationId xmlns:a16="http://schemas.microsoft.com/office/drawing/2014/main" id="{2938DF87-0609-4F6F-91EB-990482D0C27A}"/>
+                <a16:creationId xmlns:a16="http://schemas.microsoft.com/office/drawing/2014/main" id="{A48A471E-0F7A-42BC-ABD6-F8FAD03984C0}"/>
               </a:ext>
             </a:extLst>
           </p:cNvPr>
@@ -7331,7 +7348,7 @@
           <p:cNvPr id="5" name="footer-2">
             <a:extLst xmlns:a="http://schemas.openxmlformats.org/drawingml/2006/main">
               <a:ext uri="{FF2B5EF4-FFF2-40B4-BE49-F238E27FC236}">
-                <a16:creationId xmlns:a16="http://schemas.microsoft.com/office/drawing/2014/main" id="{27157065-F8C8-4023-9ABC-4C2007CE3B82}"/>
+                <a16:creationId xmlns:a16="http://schemas.microsoft.com/office/drawing/2014/main" id="{8D7D734E-3F52-4678-853C-96E1AEF13AB2}"/>
               </a:ext>
             </a:extLst>
           </p:cNvPr>
@@ -7381,7 +7398,7 @@
           <p:cNvPr id="6" name="">
             <a:extLst xmlns:a="http://schemas.openxmlformats.org/drawingml/2006/main">
               <a:ext uri="{FF2B5EF4-FFF2-40B4-BE49-F238E27FC236}">
-                <a16:creationId xmlns:a16="http://schemas.microsoft.com/office/drawing/2014/main" id="{A4C12CBF-7740-44B9-82A3-B8620DE62E91}"/>
+                <a16:creationId xmlns:a16="http://schemas.microsoft.com/office/drawing/2014/main" id="{0C47F209-5578-431E-9F98-485406FD0F84}"/>
               </a:ext>
             </a:extLst>
           </p:cNvPr>
@@ -7416,7 +7433,7 @@
           <p:cNvPr id="7" name="">
             <a:extLst xmlns:a="http://schemas.openxmlformats.org/drawingml/2006/main">
               <a:ext uri="{FF2B5EF4-FFF2-40B4-BE49-F238E27FC236}">
-                <a16:creationId xmlns:a16="http://schemas.microsoft.com/office/drawing/2014/main" id="{F743A18E-9A8D-43B4-B51C-B5387AC46B9E}"/>
+                <a16:creationId xmlns:a16="http://schemas.microsoft.com/office/drawing/2014/main" id="{D15D0C0F-D975-4880-9100-20E75D1822DF}"/>
               </a:ext>
             </a:extLst>
           </p:cNvPr>
@@ -7447,7 +7464,7 @@
           <p:cNvPr id="8" name="">
             <a:extLst xmlns:a="http://schemas.openxmlformats.org/drawingml/2006/main">
               <a:ext uri="{FF2B5EF4-FFF2-40B4-BE49-F238E27FC236}">
-                <a16:creationId xmlns:a16="http://schemas.microsoft.com/office/drawing/2014/main" id="{D29E4247-C8AE-4F1F-BF75-4410B0817D55}"/>
+                <a16:creationId xmlns:a16="http://schemas.microsoft.com/office/drawing/2014/main" id="{75FA16A5-0421-4BB6-BA1E-65276075104B}"/>
               </a:ext>
             </a:extLst>
           </p:cNvPr>
@@ -7497,7 +7514,7 @@
           <p:cNvPr id="9" name="">
             <a:extLst xmlns:a="http://schemas.openxmlformats.org/drawingml/2006/main">
               <a:ext uri="{FF2B5EF4-FFF2-40B4-BE49-F238E27FC236}">
-                <a16:creationId xmlns:a16="http://schemas.microsoft.com/office/drawing/2014/main" id="{F3DF7773-7CBF-4900-9C95-B7FAC4F8E599}"/>
+                <a16:creationId xmlns:a16="http://schemas.microsoft.com/office/drawing/2014/main" id="{2BF72DA8-FA13-469D-BA43-874F188AEB98}"/>
               </a:ext>
             </a:extLst>
           </p:cNvPr>
@@ -7547,7 +7564,7 @@
           <p:cNvPr id="10" name="">
             <a:extLst xmlns:a="http://schemas.openxmlformats.org/drawingml/2006/main">
               <a:ext uri="{FF2B5EF4-FFF2-40B4-BE49-F238E27FC236}">
-                <a16:creationId xmlns:a16="http://schemas.microsoft.com/office/drawing/2014/main" id="{A3DEB8C0-308D-4733-AAB1-4D7724EDF327}"/>
+                <a16:creationId xmlns:a16="http://schemas.microsoft.com/office/drawing/2014/main" id="{2C5E6E1C-2632-42B3-92D8-1690A45AD679}"/>
               </a:ext>
             </a:extLst>
           </p:cNvPr>
@@ -7582,7 +7599,7 @@
           <p:cNvPr id="11" name="">
             <a:extLst xmlns:a="http://schemas.openxmlformats.org/drawingml/2006/main">
               <a:ext uri="{FF2B5EF4-FFF2-40B4-BE49-F238E27FC236}">
-                <a16:creationId xmlns:a16="http://schemas.microsoft.com/office/drawing/2014/main" id="{1851C05F-19FE-421A-8368-0730CE38F421}"/>
+                <a16:creationId xmlns:a16="http://schemas.microsoft.com/office/drawing/2014/main" id="{3974038C-9901-4AFD-8DBC-2E3A973169E1}"/>
               </a:ext>
             </a:extLst>
           </p:cNvPr>
@@ -7613,7 +7630,7 @@
           <p:cNvPr id="12" name="">
             <a:extLst xmlns:a="http://schemas.openxmlformats.org/drawingml/2006/main">
               <a:ext uri="{FF2B5EF4-FFF2-40B4-BE49-F238E27FC236}">
-                <a16:creationId xmlns:a16="http://schemas.microsoft.com/office/drawing/2014/main" id="{28687857-F44A-4F38-A2F8-9FD682F6BDBF}"/>
+                <a16:creationId xmlns:a16="http://schemas.microsoft.com/office/drawing/2014/main" id="{B7B49E3F-87BA-432A-AC5D-A16D1622ABB3}"/>
               </a:ext>
             </a:extLst>
           </p:cNvPr>
@@ -7663,7 +7680,7 @@
           <p:cNvPr id="13" name="">
             <a:extLst xmlns:a="http://schemas.openxmlformats.org/drawingml/2006/main">
               <a:ext uri="{FF2B5EF4-FFF2-40B4-BE49-F238E27FC236}">
-                <a16:creationId xmlns:a16="http://schemas.microsoft.com/office/drawing/2014/main" id="{D2157DE9-9415-4D00-9D22-674B922D034E}"/>
+                <a16:creationId xmlns:a16="http://schemas.microsoft.com/office/drawing/2014/main" id="{C6B20C33-278E-4093-B0AD-871467649545}"/>
               </a:ext>
             </a:extLst>
           </p:cNvPr>
@@ -7713,7 +7730,7 @@
           <p:cNvPr id="14" name="">
             <a:extLst xmlns:a="http://schemas.openxmlformats.org/drawingml/2006/main">
               <a:ext uri="{FF2B5EF4-FFF2-40B4-BE49-F238E27FC236}">
-                <a16:creationId xmlns:a16="http://schemas.microsoft.com/office/drawing/2014/main" id="{F93FFED2-4CEB-4183-8B58-AABE0E4BA07D}"/>
+                <a16:creationId xmlns:a16="http://schemas.microsoft.com/office/drawing/2014/main" id="{742A1241-E4E5-4192-9C5C-96F0F84AEC3F}"/>
               </a:ext>
             </a:extLst>
           </p:cNvPr>
@@ -7748,7 +7765,7 @@
           <p:cNvPr id="15" name="">
             <a:extLst xmlns:a="http://schemas.openxmlformats.org/drawingml/2006/main">
               <a:ext uri="{FF2B5EF4-FFF2-40B4-BE49-F238E27FC236}">
-                <a16:creationId xmlns:a16="http://schemas.microsoft.com/office/drawing/2014/main" id="{D5F886BA-79E7-4DA2-86CC-EAE8EA2B1804}"/>
+                <a16:creationId xmlns:a16="http://schemas.microsoft.com/office/drawing/2014/main" id="{BA1AF37A-E62E-4A5D-9F8E-730901AC2C45}"/>
               </a:ext>
             </a:extLst>
           </p:cNvPr>
@@ -7779,7 +7796,7 @@
           <p:cNvPr id="16" name="">
             <a:extLst xmlns:a="http://schemas.openxmlformats.org/drawingml/2006/main">
               <a:ext uri="{FF2B5EF4-FFF2-40B4-BE49-F238E27FC236}">
-                <a16:creationId xmlns:a16="http://schemas.microsoft.com/office/drawing/2014/main" id="{59A4BBDA-561C-4F72-9A43-7D2A4077230E}"/>
+                <a16:creationId xmlns:a16="http://schemas.microsoft.com/office/drawing/2014/main" id="{666CFEA8-ABFE-4956-A778-5EB242682865}"/>
               </a:ext>
             </a:extLst>
           </p:cNvPr>
@@ -7829,7 +7846,7 @@
           <p:cNvPr id="17" name="">
             <a:extLst xmlns:a="http://schemas.openxmlformats.org/drawingml/2006/main">
               <a:ext uri="{FF2B5EF4-FFF2-40B4-BE49-F238E27FC236}">
-                <a16:creationId xmlns:a16="http://schemas.microsoft.com/office/drawing/2014/main" id="{28156A96-C52B-4DE9-B2B5-3259175C6A73}"/>
+                <a16:creationId xmlns:a16="http://schemas.microsoft.com/office/drawing/2014/main" id="{B760F81F-09BC-435A-897C-5E26D793EB9A}"/>
               </a:ext>
             </a:extLst>
           </p:cNvPr>
@@ -7879,7 +7896,7 @@
           <p:cNvPr id="18" name="">
             <a:extLst xmlns:a="http://schemas.openxmlformats.org/drawingml/2006/main">
               <a:ext uri="{FF2B5EF4-FFF2-40B4-BE49-F238E27FC236}">
-                <a16:creationId xmlns:a16="http://schemas.microsoft.com/office/drawing/2014/main" id="{D3328F53-EE32-478C-9A7F-6BB9F5373D8F}"/>
+                <a16:creationId xmlns:a16="http://schemas.microsoft.com/office/drawing/2014/main" id="{924055F0-6602-48BC-BCC0-A8659AA6ABB5}"/>
               </a:ext>
             </a:extLst>
           </p:cNvPr>
@@ -7929,7 +7946,7 @@
           <p:cNvPr id="19" name="">
             <a:extLst xmlns:a="http://schemas.openxmlformats.org/drawingml/2006/main">
               <a:ext uri="{FF2B5EF4-FFF2-40B4-BE49-F238E27FC236}">
-                <a16:creationId xmlns:a16="http://schemas.microsoft.com/office/drawing/2014/main" id="{3EAFBC4C-8840-4032-90FB-F95DCB9A8C83}"/>
+                <a16:creationId xmlns:a16="http://schemas.microsoft.com/office/drawing/2014/main" id="{D0AEDFD7-9546-467F-956C-B76E85D997C8}"/>
               </a:ext>
             </a:extLst>
           </p:cNvPr>
@@ -8028,7 +8045,7 @@
     </p:spTree>
     <p:extLst>
       <p:ext uri="{BB962C8B-B14F-4D97-AF65-F5344CB8AC3E}">
-        <p14:creationId xmlns:p14="http://schemas.microsoft.com/office/powerpoint/2010/main" val="1345072318"/>
+        <p14:creationId xmlns:p14="http://schemas.microsoft.com/office/powerpoint/2010/main" val="1150805531"/>
       </p:ext>
     </p:extLst>
   </p:cSld>
@@ -8059,7 +8076,7 @@
           <p:cNvPr id="1" name="">
             <a:extLst xmlns:a="http://schemas.openxmlformats.org/drawingml/2006/main">
               <a:ext uri="{FF2B5EF4-FFF2-40B4-BE49-F238E27FC236}">
-                <a16:creationId xmlns:a16="http://schemas.microsoft.com/office/drawing/2014/main" id="{DF6CD78B-75AD-450E-9C71-B724AFF936DB}"/>
+                <a16:creationId xmlns:a16="http://schemas.microsoft.com/office/drawing/2014/main" id="{3A450573-7721-450E-984A-5ECF5A16DDB9}"/>
               </a:ext>
             </a:extLst>
           </p:cNvPr>
@@ -8090,7 +8107,7 @@
           <p:cNvPr id="2" name="">
             <a:extLst xmlns:a="http://schemas.openxmlformats.org/drawingml/2006/main">
               <a:ext uri="{FF2B5EF4-FFF2-40B4-BE49-F238E27FC236}">
-                <a16:creationId xmlns:a16="http://schemas.microsoft.com/office/drawing/2014/main" id="{E4393594-2D6E-4B03-B79E-533BB066231D}"/>
+                <a16:creationId xmlns:a16="http://schemas.microsoft.com/office/drawing/2014/main" id="{9C899FD6-91B6-495B-B08D-76BD44312DBB}"/>
               </a:ext>
             </a:extLst>
           </p:cNvPr>
@@ -8140,7 +8157,7 @@
           <p:cNvPr id="3" name="">
             <a:extLst xmlns:a="http://schemas.openxmlformats.org/drawingml/2006/main">
               <a:ext uri="{FF2B5EF4-FFF2-40B4-BE49-F238E27FC236}">
-                <a16:creationId xmlns:a16="http://schemas.microsoft.com/office/drawing/2014/main" id="{A7602DBB-5D3C-4FFF-9AB0-925FE4E49A0C}"/>
+                <a16:creationId xmlns:a16="http://schemas.microsoft.com/office/drawing/2014/main" id="{790614F9-1328-4C23-BC20-A08B68DDBEDE}"/>
               </a:ext>
             </a:extLst>
           </p:cNvPr>
@@ -8190,7 +8207,7 @@
           <p:cNvPr id="4" name="">
             <a:extLst xmlns:a="http://schemas.openxmlformats.org/drawingml/2006/main">
               <a:ext uri="{FF2B5EF4-FFF2-40B4-BE49-F238E27FC236}">
-                <a16:creationId xmlns:a16="http://schemas.microsoft.com/office/drawing/2014/main" id="{C84D061D-C613-4C50-B164-D9DD8C44C46D}"/>
+                <a16:creationId xmlns:a16="http://schemas.microsoft.com/office/drawing/2014/main" id="{AC2DC95F-B672-4C99-BD44-DC7401AC3DA2}"/>
               </a:ext>
             </a:extLst>
           </p:cNvPr>
@@ -8221,7 +8238,7 @@
           <p:cNvPr id="5" name="footer-3">
             <a:extLst xmlns:a="http://schemas.openxmlformats.org/drawingml/2006/main">
               <a:ext uri="{FF2B5EF4-FFF2-40B4-BE49-F238E27FC236}">
-                <a16:creationId xmlns:a16="http://schemas.microsoft.com/office/drawing/2014/main" id="{512A6F6D-09BF-4DA4-9535-23A0180F21D0}"/>
+                <a16:creationId xmlns:a16="http://schemas.microsoft.com/office/drawing/2014/main" id="{94AB40F6-5713-402F-B139-B6C4DE50E22D}"/>
               </a:ext>
             </a:extLst>
           </p:cNvPr>
@@ -8271,7 +8288,7 @@
           <p:cNvPr id="6" name="">
             <a:extLst xmlns:a="http://schemas.openxmlformats.org/drawingml/2006/main">
               <a:ext uri="{FF2B5EF4-FFF2-40B4-BE49-F238E27FC236}">
-                <a16:creationId xmlns:a16="http://schemas.microsoft.com/office/drawing/2014/main" id="{A15A1F47-5055-4D02-9EAB-BC4779BFC1D9}"/>
+                <a16:creationId xmlns:a16="http://schemas.microsoft.com/office/drawing/2014/main" id="{7ACEDDF7-B354-4DAC-AD1C-DBB261FAD963}"/>
               </a:ext>
             </a:extLst>
           </p:cNvPr>
@@ -8321,7 +8338,7 @@
           <p:cNvPr id="7" name="">
             <a:extLst xmlns:a="http://schemas.openxmlformats.org/drawingml/2006/main">
               <a:ext uri="{FF2B5EF4-FFF2-40B4-BE49-F238E27FC236}">
-                <a16:creationId xmlns:a16="http://schemas.microsoft.com/office/drawing/2014/main" id="{903E4CF3-AD94-4F55-9C17-033016C7F12D}"/>
+                <a16:creationId xmlns:a16="http://schemas.microsoft.com/office/drawing/2014/main" id="{6082EFE9-2C40-400F-91B5-86D9E2CF3C34}"/>
               </a:ext>
             </a:extLst>
           </p:cNvPr>
@@ -8356,7 +8373,7 @@
           <p:cNvPr id="8" name="">
             <a:extLst xmlns:a="http://schemas.openxmlformats.org/drawingml/2006/main">
               <a:ext uri="{FF2B5EF4-FFF2-40B4-BE49-F238E27FC236}">
-                <a16:creationId xmlns:a16="http://schemas.microsoft.com/office/drawing/2014/main" id="{DE328679-A2C8-4376-8844-EF012679F68C}"/>
+                <a16:creationId xmlns:a16="http://schemas.microsoft.com/office/drawing/2014/main" id="{A1B72608-6EB2-49BA-8B71-D26B9A2894E4}"/>
               </a:ext>
             </a:extLst>
           </p:cNvPr>
@@ -8440,7 +8457,7 @@
           <p:cNvPr id="9" name="">
             <a:extLst xmlns:a="http://schemas.openxmlformats.org/drawingml/2006/main">
               <a:ext uri="{FF2B5EF4-FFF2-40B4-BE49-F238E27FC236}">
-                <a16:creationId xmlns:a16="http://schemas.microsoft.com/office/drawing/2014/main" id="{CCA99681-C970-416A-B68A-AA6B2E9B9FD7}"/>
+                <a16:creationId xmlns:a16="http://schemas.microsoft.com/office/drawing/2014/main" id="{5E7A5DB8-CC6C-4525-841C-9C19EB4FD8FD}"/>
               </a:ext>
             </a:extLst>
           </p:cNvPr>
@@ -8490,7 +8507,7 @@
           <p:cNvPr id="10" name="">
             <a:extLst xmlns:a="http://schemas.openxmlformats.org/drawingml/2006/main">
               <a:ext uri="{FF2B5EF4-FFF2-40B4-BE49-F238E27FC236}">
-                <a16:creationId xmlns:a16="http://schemas.microsoft.com/office/drawing/2014/main" id="{0AF0BD8D-C5B0-42E7-85A9-597901FA86B4}"/>
+                <a16:creationId xmlns:a16="http://schemas.microsoft.com/office/drawing/2014/main" id="{11054F6A-DC79-43AF-88CB-DD481A8883B5}"/>
               </a:ext>
             </a:extLst>
           </p:cNvPr>
@@ -8525,7 +8542,7 @@
           <p:cNvPr id="11" name="">
             <a:extLst xmlns:a="http://schemas.openxmlformats.org/drawingml/2006/main">
               <a:ext uri="{FF2B5EF4-FFF2-40B4-BE49-F238E27FC236}">
-                <a16:creationId xmlns:a16="http://schemas.microsoft.com/office/drawing/2014/main" id="{D0782402-4BD2-446B-8F0A-608B435CFAB4}"/>
+                <a16:creationId xmlns:a16="http://schemas.microsoft.com/office/drawing/2014/main" id="{8682EEEF-94BD-451A-9718-40193DFF8C7A}"/>
               </a:ext>
             </a:extLst>
           </p:cNvPr>
@@ -8626,7 +8643,7 @@
           <p:cNvPr id="12" name="">
             <a:extLst xmlns:a="http://schemas.openxmlformats.org/drawingml/2006/main">
               <a:ext uri="{FF2B5EF4-FFF2-40B4-BE49-F238E27FC236}">
-                <a16:creationId xmlns:a16="http://schemas.microsoft.com/office/drawing/2014/main" id="{57BE3DFE-AC49-4072-AD9D-EFFCE1A8413E}"/>
+                <a16:creationId xmlns:a16="http://schemas.microsoft.com/office/drawing/2014/main" id="{228D688D-8941-4E4E-8846-0B5227E69324}"/>
               </a:ext>
             </a:extLst>
           </p:cNvPr>
@@ -8674,7 +8691,7 @@
     </p:spTree>
     <p:extLst>
       <p:ext uri="{BB962C8B-B14F-4D97-AF65-F5344CB8AC3E}">
-        <p14:creationId xmlns:p14="http://schemas.microsoft.com/office/powerpoint/2010/main" val="552528777"/>
+        <p14:creationId xmlns:p14="http://schemas.microsoft.com/office/powerpoint/2010/main" val="347162467"/>
       </p:ext>
     </p:extLst>
   </p:cSld>
@@ -8705,7 +8722,7 @@
           <p:cNvPr id="1" name="">
             <a:extLst xmlns:a="http://schemas.openxmlformats.org/drawingml/2006/main">
               <a:ext uri="{FF2B5EF4-FFF2-40B4-BE49-F238E27FC236}">
-                <a16:creationId xmlns:a16="http://schemas.microsoft.com/office/drawing/2014/main" id="{39388BAF-46EF-43A6-8091-FAEC4D1D8042}"/>
+                <a16:creationId xmlns:a16="http://schemas.microsoft.com/office/drawing/2014/main" id="{6D3F90CF-94FD-43FB-AB92-55CA3AAC1A2F}"/>
               </a:ext>
             </a:extLst>
           </p:cNvPr>
@@ -8736,7 +8753,7 @@
           <p:cNvPr id="2" name="">
             <a:extLst xmlns:a="http://schemas.openxmlformats.org/drawingml/2006/main">
               <a:ext uri="{FF2B5EF4-FFF2-40B4-BE49-F238E27FC236}">
-                <a16:creationId xmlns:a16="http://schemas.microsoft.com/office/drawing/2014/main" id="{8B3E959D-4A6C-41A7-A994-44EAE4432B85}"/>
+                <a16:creationId xmlns:a16="http://schemas.microsoft.com/office/drawing/2014/main" id="{D5382838-A36B-454F-B270-325236A9AEE9}"/>
               </a:ext>
             </a:extLst>
           </p:cNvPr>
@@ -8786,7 +8803,7 @@
           <p:cNvPr id="3" name="">
             <a:extLst xmlns:a="http://schemas.openxmlformats.org/drawingml/2006/main">
               <a:ext uri="{FF2B5EF4-FFF2-40B4-BE49-F238E27FC236}">
-                <a16:creationId xmlns:a16="http://schemas.microsoft.com/office/drawing/2014/main" id="{42DD82D2-8D9B-4E30-B964-E6197CA80BCC}"/>
+                <a16:creationId xmlns:a16="http://schemas.microsoft.com/office/drawing/2014/main" id="{AD549FA3-69C5-4260-8456-911C4658813A}"/>
               </a:ext>
             </a:extLst>
           </p:cNvPr>
@@ -8836,7 +8853,7 @@
           <p:cNvPr id="4" name="">
             <a:extLst xmlns:a="http://schemas.openxmlformats.org/drawingml/2006/main">
               <a:ext uri="{FF2B5EF4-FFF2-40B4-BE49-F238E27FC236}">
-                <a16:creationId xmlns:a16="http://schemas.microsoft.com/office/drawing/2014/main" id="{E223638E-5B72-46CF-A8FA-DBE33BC4253D}"/>
+                <a16:creationId xmlns:a16="http://schemas.microsoft.com/office/drawing/2014/main" id="{9DC084D2-9F69-4A4A-8300-16D120DD3109}"/>
               </a:ext>
             </a:extLst>
           </p:cNvPr>
@@ -8867,7 +8884,7 @@
           <p:cNvPr id="5" name="footer-4">
             <a:extLst xmlns:a="http://schemas.openxmlformats.org/drawingml/2006/main">
               <a:ext uri="{FF2B5EF4-FFF2-40B4-BE49-F238E27FC236}">
-                <a16:creationId xmlns:a16="http://schemas.microsoft.com/office/drawing/2014/main" id="{C2B11BD2-FCFB-4C92-BF50-D49AA8B429BE}"/>
+                <a16:creationId xmlns:a16="http://schemas.microsoft.com/office/drawing/2014/main" id="{B919F170-E425-4CE3-9B58-E606A553183F}"/>
               </a:ext>
             </a:extLst>
           </p:cNvPr>
@@ -8917,7 +8934,7 @@
           <p:cNvPr id="6" name="">
             <a:extLst xmlns:a="http://schemas.openxmlformats.org/drawingml/2006/main">
               <a:ext uri="{FF2B5EF4-FFF2-40B4-BE49-F238E27FC236}">
-                <a16:creationId xmlns:a16="http://schemas.microsoft.com/office/drawing/2014/main" id="{4B015016-44DB-42EC-86F0-3CF694FD4A10}"/>
+                <a16:creationId xmlns:a16="http://schemas.microsoft.com/office/drawing/2014/main" id="{809DB816-EBBE-4948-8CF0-69D56C138546}"/>
               </a:ext>
             </a:extLst>
           </p:cNvPr>
@@ -8952,7 +8969,7 @@
           <p:cNvPr id="7" name="">
             <a:extLst xmlns:a="http://schemas.openxmlformats.org/drawingml/2006/main">
               <a:ext uri="{FF2B5EF4-FFF2-40B4-BE49-F238E27FC236}">
-                <a16:creationId xmlns:a16="http://schemas.microsoft.com/office/drawing/2014/main" id="{A8650753-5AFE-47CF-BC69-8E4BD4E65C89}"/>
+                <a16:creationId xmlns:a16="http://schemas.microsoft.com/office/drawing/2014/main" id="{77465D07-B3EC-475D-BF02-D25A2FE3472F}"/>
               </a:ext>
             </a:extLst>
           </p:cNvPr>
@@ -8983,7 +9000,7 @@
           <p:cNvPr id="8" name="">
             <a:extLst xmlns:a="http://schemas.openxmlformats.org/drawingml/2006/main">
               <a:ext uri="{FF2B5EF4-FFF2-40B4-BE49-F238E27FC236}">
-                <a16:creationId xmlns:a16="http://schemas.microsoft.com/office/drawing/2014/main" id="{38A24776-4D9E-422C-94E5-74C86A75C33A}"/>
+                <a16:creationId xmlns:a16="http://schemas.microsoft.com/office/drawing/2014/main" id="{39F97322-2B02-4165-84DC-86C5B30A8628}"/>
               </a:ext>
             </a:extLst>
           </p:cNvPr>
@@ -9033,7 +9050,7 @@
           <p:cNvPr id="9" name="">
             <a:extLst xmlns:a="http://schemas.openxmlformats.org/drawingml/2006/main">
               <a:ext uri="{FF2B5EF4-FFF2-40B4-BE49-F238E27FC236}">
-                <a16:creationId xmlns:a16="http://schemas.microsoft.com/office/drawing/2014/main" id="{B10B4947-4586-48E5-AA1C-7B5018A22012}"/>
+                <a16:creationId xmlns:a16="http://schemas.microsoft.com/office/drawing/2014/main" id="{F5972BB5-35F4-464E-8B1C-A5CEE074B739}"/>
               </a:ext>
             </a:extLst>
           </p:cNvPr>
@@ -9083,7 +9100,7 @@
           <p:cNvPr id="10" name="">
             <a:extLst xmlns:a="http://schemas.openxmlformats.org/drawingml/2006/main">
               <a:ext uri="{FF2B5EF4-FFF2-40B4-BE49-F238E27FC236}">
-                <a16:creationId xmlns:a16="http://schemas.microsoft.com/office/drawing/2014/main" id="{F311F1F1-0A49-46DE-A50F-C6B5E0DA7646}"/>
+                <a16:creationId xmlns:a16="http://schemas.microsoft.com/office/drawing/2014/main" id="{04B281E6-3B8A-41DA-ACAB-1BBC63B8A806}"/>
               </a:ext>
             </a:extLst>
           </p:cNvPr>
@@ -9118,7 +9135,7 @@
           <p:cNvPr id="11" name="">
             <a:extLst xmlns:a="http://schemas.openxmlformats.org/drawingml/2006/main">
               <a:ext uri="{FF2B5EF4-FFF2-40B4-BE49-F238E27FC236}">
-                <a16:creationId xmlns:a16="http://schemas.microsoft.com/office/drawing/2014/main" id="{1329CFFD-9C4E-4076-8E52-E7E4798B4A46}"/>
+                <a16:creationId xmlns:a16="http://schemas.microsoft.com/office/drawing/2014/main" id="{049AF51E-48E5-4C33-A0E2-6F51128D6C47}"/>
               </a:ext>
             </a:extLst>
           </p:cNvPr>
@@ -9149,7 +9166,7 @@
           <p:cNvPr id="12" name="">
             <a:extLst xmlns:a="http://schemas.openxmlformats.org/drawingml/2006/main">
               <a:ext uri="{FF2B5EF4-FFF2-40B4-BE49-F238E27FC236}">
-                <a16:creationId xmlns:a16="http://schemas.microsoft.com/office/drawing/2014/main" id="{EEF378FE-7074-4D73-9BAB-F36003B695DB}"/>
+                <a16:creationId xmlns:a16="http://schemas.microsoft.com/office/drawing/2014/main" id="{2F1C6462-D056-4BE9-9826-989A7B2F6B28}"/>
               </a:ext>
             </a:extLst>
           </p:cNvPr>
@@ -9199,7 +9216,7 @@
           <p:cNvPr id="13" name="">
             <a:extLst xmlns:a="http://schemas.openxmlformats.org/drawingml/2006/main">
               <a:ext uri="{FF2B5EF4-FFF2-40B4-BE49-F238E27FC236}">
-                <a16:creationId xmlns:a16="http://schemas.microsoft.com/office/drawing/2014/main" id="{2CE3BD4C-D9ED-446D-9434-10060B3B31FB}"/>
+                <a16:creationId xmlns:a16="http://schemas.microsoft.com/office/drawing/2014/main" id="{8857955D-0792-4925-86EA-A465490229B9}"/>
               </a:ext>
             </a:extLst>
           </p:cNvPr>
@@ -9249,7 +9266,7 @@
           <p:cNvPr id="14" name="">
             <a:extLst xmlns:a="http://schemas.openxmlformats.org/drawingml/2006/main">
               <a:ext uri="{FF2B5EF4-FFF2-40B4-BE49-F238E27FC236}">
-                <a16:creationId xmlns:a16="http://schemas.microsoft.com/office/drawing/2014/main" id="{42A0EA17-C24F-4797-8F03-49E00509A974}"/>
+                <a16:creationId xmlns:a16="http://schemas.microsoft.com/office/drawing/2014/main" id="{2D2239E4-4821-4ADB-9915-207BC7C300DF}"/>
               </a:ext>
             </a:extLst>
           </p:cNvPr>
@@ -9284,7 +9301,7 @@
           <p:cNvPr id="15" name="">
             <a:extLst xmlns:a="http://schemas.openxmlformats.org/drawingml/2006/main">
               <a:ext uri="{FF2B5EF4-FFF2-40B4-BE49-F238E27FC236}">
-                <a16:creationId xmlns:a16="http://schemas.microsoft.com/office/drawing/2014/main" id="{D9732C08-933F-4A6F-B4F8-FD7CBBC583B0}"/>
+                <a16:creationId xmlns:a16="http://schemas.microsoft.com/office/drawing/2014/main" id="{AD9D0D3E-5CD8-41F4-9D92-BC4D14738215}"/>
               </a:ext>
             </a:extLst>
           </p:cNvPr>
@@ -9315,7 +9332,7 @@
           <p:cNvPr id="16" name="">
             <a:extLst xmlns:a="http://schemas.openxmlformats.org/drawingml/2006/main">
               <a:ext uri="{FF2B5EF4-FFF2-40B4-BE49-F238E27FC236}">
-                <a16:creationId xmlns:a16="http://schemas.microsoft.com/office/drawing/2014/main" id="{82288E88-513B-41DE-BCA9-081F02242C1C}"/>
+                <a16:creationId xmlns:a16="http://schemas.microsoft.com/office/drawing/2014/main" id="{4F00B218-0732-4310-869A-859B3A4C5B61}"/>
               </a:ext>
             </a:extLst>
           </p:cNvPr>
@@ -9365,7 +9382,7 @@
           <p:cNvPr id="17" name="">
             <a:extLst xmlns:a="http://schemas.openxmlformats.org/drawingml/2006/main">
               <a:ext uri="{FF2B5EF4-FFF2-40B4-BE49-F238E27FC236}">
-                <a16:creationId xmlns:a16="http://schemas.microsoft.com/office/drawing/2014/main" id="{76D792C8-FB36-4616-B9C8-96AA06C442F8}"/>
+                <a16:creationId xmlns:a16="http://schemas.microsoft.com/office/drawing/2014/main" id="{99E02968-BDD7-4502-B2F9-08A36C6123EE}"/>
               </a:ext>
             </a:extLst>
           </p:cNvPr>
@@ -9415,7 +9432,7 @@
           <p:cNvPr id="18" name="">
             <a:extLst xmlns:a="http://schemas.openxmlformats.org/drawingml/2006/main">
               <a:ext uri="{FF2B5EF4-FFF2-40B4-BE49-F238E27FC236}">
-                <a16:creationId xmlns:a16="http://schemas.microsoft.com/office/drawing/2014/main" id="{D5A42C4B-4CA7-438C-B823-B7CFA102695A}"/>
+                <a16:creationId xmlns:a16="http://schemas.microsoft.com/office/drawing/2014/main" id="{A63C035B-2DDC-4374-AE3A-43EA6B2EB453}"/>
               </a:ext>
             </a:extLst>
           </p:cNvPr>
@@ -9463,7 +9480,7 @@
     </p:spTree>
     <p:extLst>
       <p:ext uri="{BB962C8B-B14F-4D97-AF65-F5344CB8AC3E}">
-        <p14:creationId xmlns:p14="http://schemas.microsoft.com/office/powerpoint/2010/main" val="1213431920"/>
+        <p14:creationId xmlns:p14="http://schemas.microsoft.com/office/powerpoint/2010/main" val="276861057"/>
       </p:ext>
     </p:extLst>
   </p:cSld>
@@ -9494,7 +9511,7 @@
           <p:cNvPr id="1" name="">
             <a:extLst xmlns:a="http://schemas.openxmlformats.org/drawingml/2006/main">
               <a:ext uri="{FF2B5EF4-FFF2-40B4-BE49-F238E27FC236}">
-                <a16:creationId xmlns:a16="http://schemas.microsoft.com/office/drawing/2014/main" id="{FE7AA83E-BE42-4202-AA30-87D75CE8BAA3}"/>
+                <a16:creationId xmlns:a16="http://schemas.microsoft.com/office/drawing/2014/main" id="{852BC8F8-1BC6-4938-9B79-5C49CDDA3F03}"/>
               </a:ext>
             </a:extLst>
           </p:cNvPr>
@@ -9525,7 +9542,7 @@
           <p:cNvPr id="2" name="">
             <a:extLst xmlns:a="http://schemas.openxmlformats.org/drawingml/2006/main">
               <a:ext uri="{FF2B5EF4-FFF2-40B4-BE49-F238E27FC236}">
-                <a16:creationId xmlns:a16="http://schemas.microsoft.com/office/drawing/2014/main" id="{209BD5D2-A090-4C91-8B50-65733EB0D6E8}"/>
+                <a16:creationId xmlns:a16="http://schemas.microsoft.com/office/drawing/2014/main" id="{765183A6-C70A-4649-98BE-185BA2B3E4CA}"/>
               </a:ext>
             </a:extLst>
           </p:cNvPr>
@@ -9575,7 +9592,7 @@
           <p:cNvPr id="3" name="">
             <a:extLst xmlns:a="http://schemas.openxmlformats.org/drawingml/2006/main">
               <a:ext uri="{FF2B5EF4-FFF2-40B4-BE49-F238E27FC236}">
-                <a16:creationId xmlns:a16="http://schemas.microsoft.com/office/drawing/2014/main" id="{2969A243-E575-4B13-AE1E-4A71A8B7501E}"/>
+                <a16:creationId xmlns:a16="http://schemas.microsoft.com/office/drawing/2014/main" id="{FFB09CA4-FEDA-461A-817C-34C1DE4376DD}"/>
               </a:ext>
             </a:extLst>
           </p:cNvPr>
@@ -9625,7 +9642,7 @@
           <p:cNvPr id="4" name="">
             <a:extLst xmlns:a="http://schemas.openxmlformats.org/drawingml/2006/main">
               <a:ext uri="{FF2B5EF4-FFF2-40B4-BE49-F238E27FC236}">
-                <a16:creationId xmlns:a16="http://schemas.microsoft.com/office/drawing/2014/main" id="{FEFED1F9-6953-43E4-AAF5-4650754C0129}"/>
+                <a16:creationId xmlns:a16="http://schemas.microsoft.com/office/drawing/2014/main" id="{7F7986BC-A73D-444F-A2E5-DF3A5F1F7401}"/>
               </a:ext>
             </a:extLst>
           </p:cNvPr>
@@ -9656,7 +9673,7 @@
           <p:cNvPr id="5" name="footer-5">
             <a:extLst xmlns:a="http://schemas.openxmlformats.org/drawingml/2006/main">
               <a:ext uri="{FF2B5EF4-FFF2-40B4-BE49-F238E27FC236}">
-                <a16:creationId xmlns:a16="http://schemas.microsoft.com/office/drawing/2014/main" id="{AADF0D0C-BFE7-4583-84DB-EF1D40D7AE9A}"/>
+                <a16:creationId xmlns:a16="http://schemas.microsoft.com/office/drawing/2014/main" id="{B68B9103-A719-4337-AE87-63A6B7C1C872}"/>
               </a:ext>
             </a:extLst>
           </p:cNvPr>
@@ -9706,7 +9723,7 @@
           <p:cNvPr id="6" name="">
             <a:extLst xmlns:a="http://schemas.openxmlformats.org/drawingml/2006/main">
               <a:ext uri="{FF2B5EF4-FFF2-40B4-BE49-F238E27FC236}">
-                <a16:creationId xmlns:a16="http://schemas.microsoft.com/office/drawing/2014/main" id="{6F990245-B0A3-4428-B466-93CBD8FB5B55}"/>
+                <a16:creationId xmlns:a16="http://schemas.microsoft.com/office/drawing/2014/main" id="{66EF2C88-AFBA-45B3-AF43-BD385970624E}"/>
               </a:ext>
             </a:extLst>
           </p:cNvPr>
@@ -9756,7 +9773,7 @@
           <p:cNvPr id="7" name="">
             <a:extLst xmlns:a="http://schemas.openxmlformats.org/drawingml/2006/main">
               <a:ext uri="{FF2B5EF4-FFF2-40B4-BE49-F238E27FC236}">
-                <a16:creationId xmlns:a16="http://schemas.microsoft.com/office/drawing/2014/main" id="{F33CEA66-3EA8-4217-ABB8-A6CD332834A5}"/>
+                <a16:creationId xmlns:a16="http://schemas.microsoft.com/office/drawing/2014/main" id="{E520140E-22FA-4152-BD4D-1568A2EF2AA8}"/>
               </a:ext>
             </a:extLst>
           </p:cNvPr>
@@ -9857,7 +9874,7 @@
           <p:cNvPr id="8" name="">
             <a:extLst xmlns:a="http://schemas.openxmlformats.org/drawingml/2006/main">
               <a:ext uri="{FF2B5EF4-FFF2-40B4-BE49-F238E27FC236}">
-                <a16:creationId xmlns:a16="http://schemas.microsoft.com/office/drawing/2014/main" id="{1594AEA1-9AF8-419C-8A18-DBFBCD34E62A}"/>
+                <a16:creationId xmlns:a16="http://schemas.microsoft.com/office/drawing/2014/main" id="{BE53D736-B6B1-4039-8EF6-A13C19300283}"/>
               </a:ext>
             </a:extLst>
           </p:cNvPr>
@@ -9892,7 +9909,7 @@
           <p:cNvPr id="9" name="">
             <a:extLst xmlns:a="http://schemas.openxmlformats.org/drawingml/2006/main">
               <a:ext uri="{FF2B5EF4-FFF2-40B4-BE49-F238E27FC236}">
-                <a16:creationId xmlns:a16="http://schemas.microsoft.com/office/drawing/2014/main" id="{E18EBCAB-7B4B-4CB1-AF15-4BA309F46813}"/>
+                <a16:creationId xmlns:a16="http://schemas.microsoft.com/office/drawing/2014/main" id="{41B1CE87-0FA9-4792-977B-0F76A555DF13}"/>
               </a:ext>
             </a:extLst>
           </p:cNvPr>
@@ -9942,7 +9959,7 @@
           <p:cNvPr id="10" name="">
             <a:extLst xmlns:a="http://schemas.openxmlformats.org/drawingml/2006/main">
               <a:ext uri="{FF2B5EF4-FFF2-40B4-BE49-F238E27FC236}">
-                <a16:creationId xmlns:a16="http://schemas.microsoft.com/office/drawing/2014/main" id="{95C744FE-C5C3-43F1-9938-C6C363A28F43}"/>
+                <a16:creationId xmlns:a16="http://schemas.microsoft.com/office/drawing/2014/main" id="{7FADCC52-8759-4893-AE45-1985DD29178E}"/>
               </a:ext>
             </a:extLst>
           </p:cNvPr>
@@ -10009,7 +10026,7 @@
           <p:cNvPr id="11" name="">
             <a:extLst xmlns:a="http://schemas.openxmlformats.org/drawingml/2006/main">
               <a:ext uri="{FF2B5EF4-FFF2-40B4-BE49-F238E27FC236}">
-                <a16:creationId xmlns:a16="http://schemas.microsoft.com/office/drawing/2014/main" id="{D573853E-8755-4193-A40A-E5D7AFE7DF53}"/>
+                <a16:creationId xmlns:a16="http://schemas.microsoft.com/office/drawing/2014/main" id="{BA346D70-C732-4567-B310-D9F61A97E623}"/>
               </a:ext>
             </a:extLst>
           </p:cNvPr>
@@ -10057,7 +10074,7 @@
     </p:spTree>
     <p:extLst>
       <p:ext uri="{BB962C8B-B14F-4D97-AF65-F5344CB8AC3E}">
-        <p14:creationId xmlns:p14="http://schemas.microsoft.com/office/powerpoint/2010/main" val="785415564"/>
+        <p14:creationId xmlns:p14="http://schemas.microsoft.com/office/powerpoint/2010/main" val="1185360260"/>
       </p:ext>
     </p:extLst>
   </p:cSld>
@@ -10088,7 +10105,7 @@
           <p:cNvPr id="1" name="">
             <a:extLst xmlns:a="http://schemas.openxmlformats.org/drawingml/2006/main">
               <a:ext uri="{FF2B5EF4-FFF2-40B4-BE49-F238E27FC236}">
-                <a16:creationId xmlns:a16="http://schemas.microsoft.com/office/drawing/2014/main" id="{2F289977-6278-48B5-9DEE-DC0E2D5D0015}"/>
+                <a16:creationId xmlns:a16="http://schemas.microsoft.com/office/drawing/2014/main" id="{6DCC4BAF-E9B8-452F-A227-04FA049B5DDD}"/>
               </a:ext>
             </a:extLst>
           </p:cNvPr>
@@ -10119,7 +10136,7 @@
           <p:cNvPr id="2" name="">
             <a:extLst xmlns:a="http://schemas.openxmlformats.org/drawingml/2006/main">
               <a:ext uri="{FF2B5EF4-FFF2-40B4-BE49-F238E27FC236}">
-                <a16:creationId xmlns:a16="http://schemas.microsoft.com/office/drawing/2014/main" id="{112A9469-559C-4821-949C-A6D324298EEA}"/>
+                <a16:creationId xmlns:a16="http://schemas.microsoft.com/office/drawing/2014/main" id="{F996FFF5-38E0-4892-BC1F-01ACEC7952AA}"/>
               </a:ext>
             </a:extLst>
           </p:cNvPr>
@@ -10169,7 +10186,7 @@
           <p:cNvPr id="3" name="">
             <a:extLst xmlns:a="http://schemas.openxmlformats.org/drawingml/2006/main">
               <a:ext uri="{FF2B5EF4-FFF2-40B4-BE49-F238E27FC236}">
-                <a16:creationId xmlns:a16="http://schemas.microsoft.com/office/drawing/2014/main" id="{EEBEEF70-10B7-45F0-B7DD-DC566E4B9A59}"/>
+                <a16:creationId xmlns:a16="http://schemas.microsoft.com/office/drawing/2014/main" id="{DC0DF75F-C912-450A-829B-055D815EEB04}"/>
               </a:ext>
             </a:extLst>
           </p:cNvPr>
@@ -10219,7 +10236,7 @@
           <p:cNvPr id="4" name="">
             <a:extLst xmlns:a="http://schemas.openxmlformats.org/drawingml/2006/main">
               <a:ext uri="{FF2B5EF4-FFF2-40B4-BE49-F238E27FC236}">
-                <a16:creationId xmlns:a16="http://schemas.microsoft.com/office/drawing/2014/main" id="{0953FB6E-4CF2-42DB-A92C-6AF6E39F22B1}"/>
+                <a16:creationId xmlns:a16="http://schemas.microsoft.com/office/drawing/2014/main" id="{9166E22D-DE3F-4FAF-8C86-9520550D7C63}"/>
               </a:ext>
             </a:extLst>
           </p:cNvPr>
@@ -10250,7 +10267,7 @@
           <p:cNvPr id="5" name="footer-6">
             <a:extLst xmlns:a="http://schemas.openxmlformats.org/drawingml/2006/main">
               <a:ext uri="{FF2B5EF4-FFF2-40B4-BE49-F238E27FC236}">
-                <a16:creationId xmlns:a16="http://schemas.microsoft.com/office/drawing/2014/main" id="{E1162CF6-BA53-4918-8434-7C0C51602AD1}"/>
+                <a16:creationId xmlns:a16="http://schemas.microsoft.com/office/drawing/2014/main" id="{9093021D-640A-4A44-BEFE-95BCBF913CC1}"/>
               </a:ext>
             </a:extLst>
           </p:cNvPr>
@@ -10300,7 +10317,7 @@
           <p:cNvPr id="6" name="">
             <a:extLst xmlns:a="http://schemas.openxmlformats.org/drawingml/2006/main">
               <a:ext uri="{FF2B5EF4-FFF2-40B4-BE49-F238E27FC236}">
-                <a16:creationId xmlns:a16="http://schemas.microsoft.com/office/drawing/2014/main" id="{315FCE94-77D9-4901-9CE5-D27FC7553B09}"/>
+                <a16:creationId xmlns:a16="http://schemas.microsoft.com/office/drawing/2014/main" id="{9005AB1E-75AA-40D7-BA81-601E522D21B3}"/>
               </a:ext>
             </a:extLst>
           </p:cNvPr>
@@ -10335,7 +10352,7 @@
           <p:cNvPr id="7" name="">
             <a:extLst xmlns:a="http://schemas.openxmlformats.org/drawingml/2006/main">
               <a:ext uri="{FF2B5EF4-FFF2-40B4-BE49-F238E27FC236}">
-                <a16:creationId xmlns:a16="http://schemas.microsoft.com/office/drawing/2014/main" id="{2107431F-49CB-4209-9A4D-82402A22DEDA}"/>
+                <a16:creationId xmlns:a16="http://schemas.microsoft.com/office/drawing/2014/main" id="{22FA29F5-C979-454B-AB3B-4CE6D284AFDC}"/>
               </a:ext>
             </a:extLst>
           </p:cNvPr>
@@ -10385,7 +10402,7 @@
           <p:cNvPr id="8" name="">
             <a:extLst xmlns:a="http://schemas.openxmlformats.org/drawingml/2006/main">
               <a:ext uri="{FF2B5EF4-FFF2-40B4-BE49-F238E27FC236}">
-                <a16:creationId xmlns:a16="http://schemas.microsoft.com/office/drawing/2014/main" id="{1FA89575-3C2C-48BC-ABCF-09B2417984A3}"/>
+                <a16:creationId xmlns:a16="http://schemas.microsoft.com/office/drawing/2014/main" id="{8D1B6FA3-9797-4C14-BF41-0495BC3034EF}"/>
               </a:ext>
             </a:extLst>
           </p:cNvPr>
@@ -10420,7 +10437,7 @@
           <p:cNvPr id="9" name="">
             <a:extLst xmlns:a="http://schemas.openxmlformats.org/drawingml/2006/main">
               <a:ext uri="{FF2B5EF4-FFF2-40B4-BE49-F238E27FC236}">
-                <a16:creationId xmlns:a16="http://schemas.microsoft.com/office/drawing/2014/main" id="{09C71B58-E718-43E8-AA4D-8F3707D2C2F6}"/>
+                <a16:creationId xmlns:a16="http://schemas.microsoft.com/office/drawing/2014/main" id="{2AF54372-4F8A-498F-86C4-B9C08A3EE2E0}"/>
               </a:ext>
             </a:extLst>
           </p:cNvPr>
@@ -10470,7 +10487,7 @@
           <p:cNvPr id="10" name="">
             <a:extLst xmlns:a="http://schemas.openxmlformats.org/drawingml/2006/main">
               <a:ext uri="{FF2B5EF4-FFF2-40B4-BE49-F238E27FC236}">
-                <a16:creationId xmlns:a16="http://schemas.microsoft.com/office/drawing/2014/main" id="{204E392A-A756-4D69-A887-3183AC578187}"/>
+                <a16:creationId xmlns:a16="http://schemas.microsoft.com/office/drawing/2014/main" id="{4531545F-1BF7-4C40-B2F5-BA9BB1D4F646}"/>
               </a:ext>
             </a:extLst>
           </p:cNvPr>
@@ -10505,7 +10522,7 @@
           <p:cNvPr id="11" name="">
             <a:extLst xmlns:a="http://schemas.openxmlformats.org/drawingml/2006/main">
               <a:ext uri="{FF2B5EF4-FFF2-40B4-BE49-F238E27FC236}">
-                <a16:creationId xmlns:a16="http://schemas.microsoft.com/office/drawing/2014/main" id="{C44421E8-8B70-49FC-B7E9-3AD0CA35CE43}"/>
+                <a16:creationId xmlns:a16="http://schemas.microsoft.com/office/drawing/2014/main" id="{D6FF8B18-7FFE-4971-9E97-3C7231F0251F}"/>
               </a:ext>
             </a:extLst>
           </p:cNvPr>
@@ -10555,7 +10572,7 @@
           <p:cNvPr id="12" name="">
             <a:extLst xmlns:a="http://schemas.openxmlformats.org/drawingml/2006/main">
               <a:ext uri="{FF2B5EF4-FFF2-40B4-BE49-F238E27FC236}">
-                <a16:creationId xmlns:a16="http://schemas.microsoft.com/office/drawing/2014/main" id="{DDFF0B4E-7FCF-4D23-B8AB-6C3DDCFA8ADA}"/>
+                <a16:creationId xmlns:a16="http://schemas.microsoft.com/office/drawing/2014/main" id="{00F6B5EF-7ED7-4A82-AB9D-FFDF88154129}"/>
               </a:ext>
             </a:extLst>
           </p:cNvPr>
@@ -10590,7 +10607,7 @@
           <p:cNvPr id="13" name="">
             <a:extLst xmlns:a="http://schemas.openxmlformats.org/drawingml/2006/main">
               <a:ext uri="{FF2B5EF4-FFF2-40B4-BE49-F238E27FC236}">
-                <a16:creationId xmlns:a16="http://schemas.microsoft.com/office/drawing/2014/main" id="{2B2937BF-9EB2-4415-BF57-4AB84604B794}"/>
+                <a16:creationId xmlns:a16="http://schemas.microsoft.com/office/drawing/2014/main" id="{C17448E8-5AA5-4EFE-8547-DD56BAB1F4F5}"/>
               </a:ext>
             </a:extLst>
           </p:cNvPr>
@@ -10640,7 +10657,7 @@
           <p:cNvPr id="14" name="">
             <a:extLst xmlns:a="http://schemas.openxmlformats.org/drawingml/2006/main">
               <a:ext uri="{FF2B5EF4-FFF2-40B4-BE49-F238E27FC236}">
-                <a16:creationId xmlns:a16="http://schemas.microsoft.com/office/drawing/2014/main" id="{388D3E45-CA88-486F-AE66-5B131CE147F2}"/>
+                <a16:creationId xmlns:a16="http://schemas.microsoft.com/office/drawing/2014/main" id="{8F1C68B0-1C39-4E18-B5CE-C4BCF398A7A5}"/>
               </a:ext>
             </a:extLst>
           </p:cNvPr>
@@ -10741,7 +10758,7 @@
           <p:cNvPr id="15" name="">
             <a:extLst xmlns:a="http://schemas.openxmlformats.org/drawingml/2006/main">
               <a:ext uri="{FF2B5EF4-FFF2-40B4-BE49-F238E27FC236}">
-                <a16:creationId xmlns:a16="http://schemas.microsoft.com/office/drawing/2014/main" id="{72DD9749-D663-457E-BE8D-1AD815C765BA}"/>
+                <a16:creationId xmlns:a16="http://schemas.microsoft.com/office/drawing/2014/main" id="{4CD856B5-C9CD-48D1-BF99-A34DD494395F}"/>
               </a:ext>
             </a:extLst>
           </p:cNvPr>
@@ -10772,7 +10789,7 @@
           <p:cNvPr id="16" name="">
             <a:extLst xmlns:a="http://schemas.openxmlformats.org/drawingml/2006/main">
               <a:ext uri="{FF2B5EF4-FFF2-40B4-BE49-F238E27FC236}">
-                <a16:creationId xmlns:a16="http://schemas.microsoft.com/office/drawing/2014/main" id="{E89555B8-17AC-4431-BF84-F83F9A04E6A6}"/>
+                <a16:creationId xmlns:a16="http://schemas.microsoft.com/office/drawing/2014/main" id="{F2919A75-4A5D-4798-BC69-988FE2D798D1}"/>
               </a:ext>
             </a:extLst>
           </p:cNvPr>
@@ -10803,7 +10820,7 @@
           <p:cNvPr id="17" name="">
             <a:extLst xmlns:a="http://schemas.openxmlformats.org/drawingml/2006/main">
               <a:ext uri="{FF2B5EF4-FFF2-40B4-BE49-F238E27FC236}">
-                <a16:creationId xmlns:a16="http://schemas.microsoft.com/office/drawing/2014/main" id="{5D2A783F-517E-41DE-A397-15B2F8372BF4}"/>
+                <a16:creationId xmlns:a16="http://schemas.microsoft.com/office/drawing/2014/main" id="{50BFB05A-EA13-4492-B6F4-89A85CA4A3E1}"/>
               </a:ext>
             </a:extLst>
           </p:cNvPr>
@@ -10834,7 +10851,7 @@
           <p:cNvPr id="18" name="">
             <a:extLst xmlns:a="http://schemas.openxmlformats.org/drawingml/2006/main">
               <a:ext uri="{FF2B5EF4-FFF2-40B4-BE49-F238E27FC236}">
-                <a16:creationId xmlns:a16="http://schemas.microsoft.com/office/drawing/2014/main" id="{09A2BAD2-C9A0-40A5-BB61-F299334C2483}"/>
+                <a16:creationId xmlns:a16="http://schemas.microsoft.com/office/drawing/2014/main" id="{46E0FDC9-D7B5-4637-9A12-3F721F2C7255}"/>
               </a:ext>
             </a:extLst>
           </p:cNvPr>
@@ -10884,7 +10901,7 @@
           <p:cNvPr id="19" name="">
             <a:extLst xmlns:a="http://schemas.openxmlformats.org/drawingml/2006/main">
               <a:ext uri="{FF2B5EF4-FFF2-40B4-BE49-F238E27FC236}">
-                <a16:creationId xmlns:a16="http://schemas.microsoft.com/office/drawing/2014/main" id="{7A15B573-1634-4011-B36D-EAA968CF7588}"/>
+                <a16:creationId xmlns:a16="http://schemas.microsoft.com/office/drawing/2014/main" id="{A9ED54CC-F6B2-4377-B6EF-F9BA348F8BB9}"/>
               </a:ext>
             </a:extLst>
           </p:cNvPr>
@@ -10932,7 +10949,7 @@
     </p:spTree>
     <p:extLst>
       <p:ext uri="{BB962C8B-B14F-4D97-AF65-F5344CB8AC3E}">
-        <p14:creationId xmlns:p14="http://schemas.microsoft.com/office/powerpoint/2010/main" val="464523770"/>
+        <p14:creationId xmlns:p14="http://schemas.microsoft.com/office/powerpoint/2010/main" val="1150530340"/>
       </p:ext>
     </p:extLst>
   </p:cSld>
@@ -10963,7 +10980,7 @@
           <p:cNvPr id="1" name="">
             <a:extLst xmlns:a="http://schemas.openxmlformats.org/drawingml/2006/main">
               <a:ext uri="{FF2B5EF4-FFF2-40B4-BE49-F238E27FC236}">
-                <a16:creationId xmlns:a16="http://schemas.microsoft.com/office/drawing/2014/main" id="{5B4D73A9-3844-4E5B-A167-F5C6F41193F2}"/>
+                <a16:creationId xmlns:a16="http://schemas.microsoft.com/office/drawing/2014/main" id="{3C7305F4-0337-4329-93E7-16AB64E5C53C}"/>
               </a:ext>
             </a:extLst>
           </p:cNvPr>
@@ -10994,7 +11011,7 @@
           <p:cNvPr id="2" name="">
             <a:extLst xmlns:a="http://schemas.openxmlformats.org/drawingml/2006/main">
               <a:ext uri="{FF2B5EF4-FFF2-40B4-BE49-F238E27FC236}">
-                <a16:creationId xmlns:a16="http://schemas.microsoft.com/office/drawing/2014/main" id="{46B0D665-16CE-4D4C-8FC9-29728065D0E5}"/>
+                <a16:creationId xmlns:a16="http://schemas.microsoft.com/office/drawing/2014/main" id="{44513DD2-9C3B-4D00-9039-4FC491DCA7A0}"/>
               </a:ext>
             </a:extLst>
           </p:cNvPr>
@@ -11044,7 +11061,7 @@
           <p:cNvPr id="3" name="">
             <a:extLst xmlns:a="http://schemas.openxmlformats.org/drawingml/2006/main">
               <a:ext uri="{FF2B5EF4-FFF2-40B4-BE49-F238E27FC236}">
-                <a16:creationId xmlns:a16="http://schemas.microsoft.com/office/drawing/2014/main" id="{9FD3AE99-43AD-4EF6-8982-9BC1B7460FBB}"/>
+                <a16:creationId xmlns:a16="http://schemas.microsoft.com/office/drawing/2014/main" id="{ABA5C4AF-50A3-487E-8517-7A96003D7561}"/>
               </a:ext>
             </a:extLst>
           </p:cNvPr>
@@ -11094,7 +11111,7 @@
           <p:cNvPr id="4" name="">
             <a:extLst xmlns:a="http://schemas.openxmlformats.org/drawingml/2006/main">
               <a:ext uri="{FF2B5EF4-FFF2-40B4-BE49-F238E27FC236}">
-                <a16:creationId xmlns:a16="http://schemas.microsoft.com/office/drawing/2014/main" id="{599E1A7F-2E4D-4D1D-97C9-65804AA7D000}"/>
+                <a16:creationId xmlns:a16="http://schemas.microsoft.com/office/drawing/2014/main" id="{4FC133C5-9492-4B18-BF48-CAB0E3063BD7}"/>
               </a:ext>
             </a:extLst>
           </p:cNvPr>
@@ -11125,7 +11142,7 @@
           <p:cNvPr id="5" name="footer-7">
             <a:extLst xmlns:a="http://schemas.openxmlformats.org/drawingml/2006/main">
               <a:ext uri="{FF2B5EF4-FFF2-40B4-BE49-F238E27FC236}">
-                <a16:creationId xmlns:a16="http://schemas.microsoft.com/office/drawing/2014/main" id="{603A6902-A84B-4DC2-8364-773A36876A44}"/>
+                <a16:creationId xmlns:a16="http://schemas.microsoft.com/office/drawing/2014/main" id="{5EDACED6-8926-4FD3-AAAC-3F40C38D293A}"/>
               </a:ext>
             </a:extLst>
           </p:cNvPr>
@@ -11175,7 +11192,7 @@
           <p:cNvPr id="6" name="">
             <a:extLst xmlns:a="http://schemas.openxmlformats.org/drawingml/2006/main">
               <a:ext uri="{FF2B5EF4-FFF2-40B4-BE49-F238E27FC236}">
-                <a16:creationId xmlns:a16="http://schemas.microsoft.com/office/drawing/2014/main" id="{4A7F1E62-35E5-4688-8D90-4CC72CBA6102}"/>
+                <a16:creationId xmlns:a16="http://schemas.microsoft.com/office/drawing/2014/main" id="{E491AB46-DF72-4786-82EC-B7223607F4A1}"/>
               </a:ext>
             </a:extLst>
           </p:cNvPr>
@@ -11210,7 +11227,7 @@
           <p:cNvPr id="7" name="">
             <a:extLst xmlns:a="http://schemas.openxmlformats.org/drawingml/2006/main">
               <a:ext uri="{FF2B5EF4-FFF2-40B4-BE49-F238E27FC236}">
-                <a16:creationId xmlns:a16="http://schemas.microsoft.com/office/drawing/2014/main" id="{606BCBE2-143D-4A59-B182-336A0205CEF6}"/>
+                <a16:creationId xmlns:a16="http://schemas.microsoft.com/office/drawing/2014/main" id="{7C189AAF-4FB2-4A09-B608-1CA9FB2F830A}"/>
               </a:ext>
             </a:extLst>
           </p:cNvPr>
@@ -11260,7 +11277,7 @@
           <p:cNvPr id="8" name="">
             <a:extLst xmlns:a="http://schemas.openxmlformats.org/drawingml/2006/main">
               <a:ext uri="{FF2B5EF4-FFF2-40B4-BE49-F238E27FC236}">
-                <a16:creationId xmlns:a16="http://schemas.microsoft.com/office/drawing/2014/main" id="{6F871BC3-5BBA-4FE1-97A4-5699228D562A}"/>
+                <a16:creationId xmlns:a16="http://schemas.microsoft.com/office/drawing/2014/main" id="{34085461-06DE-400C-92A1-2B6140FCF4D8}"/>
               </a:ext>
             </a:extLst>
           </p:cNvPr>
@@ -11327,7 +11344,7 @@
           <p:cNvPr id="9" name="">
             <a:extLst xmlns:a="http://schemas.openxmlformats.org/drawingml/2006/main">
               <a:ext uri="{FF2B5EF4-FFF2-40B4-BE49-F238E27FC236}">
-                <a16:creationId xmlns:a16="http://schemas.microsoft.com/office/drawing/2014/main" id="{EC976377-D525-4888-BA7A-00FF28B60E53}"/>
+                <a16:creationId xmlns:a16="http://schemas.microsoft.com/office/drawing/2014/main" id="{46843D97-F423-4E57-864E-9393E3A36F6C}"/>
               </a:ext>
             </a:extLst>
           </p:cNvPr>
@@ -11362,7 +11379,7 @@
           <p:cNvPr id="10" name="">
             <a:extLst xmlns:a="http://schemas.openxmlformats.org/drawingml/2006/main">
               <a:ext uri="{FF2B5EF4-FFF2-40B4-BE49-F238E27FC236}">
-                <a16:creationId xmlns:a16="http://schemas.microsoft.com/office/drawing/2014/main" id="{3537E92A-DE2C-49E3-ABA0-71ECFC8A0E3A}"/>
+                <a16:creationId xmlns:a16="http://schemas.microsoft.com/office/drawing/2014/main" id="{F8DBD606-6130-4C1E-AD9A-91D5BFE56082}"/>
               </a:ext>
             </a:extLst>
           </p:cNvPr>
@@ -11412,7 +11429,7 @@
           <p:cNvPr id="11" name="">
             <a:extLst xmlns:a="http://schemas.openxmlformats.org/drawingml/2006/main">
               <a:ext uri="{FF2B5EF4-FFF2-40B4-BE49-F238E27FC236}">
-                <a16:creationId xmlns:a16="http://schemas.microsoft.com/office/drawing/2014/main" id="{6D8137F6-4BEC-472D-84EC-415C5CC3F03B}"/>
+                <a16:creationId xmlns:a16="http://schemas.microsoft.com/office/drawing/2014/main" id="{F5EE59E7-BADA-4E8A-908E-40873145252E}"/>
               </a:ext>
             </a:extLst>
           </p:cNvPr>
@@ -11462,7 +11479,7 @@
           <p:cNvPr id="12" name="">
             <a:extLst xmlns:a="http://schemas.openxmlformats.org/drawingml/2006/main">
               <a:ext uri="{FF2B5EF4-FFF2-40B4-BE49-F238E27FC236}">
-                <a16:creationId xmlns:a16="http://schemas.microsoft.com/office/drawing/2014/main" id="{25AA6218-8DC4-4092-A53B-B65842D67D6D}"/>
+                <a16:creationId xmlns:a16="http://schemas.microsoft.com/office/drawing/2014/main" id="{E79F736C-8CEE-4936-B1D3-A91F1ED91303}"/>
               </a:ext>
             </a:extLst>
           </p:cNvPr>
@@ -11512,7 +11529,7 @@
           <p:cNvPr id="13" name="">
             <a:extLst xmlns:a="http://schemas.openxmlformats.org/drawingml/2006/main">
               <a:ext uri="{FF2B5EF4-FFF2-40B4-BE49-F238E27FC236}">
-                <a16:creationId xmlns:a16="http://schemas.microsoft.com/office/drawing/2014/main" id="{0DA0F635-2603-4665-AD2A-D02EBD9847A6}"/>
+                <a16:creationId xmlns:a16="http://schemas.microsoft.com/office/drawing/2014/main" id="{BB51FC46-7C97-4AF2-A393-A24E07322E86}"/>
               </a:ext>
             </a:extLst>
           </p:cNvPr>
@@ -11579,7 +11596,7 @@
           <p:cNvPr id="14" name="">
             <a:extLst xmlns:a="http://schemas.openxmlformats.org/drawingml/2006/main">
               <a:ext uri="{FF2B5EF4-FFF2-40B4-BE49-F238E27FC236}">
-                <a16:creationId xmlns:a16="http://schemas.microsoft.com/office/drawing/2014/main" id="{1566DA08-765C-4B2F-B8C9-717E8C13402D}"/>
+                <a16:creationId xmlns:a16="http://schemas.microsoft.com/office/drawing/2014/main" id="{E4F1A386-F039-40A5-93E2-05E246233EE9}"/>
               </a:ext>
             </a:extLst>
           </p:cNvPr>
@@ -11627,7 +11644,7 @@
     </p:spTree>
     <p:extLst>
       <p:ext uri="{BB962C8B-B14F-4D97-AF65-F5344CB8AC3E}">
-        <p14:creationId xmlns:p14="http://schemas.microsoft.com/office/powerpoint/2010/main" val="2097387919"/>
+        <p14:creationId xmlns:p14="http://schemas.microsoft.com/office/powerpoint/2010/main" val="740612699"/>
       </p:ext>
     </p:extLst>
   </p:cSld>
@@ -11658,7 +11675,7 @@
           <p:cNvPr id="1" name="">
             <a:extLst xmlns:a="http://schemas.openxmlformats.org/drawingml/2006/main">
               <a:ext uri="{FF2B5EF4-FFF2-40B4-BE49-F238E27FC236}">
-                <a16:creationId xmlns:a16="http://schemas.microsoft.com/office/drawing/2014/main" id="{6D18EF72-D4CB-4E4D-8497-BD42AC39239B}"/>
+                <a16:creationId xmlns:a16="http://schemas.microsoft.com/office/drawing/2014/main" id="{8B9F0D34-4374-4CF9-A906-68C79BAD0C78}"/>
               </a:ext>
             </a:extLst>
           </p:cNvPr>
@@ -11689,7 +11706,7 @@
           <p:cNvPr id="2" name="">
             <a:extLst xmlns:a="http://schemas.openxmlformats.org/drawingml/2006/main">
               <a:ext uri="{FF2B5EF4-FFF2-40B4-BE49-F238E27FC236}">
-                <a16:creationId xmlns:a16="http://schemas.microsoft.com/office/drawing/2014/main" id="{69B3F311-9D88-475A-AA41-C28FA5020477}"/>
+                <a16:creationId xmlns:a16="http://schemas.microsoft.com/office/drawing/2014/main" id="{3EC1A386-9809-44C3-9E2C-47894D6E748F}"/>
               </a:ext>
             </a:extLst>
           </p:cNvPr>
@@ -11739,7 +11756,7 @@
           <p:cNvPr id="3" name="">
             <a:extLst xmlns:a="http://schemas.openxmlformats.org/drawingml/2006/main">
               <a:ext uri="{FF2B5EF4-FFF2-40B4-BE49-F238E27FC236}">
-                <a16:creationId xmlns:a16="http://schemas.microsoft.com/office/drawing/2014/main" id="{B6FC7DAA-6F15-40F9-8F60-CB2816C8933E}"/>
+                <a16:creationId xmlns:a16="http://schemas.microsoft.com/office/drawing/2014/main" id="{16F369ED-A494-4A8E-AD70-7E0815DEE931}"/>
               </a:ext>
             </a:extLst>
           </p:cNvPr>
@@ -11789,7 +11806,7 @@
           <p:cNvPr id="4" name="">
             <a:extLst xmlns:a="http://schemas.openxmlformats.org/drawingml/2006/main">
               <a:ext uri="{FF2B5EF4-FFF2-40B4-BE49-F238E27FC236}">
-                <a16:creationId xmlns:a16="http://schemas.microsoft.com/office/drawing/2014/main" id="{DF58C4AF-B3F4-4D4E-953A-CF3CDACCF86D}"/>
+                <a16:creationId xmlns:a16="http://schemas.microsoft.com/office/drawing/2014/main" id="{E95ABC1E-6368-45B1-AF00-CFE1266AE9C9}"/>
               </a:ext>
             </a:extLst>
           </p:cNvPr>
@@ -11820,7 +11837,7 @@
           <p:cNvPr id="5" name="footer-8">
             <a:extLst xmlns:a="http://schemas.openxmlformats.org/drawingml/2006/main">
               <a:ext uri="{FF2B5EF4-FFF2-40B4-BE49-F238E27FC236}">
-                <a16:creationId xmlns:a16="http://schemas.microsoft.com/office/drawing/2014/main" id="{513E2D05-0EC2-48B1-8C49-F080A66B18EB}"/>
+                <a16:creationId xmlns:a16="http://schemas.microsoft.com/office/drawing/2014/main" id="{522CDB25-3AA1-4AD1-93C3-53BD6F910F35}"/>
               </a:ext>
             </a:extLst>
           </p:cNvPr>
@@ -11870,7 +11887,7 @@
           <p:cNvPr id="6" name="">
             <a:extLst xmlns:a="http://schemas.openxmlformats.org/drawingml/2006/main">
               <a:ext uri="{FF2B5EF4-FFF2-40B4-BE49-F238E27FC236}">
-                <a16:creationId xmlns:a16="http://schemas.microsoft.com/office/drawing/2014/main" id="{81453465-BBA1-46DB-A6CC-D8541FA12547}"/>
+                <a16:creationId xmlns:a16="http://schemas.microsoft.com/office/drawing/2014/main" id="{C84DE9D9-36D9-4782-95D7-87A9AE094541}"/>
               </a:ext>
             </a:extLst>
           </p:cNvPr>
@@ -11905,7 +11922,7 @@
           <p:cNvPr id="7" name="">
             <a:extLst xmlns:a="http://schemas.openxmlformats.org/drawingml/2006/main">
               <a:ext uri="{FF2B5EF4-FFF2-40B4-BE49-F238E27FC236}">
-                <a16:creationId xmlns:a16="http://schemas.microsoft.com/office/drawing/2014/main" id="{ADE56CCA-77B5-4ECF-9A55-88F78F6F2418}"/>
+                <a16:creationId xmlns:a16="http://schemas.microsoft.com/office/drawing/2014/main" id="{90CEF57E-7BB5-4DA9-9639-F694B6B3176E}"/>
               </a:ext>
             </a:extLst>
           </p:cNvPr>
@@ -11955,7 +11972,7 @@
           <p:cNvPr id="8" name="">
             <a:extLst xmlns:a="http://schemas.openxmlformats.org/drawingml/2006/main">
               <a:ext uri="{FF2B5EF4-FFF2-40B4-BE49-F238E27FC236}">
-                <a16:creationId xmlns:a16="http://schemas.microsoft.com/office/drawing/2014/main" id="{EF5E4B90-8D40-436A-8DE7-47E3F249D441}"/>
+                <a16:creationId xmlns:a16="http://schemas.microsoft.com/office/drawing/2014/main" id="{A3BCC842-2FBE-4653-BC24-B6D078C28E83}"/>
               </a:ext>
             </a:extLst>
           </p:cNvPr>
@@ -12005,7 +12022,7 @@
           <p:cNvPr id="9" name="">
             <a:extLst xmlns:a="http://schemas.openxmlformats.org/drawingml/2006/main">
               <a:ext uri="{FF2B5EF4-FFF2-40B4-BE49-F238E27FC236}">
-                <a16:creationId xmlns:a16="http://schemas.microsoft.com/office/drawing/2014/main" id="{C6CB8F71-A0B8-4AE5-8CEC-63B7BCC83E36}"/>
+                <a16:creationId xmlns:a16="http://schemas.microsoft.com/office/drawing/2014/main" id="{2710FF53-7EA3-4C56-A438-BFCDE75FC247}"/>
               </a:ext>
             </a:extLst>
           </p:cNvPr>
@@ -12040,7 +12057,7 @@
           <p:cNvPr id="10" name="">
             <a:extLst xmlns:a="http://schemas.openxmlformats.org/drawingml/2006/main">
               <a:ext uri="{FF2B5EF4-FFF2-40B4-BE49-F238E27FC236}">
-                <a16:creationId xmlns:a16="http://schemas.microsoft.com/office/drawing/2014/main" id="{1620358B-B486-4DF0-8C38-090480DE26F7}"/>
+                <a16:creationId xmlns:a16="http://schemas.microsoft.com/office/drawing/2014/main" id="{03E0FDF4-9640-4A85-8F1A-28066C3A48BC}"/>
               </a:ext>
             </a:extLst>
           </p:cNvPr>
@@ -12090,7 +12107,7 @@
           <p:cNvPr id="11" name="">
             <a:extLst xmlns:a="http://schemas.openxmlformats.org/drawingml/2006/main">
               <a:ext uri="{FF2B5EF4-FFF2-40B4-BE49-F238E27FC236}">
-                <a16:creationId xmlns:a16="http://schemas.microsoft.com/office/drawing/2014/main" id="{607FC3F2-5B20-464C-9F9A-F8320ED8A807}"/>
+                <a16:creationId xmlns:a16="http://schemas.microsoft.com/office/drawing/2014/main" id="{D1C0DAD8-D403-4ED9-BFE4-F48E08BDA0BA}"/>
               </a:ext>
             </a:extLst>
           </p:cNvPr>
@@ -12140,7 +12157,7 @@
           <p:cNvPr id="12" name="">
             <a:extLst xmlns:a="http://schemas.openxmlformats.org/drawingml/2006/main">
               <a:ext uri="{FF2B5EF4-FFF2-40B4-BE49-F238E27FC236}">
-                <a16:creationId xmlns:a16="http://schemas.microsoft.com/office/drawing/2014/main" id="{06E9079D-FD86-47BE-AED6-92EE8183A2E6}"/>
+                <a16:creationId xmlns:a16="http://schemas.microsoft.com/office/drawing/2014/main" id="{F4D8EE3F-D301-4260-AFB3-126745DD4A9C}"/>
               </a:ext>
             </a:extLst>
           </p:cNvPr>
@@ -12175,7 +12192,7 @@
           <p:cNvPr id="13" name="">
             <a:extLst xmlns:a="http://schemas.openxmlformats.org/drawingml/2006/main">
               <a:ext uri="{FF2B5EF4-FFF2-40B4-BE49-F238E27FC236}">
-                <a16:creationId xmlns:a16="http://schemas.microsoft.com/office/drawing/2014/main" id="{9528D6D5-ECC9-484A-B924-959EAADFE279}"/>
+                <a16:creationId xmlns:a16="http://schemas.microsoft.com/office/drawing/2014/main" id="{690C7F1D-0BD3-4F89-9AEF-3349DF6DA2B6}"/>
               </a:ext>
             </a:extLst>
           </p:cNvPr>
@@ -12225,7 +12242,7 @@
           <p:cNvPr id="14" name="">
             <a:extLst xmlns:a="http://schemas.openxmlformats.org/drawingml/2006/main">
               <a:ext uri="{FF2B5EF4-FFF2-40B4-BE49-F238E27FC236}">
-                <a16:creationId xmlns:a16="http://schemas.microsoft.com/office/drawing/2014/main" id="{70606273-5039-4E10-AD97-AF1ED217249C}"/>
+                <a16:creationId xmlns:a16="http://schemas.microsoft.com/office/drawing/2014/main" id="{A149BB18-4CEC-4C44-8891-1B709C09AAE5}"/>
               </a:ext>
             </a:extLst>
           </p:cNvPr>
@@ -12275,7 +12292,7 @@
           <p:cNvPr id="15" name="">
             <a:extLst xmlns:a="http://schemas.openxmlformats.org/drawingml/2006/main">
               <a:ext uri="{FF2B5EF4-FFF2-40B4-BE49-F238E27FC236}">
-                <a16:creationId xmlns:a16="http://schemas.microsoft.com/office/drawing/2014/main" id="{98C506F3-6628-4251-B6B0-ED688466D6FB}"/>
+                <a16:creationId xmlns:a16="http://schemas.microsoft.com/office/drawing/2014/main" id="{916C3ADF-D148-40BD-987A-C58F5C225A21}"/>
               </a:ext>
             </a:extLst>
           </p:cNvPr>
@@ -12310,7 +12327,7 @@
           <p:cNvPr id="16" name="">
             <a:extLst xmlns:a="http://schemas.openxmlformats.org/drawingml/2006/main">
               <a:ext uri="{FF2B5EF4-FFF2-40B4-BE49-F238E27FC236}">
-                <a16:creationId xmlns:a16="http://schemas.microsoft.com/office/drawing/2014/main" id="{56C025C5-488D-4BAC-96A8-07D1A29EB331}"/>
+                <a16:creationId xmlns:a16="http://schemas.microsoft.com/office/drawing/2014/main" id="{A5D52F35-7D6B-43A8-9D9F-D42826BF1ED7}"/>
               </a:ext>
             </a:extLst>
           </p:cNvPr>
@@ -12360,7 +12377,7 @@
           <p:cNvPr id="17" name="">
             <a:extLst xmlns:a="http://schemas.openxmlformats.org/drawingml/2006/main">
               <a:ext uri="{FF2B5EF4-FFF2-40B4-BE49-F238E27FC236}">
-                <a16:creationId xmlns:a16="http://schemas.microsoft.com/office/drawing/2014/main" id="{2E7920F3-C140-43E5-91D5-D0E791F69B87}"/>
+                <a16:creationId xmlns:a16="http://schemas.microsoft.com/office/drawing/2014/main" id="{46AC130C-CCEF-49E1-9C2F-CA0B117BBED8}"/>
               </a:ext>
             </a:extLst>
           </p:cNvPr>
@@ -12410,7 +12427,7 @@
           <p:cNvPr id="18" name="">
             <a:extLst xmlns:a="http://schemas.openxmlformats.org/drawingml/2006/main">
               <a:ext uri="{FF2B5EF4-FFF2-40B4-BE49-F238E27FC236}">
-                <a16:creationId xmlns:a16="http://schemas.microsoft.com/office/drawing/2014/main" id="{8D40608F-3F30-440B-BD63-A73767ED65EC}"/>
+                <a16:creationId xmlns:a16="http://schemas.microsoft.com/office/drawing/2014/main" id="{07C1C929-DC18-436B-8FC0-2B5F3969625E}"/>
               </a:ext>
             </a:extLst>
           </p:cNvPr>
@@ -12445,7 +12462,7 @@
           <p:cNvPr id="19" name="">
             <a:extLst xmlns:a="http://schemas.openxmlformats.org/drawingml/2006/main">
               <a:ext uri="{FF2B5EF4-FFF2-40B4-BE49-F238E27FC236}">
-                <a16:creationId xmlns:a16="http://schemas.microsoft.com/office/drawing/2014/main" id="{9217F3F6-14DF-4CDA-9F9A-8948173BC5C5}"/>
+                <a16:creationId xmlns:a16="http://schemas.microsoft.com/office/drawing/2014/main" id="{1D0D2F57-C251-40D1-BEAE-C1CA25189861}"/>
               </a:ext>
             </a:extLst>
           </p:cNvPr>
@@ -12495,7 +12512,7 @@
           <p:cNvPr id="20" name="">
             <a:extLst xmlns:a="http://schemas.openxmlformats.org/drawingml/2006/main">
               <a:ext uri="{FF2B5EF4-FFF2-40B4-BE49-F238E27FC236}">
-                <a16:creationId xmlns:a16="http://schemas.microsoft.com/office/drawing/2014/main" id="{8FEE88D7-3D73-4D9A-B988-49A33FD6BCFB}"/>
+                <a16:creationId xmlns:a16="http://schemas.microsoft.com/office/drawing/2014/main" id="{ACDC297B-BF5D-4067-9B2A-F181FB88E178}"/>
               </a:ext>
             </a:extLst>
           </p:cNvPr>
@@ -12545,7 +12562,7 @@
           <p:cNvPr id="21" name="">
             <a:extLst xmlns:a="http://schemas.openxmlformats.org/drawingml/2006/main">
               <a:ext uri="{FF2B5EF4-FFF2-40B4-BE49-F238E27FC236}">
-                <a16:creationId xmlns:a16="http://schemas.microsoft.com/office/drawing/2014/main" id="{FE10F07C-9C9C-4793-B007-E4EB9200E58A}"/>
+                <a16:creationId xmlns:a16="http://schemas.microsoft.com/office/drawing/2014/main" id="{D571144F-7388-4BF8-97E3-F34F76A00714}"/>
               </a:ext>
             </a:extLst>
           </p:cNvPr>
@@ -12595,7 +12612,7 @@
           <p:cNvPr id="22" name="">
             <a:extLst xmlns:a="http://schemas.openxmlformats.org/drawingml/2006/main">
               <a:ext uri="{FF2B5EF4-FFF2-40B4-BE49-F238E27FC236}">
-                <a16:creationId xmlns:a16="http://schemas.microsoft.com/office/drawing/2014/main" id="{68CB7633-DDED-4273-8D19-DBFD1A53D890}"/>
+                <a16:creationId xmlns:a16="http://schemas.microsoft.com/office/drawing/2014/main" id="{CC4EEFD2-9A15-430A-8CC3-3D35CDE45DFE}"/>
               </a:ext>
             </a:extLst>
           </p:cNvPr>
@@ -12643,7 +12660,7 @@
     </p:spTree>
     <p:extLst>
       <p:ext uri="{BB962C8B-B14F-4D97-AF65-F5344CB8AC3E}">
-        <p14:creationId xmlns:p14="http://schemas.microsoft.com/office/powerpoint/2010/main" val="1622397707"/>
+        <p14:creationId xmlns:p14="http://schemas.microsoft.com/office/powerpoint/2010/main" val="240921805"/>
       </p:ext>
     </p:extLst>
   </p:cSld>
@@ -12674,7 +12691,7 @@
           <p:cNvPr id="1" name="">
             <a:extLst xmlns:a="http://schemas.openxmlformats.org/drawingml/2006/main">
               <a:ext uri="{FF2B5EF4-FFF2-40B4-BE49-F238E27FC236}">
-                <a16:creationId xmlns:a16="http://schemas.microsoft.com/office/drawing/2014/main" id="{87DCF60F-DCA8-463D-BACD-9FFECD890D8A}"/>
+                <a16:creationId xmlns:a16="http://schemas.microsoft.com/office/drawing/2014/main" id="{53BA1DA7-3EB8-4F24-9FCE-0D5D93F46A57}"/>
               </a:ext>
             </a:extLst>
           </p:cNvPr>
@@ -12705,7 +12722,7 @@
           <p:cNvPr id="2" name="">
             <a:extLst xmlns:a="http://schemas.openxmlformats.org/drawingml/2006/main">
               <a:ext uri="{FF2B5EF4-FFF2-40B4-BE49-F238E27FC236}">
-                <a16:creationId xmlns:a16="http://schemas.microsoft.com/office/drawing/2014/main" id="{EF780674-429A-47AE-A458-BEFB95A3E4CD}"/>
+                <a16:creationId xmlns:a16="http://schemas.microsoft.com/office/drawing/2014/main" id="{8F102DFB-EFBF-4F15-BF5D-B2DC3CB141D2}"/>
               </a:ext>
             </a:extLst>
           </p:cNvPr>
@@ -12755,7 +12772,7 @@
           <p:cNvPr id="3" name="">
             <a:extLst xmlns:a="http://schemas.openxmlformats.org/drawingml/2006/main">
               <a:ext uri="{FF2B5EF4-FFF2-40B4-BE49-F238E27FC236}">
-                <a16:creationId xmlns:a16="http://schemas.microsoft.com/office/drawing/2014/main" id="{4786C423-A030-4BD2-9D6D-E4E6F2B58A39}"/>
+                <a16:creationId xmlns:a16="http://schemas.microsoft.com/office/drawing/2014/main" id="{3507B619-6F68-42EE-828C-CCFB0ACF64AE}"/>
               </a:ext>
             </a:extLst>
           </p:cNvPr>
@@ -12805,7 +12822,7 @@
           <p:cNvPr id="4" name="">
             <a:extLst xmlns:a="http://schemas.openxmlformats.org/drawingml/2006/main">
               <a:ext uri="{FF2B5EF4-FFF2-40B4-BE49-F238E27FC236}">
-                <a16:creationId xmlns:a16="http://schemas.microsoft.com/office/drawing/2014/main" id="{A3D12C83-E280-4FB2-BE9D-755736B493C3}"/>
+                <a16:creationId xmlns:a16="http://schemas.microsoft.com/office/drawing/2014/main" id="{077B0D2C-8134-4094-997E-AD90D207D0D7}"/>
               </a:ext>
             </a:extLst>
           </p:cNvPr>
@@ -12836,7 +12853,7 @@
           <p:cNvPr id="5" name="footer-9">
             <a:extLst xmlns:a="http://schemas.openxmlformats.org/drawingml/2006/main">
               <a:ext uri="{FF2B5EF4-FFF2-40B4-BE49-F238E27FC236}">
-                <a16:creationId xmlns:a16="http://schemas.microsoft.com/office/drawing/2014/main" id="{43F26315-148D-4233-9AA6-DC115ABA74BF}"/>
+                <a16:creationId xmlns:a16="http://schemas.microsoft.com/office/drawing/2014/main" id="{221C12C4-397C-4872-A642-EBBE784E8988}"/>
               </a:ext>
             </a:extLst>
           </p:cNvPr>
@@ -12886,7 +12903,7 @@
           <p:cNvPr id="6" name="">
             <a:extLst xmlns:a="http://schemas.openxmlformats.org/drawingml/2006/main">
               <a:ext uri="{FF2B5EF4-FFF2-40B4-BE49-F238E27FC236}">
-                <a16:creationId xmlns:a16="http://schemas.microsoft.com/office/drawing/2014/main" id="{C0E28CC5-AB9E-402B-91EC-00B8F37BD72B}"/>
+                <a16:creationId xmlns:a16="http://schemas.microsoft.com/office/drawing/2014/main" id="{D11FB236-62FC-41A9-B0FE-284DFAD0751B}"/>
               </a:ext>
             </a:extLst>
           </p:cNvPr>
@@ -12921,7 +12938,7 @@
           <p:cNvPr id="7" name="">
             <a:extLst xmlns:a="http://schemas.openxmlformats.org/drawingml/2006/main">
               <a:ext uri="{FF2B5EF4-FFF2-40B4-BE49-F238E27FC236}">
-                <a16:creationId xmlns:a16="http://schemas.microsoft.com/office/drawing/2014/main" id="{C4F98AA7-D374-45DA-9987-B7E898650BC2}"/>
+                <a16:creationId xmlns:a16="http://schemas.microsoft.com/office/drawing/2014/main" id="{507D7695-73CE-41D0-A09F-6BC0C1C588DD}"/>
               </a:ext>
             </a:extLst>
           </p:cNvPr>
@@ -12952,7 +12969,7 @@
           <p:cNvPr id="8" name="">
             <a:extLst xmlns:a="http://schemas.openxmlformats.org/drawingml/2006/main">
               <a:ext uri="{FF2B5EF4-FFF2-40B4-BE49-F238E27FC236}">
-                <a16:creationId xmlns:a16="http://schemas.microsoft.com/office/drawing/2014/main" id="{0F59152B-E53D-44FA-88EA-5D644FE239FB}"/>
+                <a16:creationId xmlns:a16="http://schemas.microsoft.com/office/drawing/2014/main" id="{F384D402-A522-434A-965D-23895F045462}"/>
               </a:ext>
             </a:extLst>
           </p:cNvPr>
@@ -13002,7 +13019,7 @@
           <p:cNvPr id="9" name="">
             <a:extLst xmlns:a="http://schemas.openxmlformats.org/drawingml/2006/main">
               <a:ext uri="{FF2B5EF4-FFF2-40B4-BE49-F238E27FC236}">
-                <a16:creationId xmlns:a16="http://schemas.microsoft.com/office/drawing/2014/main" id="{ED8B4F68-958F-4D9B-99C2-CFBB21736892}"/>
+                <a16:creationId xmlns:a16="http://schemas.microsoft.com/office/drawing/2014/main" id="{77654997-8846-495A-88C6-081CAC6831E9}"/>
               </a:ext>
             </a:extLst>
           </p:cNvPr>
@@ -13052,7 +13069,7 @@
           <p:cNvPr id="10" name="">
             <a:extLst xmlns:a="http://schemas.openxmlformats.org/drawingml/2006/main">
               <a:ext uri="{FF2B5EF4-FFF2-40B4-BE49-F238E27FC236}">
-                <a16:creationId xmlns:a16="http://schemas.microsoft.com/office/drawing/2014/main" id="{D4181204-3B13-45F9-AA87-E338E18335D8}"/>
+                <a16:creationId xmlns:a16="http://schemas.microsoft.com/office/drawing/2014/main" id="{8CE68694-8304-4A84-9EA1-309E1CCBE115}"/>
               </a:ext>
             </a:extLst>
           </p:cNvPr>
@@ -13087,7 +13104,7 @@
           <p:cNvPr id="11" name="">
             <a:extLst xmlns:a="http://schemas.openxmlformats.org/drawingml/2006/main">
               <a:ext uri="{FF2B5EF4-FFF2-40B4-BE49-F238E27FC236}">
-                <a16:creationId xmlns:a16="http://schemas.microsoft.com/office/drawing/2014/main" id="{39564172-4544-4242-A078-CDC1B00E4B51}"/>
+                <a16:creationId xmlns:a16="http://schemas.microsoft.com/office/drawing/2014/main" id="{E08E3E65-45F7-4711-B654-9FE8DA6F2F76}"/>
               </a:ext>
             </a:extLst>
           </p:cNvPr>
@@ -13118,7 +13135,7 @@
           <p:cNvPr id="12" name="">
             <a:extLst xmlns:a="http://schemas.openxmlformats.org/drawingml/2006/main">
               <a:ext uri="{FF2B5EF4-FFF2-40B4-BE49-F238E27FC236}">
-                <a16:creationId xmlns:a16="http://schemas.microsoft.com/office/drawing/2014/main" id="{64CDBB9C-C970-4839-99D2-2908E1684940}"/>
+                <a16:creationId xmlns:a16="http://schemas.microsoft.com/office/drawing/2014/main" id="{499EFD17-0939-4DEA-91FA-FDC894B7569B}"/>
               </a:ext>
             </a:extLst>
           </p:cNvPr>
@@ -13168,7 +13185,7 @@
           <p:cNvPr id="13" name="">
             <a:extLst xmlns:a="http://schemas.openxmlformats.org/drawingml/2006/main">
               <a:ext uri="{FF2B5EF4-FFF2-40B4-BE49-F238E27FC236}">
-                <a16:creationId xmlns:a16="http://schemas.microsoft.com/office/drawing/2014/main" id="{88F5209D-A8E9-4F29-908A-D9C3414BA228}"/>
+                <a16:creationId xmlns:a16="http://schemas.microsoft.com/office/drawing/2014/main" id="{60EDB7E9-A2B1-4215-B9CA-168215157574}"/>
               </a:ext>
             </a:extLst>
           </p:cNvPr>
@@ -13218,7 +13235,7 @@
           <p:cNvPr id="14" name="">
             <a:extLst xmlns:a="http://schemas.openxmlformats.org/drawingml/2006/main">
               <a:ext uri="{FF2B5EF4-FFF2-40B4-BE49-F238E27FC236}">
-                <a16:creationId xmlns:a16="http://schemas.microsoft.com/office/drawing/2014/main" id="{EC5F1216-473C-498E-B8D9-6FDEED74E160}"/>
+                <a16:creationId xmlns:a16="http://schemas.microsoft.com/office/drawing/2014/main" id="{5D3E45E3-CF13-478E-B4C0-2FCA757CC3D7}"/>
               </a:ext>
             </a:extLst>
           </p:cNvPr>
@@ -13253,7 +13270,7 @@
           <p:cNvPr id="15" name="">
             <a:extLst xmlns:a="http://schemas.openxmlformats.org/drawingml/2006/main">
               <a:ext uri="{FF2B5EF4-FFF2-40B4-BE49-F238E27FC236}">
-                <a16:creationId xmlns:a16="http://schemas.microsoft.com/office/drawing/2014/main" id="{B9DB145B-F7D1-4FFD-8BBF-A77DA78E34C2}"/>
+                <a16:creationId xmlns:a16="http://schemas.microsoft.com/office/drawing/2014/main" id="{5560687B-2B5D-49C3-B9C8-838339A7E862}"/>
               </a:ext>
             </a:extLst>
           </p:cNvPr>
@@ -13284,7 +13301,7 @@
           <p:cNvPr id="16" name="">
             <a:extLst xmlns:a="http://schemas.openxmlformats.org/drawingml/2006/main">
               <a:ext uri="{FF2B5EF4-FFF2-40B4-BE49-F238E27FC236}">
-                <a16:creationId xmlns:a16="http://schemas.microsoft.com/office/drawing/2014/main" id="{BE76C7D3-E96D-4DEF-97CE-018B70B9A9EF}"/>
+                <a16:creationId xmlns:a16="http://schemas.microsoft.com/office/drawing/2014/main" id="{4867D8D7-E470-4048-BDFB-7CA2D1E8E3FD}"/>
               </a:ext>
             </a:extLst>
           </p:cNvPr>
@@ -13334,7 +13351,7 @@
           <p:cNvPr id="17" name="">
             <a:extLst xmlns:a="http://schemas.openxmlformats.org/drawingml/2006/main">
               <a:ext uri="{FF2B5EF4-FFF2-40B4-BE49-F238E27FC236}">
-                <a16:creationId xmlns:a16="http://schemas.microsoft.com/office/drawing/2014/main" id="{41DBADD0-5001-4AFE-B731-E3D0DCCD7140}"/>
+                <a16:creationId xmlns:a16="http://schemas.microsoft.com/office/drawing/2014/main" id="{E5F0177C-4AFC-455E-A0D0-5D7D0D480616}"/>
               </a:ext>
             </a:extLst>
           </p:cNvPr>
@@ -13384,7 +13401,7 @@
           <p:cNvPr id="18" name="">
             <a:extLst xmlns:a="http://schemas.openxmlformats.org/drawingml/2006/main">
               <a:ext uri="{FF2B5EF4-FFF2-40B4-BE49-F238E27FC236}">
-                <a16:creationId xmlns:a16="http://schemas.microsoft.com/office/drawing/2014/main" id="{FD92BAF7-2BF5-4E06-ADDA-ACF28DABB19E}"/>
+                <a16:creationId xmlns:a16="http://schemas.microsoft.com/office/drawing/2014/main" id="{3DAE7AB2-0A71-49FF-84B9-AF8FCC23D4FD}"/>
               </a:ext>
             </a:extLst>
           </p:cNvPr>
@@ -13432,7 +13449,7 @@
     </p:spTree>
     <p:extLst>
       <p:ext uri="{BB962C8B-B14F-4D97-AF65-F5344CB8AC3E}">
-        <p14:creationId xmlns:p14="http://schemas.microsoft.com/office/powerpoint/2010/main" val="577138303"/>
+        <p14:creationId xmlns:p14="http://schemas.microsoft.com/office/powerpoint/2010/main" val="1918998943"/>
       </p:ext>
     </p:extLst>
   </p:cSld>

</xml_diff>